<commit_message>
Align grading with the official university formula
Course grade = Formative assessment (40 pts x 100%) + Summative
assessment (100 pts x 60%). The old 50/40/10 split is gone.

Formative 40 pts: attendance 0 (recorded, not scored) · class
participation 10 (weekly exercises 4, W05 client-review questions 2,
peer critique 2, engagement & English 2) · Level-3 project 20
(milestones 14: M0 1 / M1 3 / M2 4 / M3 3 / M4 3, plus individual
contribution & Git 6) · assignments 10 (5 homework sets x 2).

Summative 100 pts = W16 defense: walkthrough 30 + individual Q&A 55 +
English 10 + reflection & contribution report 5, weighted at 60%.

Bonus rescaled to +5 max (was 10%); sharp review questions moved into
class participation. Mid-term review stays formative, not scored.

Updated: grading rubric (restructured F/S items), syllabus, project
guidebook, brief, deadline guide refs, Lab-02, W01 deck P05-P06 and
lecture script. W01 pptx re-rendered (38 pages, all SVGs valid).
</commit_message>
<xml_diff>
--- a/01-slides/W01-Introduction-Systems-Analysts-and-OOAD.pptx
+++ b/01-slides/W01-Introduction-Systems-Analysts-and-OOAD.pptx
@@ -26310,7 +26310,7 @@
   <p:cSld>
     <p:spTree>
       <p:nvGrpSpPr>
-        <p:cNvPr id="677" name="" descr="&lt;Slide style={{ background: '#FFFFFF', padding: 0 }}&gt;&#10;  &lt;Box style={{ height: 72, background: '#1E4FA8', padding: '0 40px', flexDirection: 'row', alignItems: 'center', justifyContent: 'space-between' }}&gt;&#10;    &lt;Text style={{ fontSize: 15, color: '#B9CDF0', letterSpacing: 1 }}&gt;ISAD · INFORMATION SYSTEMS ANALYSIS &amp;amp; DESIGN&lt;/Text&gt;&#10;    &lt;Text style={{ fontSize: 15, color: '#B9CDF0' }}&gt;W01 · INTRODUCTION&lt;/Text&gt;&#10;  &lt;/Box&gt;&#10;  &lt;Box style={{ padding: '24px 40px 0 40px' }}&gt;&#10;    &lt;Text style={{ fontSize: 34, fontWeight: 'bold', color: '#0E3F8C' }}&gt;Assessment — No Written Exam&lt;/Text&gt;&#10;  &lt;/Box&gt;&#10;  &lt;Box style={{ flex: 1, padding: '18px 40px 0 40px', flexDirection: 'row', gap: 28, alignItems: 'stretch' }}&gt;&#10;    {[&#10;      { n: '50', pct: '%', t: 'Group Project', d: 'Milestone deliverables M0–M5: requirements, analysis models, design models, pattern catalog. Same grade for the whole team.' },&#10;      { n: '40', pct: '%', t: 'Individual Defense', d: 'Every member explains any part of the work. Contribution logs + Git history as teamwork evidence.' },&#10;      { n: '10', pct: '%', t: 'Bonus', d: 'Exceptional refactoring, extra patterns applied, outstanding English documentation.' },&#10;    ].map((c, i) =&gt; (&#10;      &lt;Box key={c.t} style={{ flex: 1, padding: '24px 22px', background: i === 0 ? '#0E3F8C' : '#F7F9FC', borderRadius: 12, border: i === 0 ? '1px solid #0E3F8C' : '1px solid #E5E7EB', flexDirection: 'column' }}&gt;&#10;        &lt;Box style={{ flexDirection: 'row', alignItems: 'baseline', marginBottom: 12 }}&gt;&#10;          &lt;Text style={{ fontSize: 72, fontWeight: 'bold', color: i === 0 ? '#FFC107' : '#1E4FA8', lineHeight: 1 }}&gt;{c.n}&lt;/Text&gt;&#10;          &lt;Text style={{ fontSize: 30, fontWeight: 'bold', color: i === 0 ? '#FFC107' : '#1E4FA8' }}&gt;{c.pct}&lt;/Text&gt;&#10;        &lt;/Box&gt;&#10;        &lt;Text style={{ fontSize: 22, fontWeight: 'bold', color: i === 0 ? '#FFFFFF' : '#1A2230', marginBottom: 10 }}&gt;{c.t}&lt;/Text&gt;&#10;        &lt;Text style={{ fontSize: 15, color: i === 0 ? '#C5D4EA' : '#4A5568', lineHeight: 1.55 }}&gt;{c.d}&lt;/Text&gt;&#10;      &lt;/Box&gt;&#10;    ))}&#10;  &lt;/Box&gt;&#10;  &lt;Box style={{ height: 40, padding: '0 40px', flexDirection: 'row', alignItems: 'center', justifyContent: 'space-between' }}&gt;&#10;    &lt;Text style={{ fontSize: 13, color: '#8B97A8' }}&gt;Assessment = project + defense (Group 50 / Individual 40 / Bonus 10)&lt;/Text&gt;&#10;    &lt;Text style={{ fontSize: 14, color: '#1E4FA8', fontWeight: 'bold' }}&gt;05 / 38&lt;/Text&gt;&#10;  &lt;/Box&gt;&#10;&lt;/Slide&gt;"/>
+        <p:cNvPr id="677" name="" descr="&lt;Slide style={{ background: '#FFFFFF', padding: 0 }}&gt;&#10;  &lt;Box style={{ height: 72, background: '#1E4FA8', padding: '0 40px', flexDirection: 'row', alignItems: 'center', justifyContent: 'space-between' }}&gt;&#10;    &lt;Text style={{ fontSize: 15, color: '#B9CDF0', letterSpacing: 1 }}&gt;ISAD · INFORMATION SYSTEMS ANALYSIS &amp;amp; DESIGN&lt;/Text&gt;&#10;    &lt;Text style={{ fontSize: 15, color: '#B9CDF0' }}&gt;W01 · INTRODUCTION&lt;/Text&gt;&#10;  &lt;/Box&gt;&#10;  &lt;Box style={{ padding: '24px 40px 0 40px' }}&gt;&#10;    &lt;Text style={{ fontSize: 34, fontWeight: 'bold', color: '#0E3F8C' }}&gt;Assessment — No Written Exam&lt;/Text&gt;&#10;  &lt;/Box&gt;&#10;  &lt;Box style={{ padding: '8px 40px 0 40px' }}&gt;&#10;    &lt;Box style={{ padding: '10px 18px', background: '#E8EFF8', borderRadius: 8 }}&gt;&#10;      &lt;Text style={{ fontSize: 16, color: '#0E3F8C', fontWeight: 'bold' }}&gt;Course grade = Formative assessment (40 points × 100%) + Summative assessment (100 points × 60%)&lt;/Text&gt;&#10;    &lt;/Box&gt;&#10;  &lt;/Box&gt;&#10;  &lt;Box style={{ flex: 1, padding: '18px 40px 0 40px', flexDirection: 'row', gap: 28, alignItems: 'stretch' }}&gt;&#10;    {[&#10;      { n: '40', pct: ' pts', t: 'Formative', d: 'Attendance 0 · Class participation 10 · Level-3 project 20 · Assignments 10. Built all semester long, counted in full.', hl: true },&#10;      { n: '60', pct: ' pts', t: 'Summative', d: 'Final defense in W16, scored out of 100 × 60%: walkthrough 30 · individual Q&amp;A 55 · English 10 · reflection 5.', hl: false },&#10;      { n: '+5', pct: '', t: 'Bonus', d: 'Extra patterns, exceptional refactoring, outstanding documentation. Course total capped at 100.', hl: false },&#10;    ].map((c, i) =&gt; (&#10;      &lt;Box key={c.t} style={{ flex: 1, padding: '24px 22px', background: i === 0 ? '#0E3F8C' : '#F7F9FC', borderRadius: 12, border: i === 0 ? '1px solid #0E3F8C' : '1px solid #E5E7EB', flexDirection: 'column' }}&gt;&#10;        &lt;Box style={{ flexDirection: 'row', alignItems: 'baseline', marginBottom: 12 }}&gt;&#10;          &lt;Text style={{ fontSize: 64, fontWeight: 'bold', color: i === 0 ? '#FFC107' : '#1E4FA8', lineHeight: 1 }}&gt;{c.n}&lt;/Text&gt;&#10;          &lt;Text style={{ fontSize: 26, fontWeight: 'bold', color: i === 0 ? '#FFC107' : '#1E4FA8' }}&gt;{c.pct}&lt;/Text&gt;&#10;        &lt;/Box&gt;&#10;        &lt;Text style={{ fontSize: 22, fontWeight: 'bold', color: i === 0 ? '#FFFFFF' : '#1A2230', marginBottom: 10 }}&gt;{c.t}&lt;/Text&gt;&#10;        &lt;Text style={{ fontSize: 15, color: i === 0 ? '#C5D4EA' : '#4A5568', lineHeight: 1.55 }}&gt;{c.d}&lt;/Text&gt;&#10;      &lt;/Box&gt;&#10;    ))}&#10;  &lt;/Box&gt;&#10;  &lt;Box style={{ height: 40, padding: '0 40px', flexDirection: 'row', alignItems: 'center', justifyContent: 'space-between' }}&gt;&#10;    &lt;Text style={{ fontSize: 13, color: '#8B97A8' }}&gt;Formative 40 pts counted in full + defense score × 60% — no written exam&lt;/Text&gt;&#10;    &lt;Text style={{ fontSize: 14, color: '#1E4FA8', fontWeight: 'bold' }}&gt;05 / 38&lt;/Text&gt;&#10;  &lt;/Box&gt;&#10;&lt;/Slide&gt;"/>
         <p:cNvGrpSpPr/>
         <p:nvPr/>
       </p:nvGrpSpPr>
@@ -26483,8 +26483,69 @@
         </p:nvSpPr>
         <p:spPr>
           <a:xfrm rot="0" flipH="0" flipV="0">
-            <a:off x="381000" y="1476375"/>
-            <a:ext cx="3629025" cy="5000625"/>
+            <a:off x="381000" y="1381125"/>
+            <a:ext cx="11430000" cy="381000"/>
+          </a:xfrm>
+          <a:prstGeom prst="roundRect">
+            <a:avLst>
+              <a:gd name="adj" fmla="val 20000"/>
+            </a:avLst>
+          </a:prstGeom>
+          <a:solidFill>
+            <a:srgbClr val="E8EFF8"/>
+          </a:solidFill>
+          <a:ln/>
+        </p:spPr>
+        <p:txBody>
+          <a:bodyPr/>
+          <a:p/>
+        </p:txBody>
+      </p:sp>
+      <p:sp>
+        <p:nvSpPr>
+          <p:cNvPr id="684" name="" descr="{&quot;isTemplate&quot;:true,&quot;type&quot;:&quot;text&quot;}"/>
+          <p:cNvSpPr txBox="1"/>
+          <p:nvPr/>
+        </p:nvSpPr>
+        <p:spPr>
+          <a:xfrm rot="0" flipH="0" flipV="0">
+            <a:off x="552450" y="1476375"/>
+            <a:ext cx="11087100" cy="190500"/>
+          </a:xfrm>
+          <a:prstGeom prst="rect"/>
+        </p:spPr>
+        <p:txBody>
+          <a:bodyPr wrap="none" lIns="0" tIns="0" rIns="0" bIns="0"/>
+          <a:p>
+            <a:pPr>
+              <a:lnSpc>
+                <a:spcPct val="100000"/>
+              </a:lnSpc>
+            </a:pPr>
+            <a:r>
+              <a:rPr lang="en-US" sz="1200" b="1">
+                <a:solidFill>
+                  <a:srgbClr val="0E3F8C"/>
+                </a:solidFill>
+                <a:latin typeface="Microsoft YaHei"/>
+                <a:ea typeface="Microsoft YaHei"/>
+              </a:rPr>
+              <a:t>Course grade = Formative assessment (40 points × 100%) + Summative assessment (100 points × 60%)</a:t>
+            </a:r>
+            <a:endParaRPr/>
+          </a:p>
+        </p:txBody>
+      </p:sp>
+      <p:sp>
+        <p:nvSpPr>
+          <p:cNvPr id="685" name=""/>
+          <p:cNvSpPr/>
+          <p:nvPr/>
+        </p:nvSpPr>
+        <p:spPr>
+          <a:xfrm rot="0" flipH="0" flipV="0">
+            <a:off x="381000" y="1933575"/>
+            <a:ext cx="3629025" cy="4543425"/>
           </a:xfrm>
           <a:prstGeom prst="roundRect">
             <a:avLst>
@@ -26508,83 +26569,83 @@
       </p:sp>
       <p:sp>
         <p:nvSpPr>
-          <p:cNvPr id="684" name="" descr="{&quot;isTemplate&quot;:true,&quot;type&quot;:&quot;text&quot;}"/>
-          <p:cNvSpPr txBox="1"/>
-          <p:nvPr/>
-        </p:nvSpPr>
-        <p:spPr>
-          <a:xfrm rot="0" flipH="0" flipV="0">
-            <a:off x="590550" y="1704975"/>
-            <a:ext cx="771525" cy="828675"/>
-          </a:xfrm>
-          <a:prstGeom prst="rect"/>
-        </p:spPr>
-        <p:txBody>
-          <a:bodyPr wrap="none" lIns="0" tIns="0" rIns="0" bIns="0"/>
-          <a:p>
-            <a:pPr>
-              <a:lnSpc>
-                <a:spcPct val="100000"/>
-              </a:lnSpc>
-            </a:pPr>
-            <a:r>
-              <a:rPr lang="en-US" sz="5400" b="1">
+          <p:cNvPr id="686" name="" descr="{&quot;isTemplate&quot;:true,&quot;type&quot;:&quot;text&quot;}"/>
+          <p:cNvSpPr txBox="1"/>
+          <p:nvPr/>
+        </p:nvSpPr>
+        <p:spPr>
+          <a:xfrm rot="0" flipH="0" flipV="0">
+            <a:off x="590550" y="2162175"/>
+            <a:ext cx="685800" cy="733425"/>
+          </a:xfrm>
+          <a:prstGeom prst="rect"/>
+        </p:spPr>
+        <p:txBody>
+          <a:bodyPr wrap="none" lIns="0" tIns="0" rIns="0" bIns="0"/>
+          <a:p>
+            <a:pPr>
+              <a:lnSpc>
+                <a:spcPct val="100000"/>
+              </a:lnSpc>
+            </a:pPr>
+            <a:r>
+              <a:rPr lang="en-US" sz="4800" b="1">
                 <a:solidFill>
                   <a:srgbClr val="FFC107"/>
                 </a:solidFill>
                 <a:latin typeface="Microsoft YaHei"/>
                 <a:ea typeface="Microsoft YaHei"/>
               </a:rPr>
-              <a:t>50</a:t>
-            </a:r>
-            <a:endParaRPr/>
-          </a:p>
-        </p:txBody>
-      </p:sp>
-      <p:sp>
-        <p:nvSpPr>
-          <p:cNvPr id="685" name="" descr="{&quot;isTemplate&quot;:true,&quot;type&quot;:&quot;text&quot;}"/>
-          <p:cNvSpPr txBox="1"/>
-          <p:nvPr/>
-        </p:nvSpPr>
-        <p:spPr>
-          <a:xfrm rot="0" flipH="0" flipV="0">
-            <a:off x="1362075" y="1704975"/>
-            <a:ext cx="257175" cy="828675"/>
-          </a:xfrm>
-          <a:prstGeom prst="rect"/>
-        </p:spPr>
-        <p:txBody>
-          <a:bodyPr wrap="none" lIns="0" tIns="0" rIns="0" bIns="0"/>
-          <a:p>
-            <a:pPr>
-              <a:lnSpc>
-                <a:spcPct val="100000"/>
-              </a:lnSpc>
-            </a:pPr>
-            <a:r>
-              <a:rPr lang="en-US" sz="2250" b="1">
+              <a:t>40</a:t>
+            </a:r>
+            <a:endParaRPr/>
+          </a:p>
+        </p:txBody>
+      </p:sp>
+      <p:sp>
+        <p:nvSpPr>
+          <p:cNvPr id="687" name="" descr="{&quot;isTemplate&quot;:true,&quot;type&quot;:&quot;text&quot;}"/>
+          <p:cNvSpPr txBox="1"/>
+          <p:nvPr/>
+        </p:nvSpPr>
+        <p:spPr>
+          <a:xfrm rot="0" flipH="0" flipV="0">
+            <a:off x="1276350" y="2162175"/>
+            <a:ext cx="447675" cy="733425"/>
+          </a:xfrm>
+          <a:prstGeom prst="rect"/>
+        </p:spPr>
+        <p:txBody>
+          <a:bodyPr wrap="none" lIns="0" tIns="0" rIns="0" bIns="0"/>
+          <a:p>
+            <a:pPr>
+              <a:lnSpc>
+                <a:spcPct val="100000"/>
+              </a:lnSpc>
+            </a:pPr>
+            <a:r>
+              <a:rPr lang="en-US" sz="1950" b="1">
                 <a:solidFill>
                   <a:srgbClr val="FFC107"/>
                 </a:solidFill>
                 <a:latin typeface="Microsoft YaHei"/>
                 <a:ea typeface="Microsoft YaHei"/>
               </a:rPr>
-              <a:t>%</a:t>
-            </a:r>
-            <a:endParaRPr/>
-          </a:p>
-        </p:txBody>
-      </p:sp>
-      <p:sp>
-        <p:nvSpPr>
-          <p:cNvPr id="686" name="" descr="{&quot;isTemplate&quot;:true,&quot;type&quot;:&quot;text&quot;}"/>
-          <p:cNvSpPr txBox="1"/>
-          <p:nvPr/>
-        </p:nvSpPr>
-        <p:spPr>
-          <a:xfrm rot="0" flipH="0" flipV="0">
-            <a:off x="590550" y="2647950"/>
+              <a:t> pts</a:t>
+            </a:r>
+            <a:endParaRPr/>
+          </a:p>
+        </p:txBody>
+      </p:sp>
+      <p:sp>
+        <p:nvSpPr>
+          <p:cNvPr id="688" name="" descr="{&quot;isTemplate&quot;:true,&quot;type&quot;:&quot;text&quot;}"/>
+          <p:cNvSpPr txBox="1"/>
+          <p:nvPr/>
+        </p:nvSpPr>
+        <p:spPr>
+          <a:xfrm rot="0" flipH="0" flipV="0">
+            <a:off x="590550" y="3009900"/>
             <a:ext cx="3209925" cy="257175"/>
           </a:xfrm>
           <a:prstGeom prst="rect"/>
@@ -26605,21 +26666,21 @@
                 <a:latin typeface="Microsoft YaHei"/>
                 <a:ea typeface="Microsoft YaHei"/>
               </a:rPr>
-              <a:t>Group Project</a:t>
-            </a:r>
-            <a:endParaRPr/>
-          </a:p>
-        </p:txBody>
-      </p:sp>
-      <p:sp>
-        <p:nvSpPr>
-          <p:cNvPr id="687" name="" descr="{&quot;isTemplate&quot;:true,&quot;type&quot;:&quot;text&quot;}"/>
-          <p:cNvSpPr txBox="1"/>
-          <p:nvPr/>
-        </p:nvSpPr>
-        <p:spPr>
-          <a:xfrm rot="0" flipH="0" flipV="0">
-            <a:off x="590550" y="3000375"/>
+              <a:t>Formative</a:t>
+            </a:r>
+            <a:endParaRPr/>
+          </a:p>
+        </p:txBody>
+      </p:sp>
+      <p:sp>
+        <p:nvSpPr>
+          <p:cNvPr id="689" name="" descr="{&quot;isTemplate&quot;:true,&quot;type&quot;:&quot;text&quot;}"/>
+          <p:cNvSpPr txBox="1"/>
+          <p:nvPr/>
+        </p:nvSpPr>
+        <p:spPr>
+          <a:xfrm rot="0" flipH="0" flipV="0">
+            <a:off x="590550" y="3362325"/>
             <a:ext cx="3209925" cy="800100"/>
           </a:xfrm>
           <a:prstGeom prst="rect"/>
@@ -26642,22 +26703,22 @@
                 <a:latin typeface="Microsoft YaHei"/>
                 <a:ea typeface="Microsoft YaHei"/>
               </a:rPr>
-              <a:t>Milestone deliverables M0–M5: requirements, analysis models, design models, pattern catalog. Same grade for the whole team.</a:t>
-            </a:r>
-            <a:endParaRPr/>
-          </a:p>
-        </p:txBody>
-      </p:sp>
-      <p:sp>
-        <p:nvSpPr>
-          <p:cNvPr id="688" name=""/>
+              <a:t>Attendance 0 · Class participation 10 · Level-3 project 20 · Assignments 10. Built all semester long, counted in full.</a:t>
+            </a:r>
+            <a:endParaRPr/>
+          </a:p>
+        </p:txBody>
+      </p:sp>
+      <p:sp>
+        <p:nvSpPr>
+          <p:cNvPr id="690" name=""/>
           <p:cNvSpPr/>
           <p:nvPr/>
         </p:nvSpPr>
         <p:spPr>
           <a:xfrm rot="0" flipH="0" flipV="0">
-            <a:off x="4276725" y="1476375"/>
-            <a:ext cx="3638550" cy="5000625"/>
+            <a:off x="4276725" y="1933575"/>
+            <a:ext cx="3638550" cy="4543425"/>
           </a:xfrm>
           <a:prstGeom prst="roundRect">
             <a:avLst>
@@ -26681,83 +26742,83 @@
       </p:sp>
       <p:sp>
         <p:nvSpPr>
-          <p:cNvPr id="689" name="" descr="{&quot;isTemplate&quot;:true,&quot;type&quot;:&quot;text&quot;}"/>
-          <p:cNvSpPr txBox="1"/>
-          <p:nvPr/>
-        </p:nvSpPr>
-        <p:spPr>
-          <a:xfrm rot="0" flipH="0" flipV="0">
-            <a:off x="4486275" y="1704975"/>
-            <a:ext cx="771525" cy="828675"/>
-          </a:xfrm>
-          <a:prstGeom prst="rect"/>
-        </p:spPr>
-        <p:txBody>
-          <a:bodyPr wrap="none" lIns="0" tIns="0" rIns="0" bIns="0"/>
-          <a:p>
-            <a:pPr>
-              <a:lnSpc>
-                <a:spcPct val="100000"/>
-              </a:lnSpc>
-            </a:pPr>
-            <a:r>
-              <a:rPr lang="en-US" sz="5400" b="1">
+          <p:cNvPr id="691" name="" descr="{&quot;isTemplate&quot;:true,&quot;type&quot;:&quot;text&quot;}"/>
+          <p:cNvSpPr txBox="1"/>
+          <p:nvPr/>
+        </p:nvSpPr>
+        <p:spPr>
+          <a:xfrm rot="0" flipH="0" flipV="0">
+            <a:off x="4486275" y="2162175"/>
+            <a:ext cx="685800" cy="733425"/>
+          </a:xfrm>
+          <a:prstGeom prst="rect"/>
+        </p:spPr>
+        <p:txBody>
+          <a:bodyPr wrap="none" lIns="0" tIns="0" rIns="0" bIns="0"/>
+          <a:p>
+            <a:pPr>
+              <a:lnSpc>
+                <a:spcPct val="100000"/>
+              </a:lnSpc>
+            </a:pPr>
+            <a:r>
+              <a:rPr lang="en-US" sz="4800" b="1">
                 <a:solidFill>
                   <a:srgbClr val="1E4FA8"/>
                 </a:solidFill>
                 <a:latin typeface="Microsoft YaHei"/>
                 <a:ea typeface="Microsoft YaHei"/>
               </a:rPr>
-              <a:t>40</a:t>
-            </a:r>
-            <a:endParaRPr/>
-          </a:p>
-        </p:txBody>
-      </p:sp>
-      <p:sp>
-        <p:nvSpPr>
-          <p:cNvPr id="690" name="" descr="{&quot;isTemplate&quot;:true,&quot;type&quot;:&quot;text&quot;}"/>
-          <p:cNvSpPr txBox="1"/>
-          <p:nvPr/>
-        </p:nvSpPr>
-        <p:spPr>
-          <a:xfrm rot="0" flipH="0" flipV="0">
-            <a:off x="5257800" y="1704975"/>
-            <a:ext cx="257175" cy="828675"/>
-          </a:xfrm>
-          <a:prstGeom prst="rect"/>
-        </p:spPr>
-        <p:txBody>
-          <a:bodyPr wrap="none" lIns="0" tIns="0" rIns="0" bIns="0"/>
-          <a:p>
-            <a:pPr>
-              <a:lnSpc>
-                <a:spcPct val="100000"/>
-              </a:lnSpc>
-            </a:pPr>
-            <a:r>
-              <a:rPr lang="en-US" sz="2250" b="1">
+              <a:t>60</a:t>
+            </a:r>
+            <a:endParaRPr/>
+          </a:p>
+        </p:txBody>
+      </p:sp>
+      <p:sp>
+        <p:nvSpPr>
+          <p:cNvPr id="692" name="" descr="{&quot;isTemplate&quot;:true,&quot;type&quot;:&quot;text&quot;}"/>
+          <p:cNvSpPr txBox="1"/>
+          <p:nvPr/>
+        </p:nvSpPr>
+        <p:spPr>
+          <a:xfrm rot="0" flipH="0" flipV="0">
+            <a:off x="5172075" y="2162175"/>
+            <a:ext cx="447675" cy="733425"/>
+          </a:xfrm>
+          <a:prstGeom prst="rect"/>
+        </p:spPr>
+        <p:txBody>
+          <a:bodyPr wrap="none" lIns="0" tIns="0" rIns="0" bIns="0"/>
+          <a:p>
+            <a:pPr>
+              <a:lnSpc>
+                <a:spcPct val="100000"/>
+              </a:lnSpc>
+            </a:pPr>
+            <a:r>
+              <a:rPr lang="en-US" sz="1950" b="1">
                 <a:solidFill>
                   <a:srgbClr val="1E4FA8"/>
                 </a:solidFill>
                 <a:latin typeface="Microsoft YaHei"/>
                 <a:ea typeface="Microsoft YaHei"/>
               </a:rPr>
-              <a:t>%</a:t>
-            </a:r>
-            <a:endParaRPr/>
-          </a:p>
-        </p:txBody>
-      </p:sp>
-      <p:sp>
-        <p:nvSpPr>
-          <p:cNvPr id="691" name="" descr="{&quot;isTemplate&quot;:true,&quot;type&quot;:&quot;text&quot;}"/>
-          <p:cNvSpPr txBox="1"/>
-          <p:nvPr/>
-        </p:nvSpPr>
-        <p:spPr>
-          <a:xfrm rot="0" flipH="0" flipV="0">
-            <a:off x="4486275" y="2647950"/>
+              <a:t> pts</a:t>
+            </a:r>
+            <a:endParaRPr/>
+          </a:p>
+        </p:txBody>
+      </p:sp>
+      <p:sp>
+        <p:nvSpPr>
+          <p:cNvPr id="693" name="" descr="{&quot;isTemplate&quot;:true,&quot;type&quot;:&quot;text&quot;}"/>
+          <p:cNvSpPr txBox="1"/>
+          <p:nvPr/>
+        </p:nvSpPr>
+        <p:spPr>
+          <a:xfrm rot="0" flipH="0" flipV="0">
+            <a:off x="4486275" y="3009900"/>
             <a:ext cx="3219450" cy="257175"/>
           </a:xfrm>
           <a:prstGeom prst="rect"/>
@@ -26778,21 +26839,21 @@
                 <a:latin typeface="Microsoft YaHei"/>
                 <a:ea typeface="Microsoft YaHei"/>
               </a:rPr>
-              <a:t>Individual Defense</a:t>
-            </a:r>
-            <a:endParaRPr/>
-          </a:p>
-        </p:txBody>
-      </p:sp>
-      <p:sp>
-        <p:nvSpPr>
-          <p:cNvPr id="692" name="" descr="{&quot;isTemplate&quot;:true,&quot;type&quot;:&quot;text&quot;}"/>
-          <p:cNvSpPr txBox="1"/>
-          <p:nvPr/>
-        </p:nvSpPr>
-        <p:spPr>
-          <a:xfrm rot="0" flipH="0" flipV="0">
-            <a:off x="4486275" y="3000375"/>
+              <a:t>Summative</a:t>
+            </a:r>
+            <a:endParaRPr/>
+          </a:p>
+        </p:txBody>
+      </p:sp>
+      <p:sp>
+        <p:nvSpPr>
+          <p:cNvPr id="694" name="" descr="{&quot;isTemplate&quot;:true,&quot;type&quot;:&quot;text&quot;}"/>
+          <p:cNvSpPr txBox="1"/>
+          <p:nvPr/>
+        </p:nvSpPr>
+        <p:spPr>
+          <a:xfrm rot="0" flipH="0" flipV="0">
+            <a:off x="4486275" y="3362325"/>
             <a:ext cx="3219450" cy="800100"/>
           </a:xfrm>
           <a:prstGeom prst="rect"/>
@@ -26815,22 +26876,22 @@
                 <a:latin typeface="Microsoft YaHei"/>
                 <a:ea typeface="Microsoft YaHei"/>
               </a:rPr>
-              <a:t>Every member explains any part of the work. Contribution logs + Git history as teamwork evidence.</a:t>
-            </a:r>
-            <a:endParaRPr/>
-          </a:p>
-        </p:txBody>
-      </p:sp>
-      <p:sp>
-        <p:nvSpPr>
-          <p:cNvPr id="693" name=""/>
+              <a:t>Final defense in W16, scored out of 100 × 60%: walkthrough 30 · individual Q&amp;A 55 · English 10 · reflection 5.</a:t>
+            </a:r>
+            <a:endParaRPr/>
+          </a:p>
+        </p:txBody>
+      </p:sp>
+      <p:sp>
+        <p:nvSpPr>
+          <p:cNvPr id="695" name=""/>
           <p:cNvSpPr/>
           <p:nvPr/>
         </p:nvSpPr>
         <p:spPr>
           <a:xfrm rot="0" flipH="0" flipV="0">
-            <a:off x="8181975" y="1476375"/>
-            <a:ext cx="3629025" cy="5000625"/>
+            <a:off x="8181975" y="1933575"/>
+            <a:ext cx="3629025" cy="4543425"/>
           </a:xfrm>
           <a:prstGeom prst="roundRect">
             <a:avLst>
@@ -26854,83 +26915,69 @@
       </p:sp>
       <p:sp>
         <p:nvSpPr>
-          <p:cNvPr id="694" name="" descr="{&quot;isTemplate&quot;:true,&quot;type&quot;:&quot;text&quot;}"/>
-          <p:cNvSpPr txBox="1"/>
-          <p:nvPr/>
-        </p:nvSpPr>
-        <p:spPr>
-          <a:xfrm rot="0" flipH="0" flipV="0">
-            <a:off x="8391525" y="1704975"/>
-            <a:ext cx="771525" cy="828675"/>
-          </a:xfrm>
-          <a:prstGeom prst="rect"/>
-        </p:spPr>
-        <p:txBody>
-          <a:bodyPr wrap="none" lIns="0" tIns="0" rIns="0" bIns="0"/>
-          <a:p>
-            <a:pPr>
-              <a:lnSpc>
-                <a:spcPct val="100000"/>
-              </a:lnSpc>
-            </a:pPr>
-            <a:r>
-              <a:rPr lang="en-US" sz="5400" b="1">
+          <p:cNvPr id="696" name="" descr="{&quot;isTemplate&quot;:true,&quot;type&quot;:&quot;text&quot;}"/>
+          <p:cNvSpPr txBox="1"/>
+          <p:nvPr/>
+        </p:nvSpPr>
+        <p:spPr>
+          <a:xfrm rot="0" flipH="0" flipV="0">
+            <a:off x="8391525" y="2162175"/>
+            <a:ext cx="695325" cy="733425"/>
+          </a:xfrm>
+          <a:prstGeom prst="rect"/>
+        </p:spPr>
+        <p:txBody>
+          <a:bodyPr wrap="none" lIns="0" tIns="0" rIns="0" bIns="0"/>
+          <a:p>
+            <a:pPr>
+              <a:lnSpc>
+                <a:spcPct val="100000"/>
+              </a:lnSpc>
+            </a:pPr>
+            <a:r>
+              <a:rPr lang="en-US" sz="4800" b="1">
                 <a:solidFill>
                   <a:srgbClr val="1E4FA8"/>
                 </a:solidFill>
                 <a:latin typeface="Microsoft YaHei"/>
                 <a:ea typeface="Microsoft YaHei"/>
               </a:rPr>
-              <a:t>10</a:t>
-            </a:r>
-            <a:endParaRPr/>
-          </a:p>
-        </p:txBody>
-      </p:sp>
-      <p:sp>
-        <p:nvSpPr>
-          <p:cNvPr id="695" name="" descr="{&quot;isTemplate&quot;:true,&quot;type&quot;:&quot;text&quot;}"/>
-          <p:cNvSpPr txBox="1"/>
-          <p:nvPr/>
-        </p:nvSpPr>
-        <p:spPr>
-          <a:xfrm rot="0" flipH="0" flipV="0">
-            <a:off x="9163050" y="1704975"/>
-            <a:ext cx="257175" cy="828675"/>
-          </a:xfrm>
-          <a:prstGeom prst="rect"/>
-        </p:spPr>
-        <p:txBody>
-          <a:bodyPr wrap="none" lIns="0" tIns="0" rIns="0" bIns="0"/>
-          <a:p>
-            <a:pPr>
-              <a:lnSpc>
-                <a:spcPct val="100000"/>
-              </a:lnSpc>
-            </a:pPr>
-            <a:r>
-              <a:rPr lang="en-US" sz="2250" b="1">
-                <a:solidFill>
-                  <a:srgbClr val="1E4FA8"/>
-                </a:solidFill>
-                <a:latin typeface="Microsoft YaHei"/>
-                <a:ea typeface="Microsoft YaHei"/>
-              </a:rPr>
-              <a:t>%</a:t>
-            </a:r>
-            <a:endParaRPr/>
-          </a:p>
-        </p:txBody>
-      </p:sp>
-      <p:sp>
-        <p:nvSpPr>
-          <p:cNvPr id="696" name="" descr="{&quot;isTemplate&quot;:true,&quot;type&quot;:&quot;text&quot;}"/>
-          <p:cNvSpPr txBox="1"/>
-          <p:nvPr/>
-        </p:nvSpPr>
-        <p:spPr>
-          <a:xfrm rot="0" flipH="0" flipV="0">
-            <a:off x="8391525" y="2647950"/>
+              <a:t>+5</a:t>
+            </a:r>
+            <a:endParaRPr/>
+          </a:p>
+        </p:txBody>
+      </p:sp>
+      <p:sp>
+        <p:nvSpPr>
+          <p:cNvPr id="697" name="" descr="{&quot;isTemplate&quot;:true,&quot;type&quot;:&quot;text&quot;}"/>
+          <p:cNvSpPr txBox="1"/>
+          <p:nvPr/>
+        </p:nvSpPr>
+        <p:spPr>
+          <a:xfrm rot="0" flipH="0" flipV="0">
+            <a:off x="9086850" y="2162175"/>
+            <a:ext cx="0" cy="0"/>
+          </a:xfrm>
+          <a:prstGeom prst="rect"/>
+        </p:spPr>
+        <p:txBody>
+          <a:bodyPr wrap="none" lIns="0" tIns="0" rIns="0" bIns="0"/>
+          <a:p>
+            <a:pPr/>
+            <a:endParaRPr/>
+          </a:p>
+        </p:txBody>
+      </p:sp>
+      <p:sp>
+        <p:nvSpPr>
+          <p:cNvPr id="698" name="" descr="{&quot;isTemplate&quot;:true,&quot;type&quot;:&quot;text&quot;}"/>
+          <p:cNvSpPr txBox="1"/>
+          <p:nvPr/>
+        </p:nvSpPr>
+        <p:spPr>
+          <a:xfrm rot="0" flipH="0" flipV="0">
+            <a:off x="8391525" y="3009900"/>
             <a:ext cx="3209925" cy="257175"/>
           </a:xfrm>
           <a:prstGeom prst="rect"/>
@@ -26959,14 +27006,14 @@
       </p:sp>
       <p:sp>
         <p:nvSpPr>
-          <p:cNvPr id="697" name="" descr="{&quot;isTemplate&quot;:true,&quot;type&quot;:&quot;text&quot;}"/>
-          <p:cNvSpPr txBox="1"/>
-          <p:nvPr/>
-        </p:nvSpPr>
-        <p:spPr>
-          <a:xfrm rot="0" flipH="0" flipV="0">
-            <a:off x="8391525" y="3000375"/>
-            <a:ext cx="3209925" cy="533400"/>
+          <p:cNvPr id="699" name="" descr="{&quot;isTemplate&quot;:true,&quot;type&quot;:&quot;text&quot;}"/>
+          <p:cNvSpPr txBox="1"/>
+          <p:nvPr/>
+        </p:nvSpPr>
+        <p:spPr>
+          <a:xfrm rot="0" flipH="0" flipV="0">
+            <a:off x="8391525" y="3362325"/>
+            <a:ext cx="3209925" cy="800100"/>
           </a:xfrm>
           <a:prstGeom prst="rect"/>
         </p:spPr>
@@ -26988,22 +27035,22 @@
                 <a:latin typeface="Microsoft YaHei"/>
                 <a:ea typeface="Microsoft YaHei"/>
               </a:rPr>
-              <a:t>Exceptional refactoring, extra patterns applied, outstanding English documentation.</a:t>
-            </a:r>
-            <a:endParaRPr/>
-          </a:p>
-        </p:txBody>
-      </p:sp>
-      <p:sp>
-        <p:nvSpPr>
-          <p:cNvPr id="698" name="" descr="{&quot;isTemplate&quot;:true,&quot;type&quot;:&quot;text&quot;}"/>
+              <a:t>Extra patterns, exceptional refactoring, outstanding documentation. Course total capped at 100.</a:t>
+            </a:r>
+            <a:endParaRPr/>
+          </a:p>
+        </p:txBody>
+      </p:sp>
+      <p:sp>
+        <p:nvSpPr>
+          <p:cNvPr id="700" name="" descr="{&quot;isTemplate&quot;:true,&quot;type&quot;:&quot;text&quot;}"/>
           <p:cNvSpPr txBox="1"/>
           <p:nvPr/>
         </p:nvSpPr>
         <p:spPr>
           <a:xfrm rot="0" flipH="0" flipV="0">
             <a:off x="381000" y="6591300"/>
-            <a:ext cx="3829050" cy="152400"/>
+            <a:ext cx="4095750" cy="152400"/>
           </a:xfrm>
           <a:prstGeom prst="rect"/>
         </p:spPr>
@@ -27023,15 +27070,15 @@
                 <a:latin typeface="Microsoft YaHei"/>
                 <a:ea typeface="Microsoft YaHei"/>
               </a:rPr>
-              <a:t>Assessment = project + defense (Group 50 / Individual 40 / Bonus 10)</a:t>
-            </a:r>
-            <a:endParaRPr/>
-          </a:p>
-        </p:txBody>
-      </p:sp>
-      <p:sp>
-        <p:nvSpPr>
-          <p:cNvPr id="699" name="" descr="{&quot;isTemplate&quot;:true,&quot;type&quot;:&quot;text&quot;}"/>
+              <a:t>Formative 40 pts counted in full + defense score × 60% — no written exam</a:t>
+            </a:r>
+            <a:endParaRPr/>
+          </a:p>
+        </p:txBody>
+      </p:sp>
+      <p:sp>
+        <p:nvSpPr>
+          <p:cNvPr id="701" name="" descr="{&quot;isTemplate&quot;:true,&quot;type&quot;:&quot;text&quot;}"/>
           <p:cNvSpPr txBox="1"/>
           <p:nvPr/>
         </p:nvSpPr>
@@ -27074,7 +27121,7 @@
   <p:cSld>
     <p:spTree>
       <p:nvGrpSpPr>
-        <p:cNvPr id="700" name="" descr="&lt;Slide style={{ background: '#FFFFFF', padding: 0 }}&gt;&#10;  &lt;Box style={{ height: 72, background: '#1E4FA8', padding: '0 40px', flexDirection: 'row', alignItems: 'center', justifyContent: 'space-between' }}&gt;&#10;    &lt;Text style={{ fontSize: 15, color: '#B9CDF0', letterSpacing: 1 }}&gt;ISAD · INFORMATION SYSTEMS ANALYSIS &amp;amp; DESIGN&lt;/Text&gt;&#10;    &lt;Text style={{ fontSize: 15, color: '#B9CDF0' }}&gt;W01 · INTRODUCTION&lt;/Text&gt;&#10;  &lt;/Box&gt;&#10;  &lt;Box style={{ padding: '22px 40px 0 40px' }}&gt;&#10;    &lt;Text style={{ fontSize: 33, fontWeight: 'bold', color: '#0E3F8C' }}&gt;Assessment in Detail&lt;/Text&gt;&#10;  &lt;/Box&gt;&#10;  &lt;Box style={{ flex: 1, padding: '16px 40px 0 40px', flexDirection: 'row', gap: 22, alignItems: 'stretch' }}&gt;&#10;    &lt;Box style={{ flex: 1, padding: '18px 18px', background: '#F7F9FC', borderRadius: 12, border: '1px solid #E5E7EB', flexDirection: 'column' }}&gt;&#10;      &lt;Box style={{ flexDirection: 'row', alignItems: 'baseline', marginBottom: 12 }}&gt;&#10;        &lt;Text style={{ fontSize: 40, fontWeight: 'bold', color: '#0E3F8C', lineHeight: 1 }}&gt;50&lt;/Text&gt;&#10;        &lt;Text style={{ fontSize: 20, fontWeight: 'bold', color: '#0E3F8C' }}&gt;%&lt;/Text&gt;&#10;        &lt;Text style={{ fontSize: 18, fontWeight: 'bold', color: '#1A2230', marginLeft: 10 }}&gt;Group project&lt;/Text&gt;&#10;      &lt;/Box&gt;&#10;      {[&#10;        ['A1', 'Requirements &amp;amp; use cases', '15%'],&#10;        ['A2', 'Analysis models', '25%'],&#10;        ['A3', 'Design class diagram', '20%'],&#10;        ['A4', 'GRASP / SOLID application', '15%'],&#10;        ['A5', 'Pattern catalog (5+)', '20%'],&#10;        ['A6', 'English documentation', '5%'],&#10;      ].map(([id, t, w]) =&gt; (&#10;        &lt;Box key={id} style={{ flexDirection: 'row', alignItems: 'center', gap: 10, padding: '6px 0', borderBottom: '1px solid #E5E7EB' }}&gt;&#10;          &lt;Box style={{ width: 34, height: 22, borderRadius: 5, background: '#E8EFF8', justifyContent: 'center', alignItems: 'center' }}&gt;&#10;            &lt;Text style={{ fontSize: 12, fontWeight: 'bold', color: '#1E4FA8' }}&gt;{id}&lt;/Text&gt;&#10;          &lt;/Box&gt;&#10;          &lt;Text style={{ flex: 1, fontSize: 14, color: '#4A5568' }}&gt;{t}&lt;/Text&gt;&#10;          &lt;Text style={{ fontSize: 14, fontWeight: 'bold', color: '#1E4FA8' }}&gt;{w}&lt;/Text&gt;&#10;        &lt;/Box&gt;&#10;      ))}&#10;    &lt;/Box&gt;&#10;    &lt;Box style={{ flex: 1, padding: '18px 18px', background: '#0E3F8C', borderRadius: 12, flexDirection: 'column' }}&gt;&#10;      &lt;Box style={{ flexDirection: 'row', alignItems: 'baseline', marginBottom: 12 }}&gt;&#10;        &lt;Text style={{ fontSize: 40, fontWeight: 'bold', color: '#FFC107', lineHeight: 1 }}&gt;40&lt;/Text&gt;&#10;        &lt;Text style={{ fontSize: 20, fontWeight: 'bold', color: '#FFC107' }}&gt;%&lt;/Text&gt;&#10;        &lt;Text style={{ fontSize: 18, fontWeight: 'bold', color: '#FFFFFF', marginLeft: 10 }}&gt;Individual&lt;/Text&gt;&#10;      &lt;/Box&gt;&#10;      {[&#10;        ['B1', 'Defense Q&amp;amp;A (W16)', '25%'],&#10;        ['B2', 'Contribution &amp;amp; Git log', '15%'],&#10;      ].map(([id, t, w]) =&gt; (&#10;        &lt;Box key={id} style={{ flexDirection: 'row', alignItems: 'center', gap: 10, padding: '8px 0', borderBottom: '1px solid #2B5793' }}&gt;&#10;          &lt;Box style={{ width: 34, height: 22, borderRadius: 5, background: '#2B5793', justifyContent: 'center', alignItems: 'center' }}&gt;&#10;            &lt;Text style={{ fontSize: 12, fontWeight: 'bold', color: '#FFC107' }}&gt;{id}&lt;/Text&gt;&#10;          &lt;/Box&gt;&#10;          &lt;Text style={{ flex: 1, fontSize: 14, color: '#C5D4EA' }}&gt;{t}&lt;/Text&gt;&#10;          &lt;Text style={{ fontSize: 14, fontWeight: 'bold', color: '#FFC107' }}&gt;{w}&lt;/Text&gt;&#10;        &lt;/Box&gt;&#10;      ))}&#10;      &lt;Box style={{ marginTop: 12, padding: '12px 14px', background: '#16325F', borderRadius: 8 }}&gt;&#10;        &lt;Text style={{ fontSize: 13, color: '#B9CDF0', lineHeight: 1.5 }}&gt;Every member is questioned on &lt;span style={{ fontWeight: 'bold', color: '#FFFFFF' }}&gt;any part&lt;/span&gt; of the team's work — not just &quot;your part&quot;.&lt;/Text&gt;&#10;      &lt;/Box&gt;&#10;    &lt;/Box&gt;&#10;    &lt;Box style={{ flex: 1, padding: '18px 18px', background: '#F7F9FC', borderRadius: 12, border: '1px solid #E5E7EB', flexDirection: 'column' }}&gt;&#10;      &lt;Box style={{ flexDirection: 'row', alignItems: 'baseline', marginBottom: 12 }}&gt;&#10;        &lt;Text style={{ fontSize: 40, fontWeight: 'bold', color: '#1E4FA8', lineHeight: 1 }}&gt;10&lt;/Text&gt;&#10;        &lt;Text style={{ fontSize: 20, fontWeight: 'bold', color: '#1E4FA8' }}&gt;%&lt;/Text&gt;&#10;        &lt;Text style={{ fontSize: 18, fontWeight: 'bold', color: '#1A2230', marginLeft: 10 }}&gt;Bonus&lt;/Text&gt;&#10;      &lt;/Box&gt;&#10;      {[&#10;        ['C1', 'Extra patterns (correct)', '+6% max'],&#10;        ['C2', 'Refactoring narrative', '+4%'],&#10;        ['C3', 'Outstanding docs', '+2%'],&#10;        ['C4', 'Sharp review questions', '+2%'],&#10;      ].map(([id, t, w]) =&gt; (&#10;        &lt;Box key={id} style={{ flexDirection: 'row', alignItems: 'center', gap: 10, padding: '6px 0', borderBottom: '1px solid #E5E7EB' }}&gt;&#10;          &lt;Box style={{ width: 34, height: 22, borderRadius: 5, background: '#E8EFF8', justifyContent: 'center', alignItems: 'center' }}&gt;&#10;            &lt;Text style={{ fontSize: 12, fontWeight: 'bold', color: '#1E4FA8' }}&gt;{id}&lt;/Text&gt;&#10;          &lt;/Box&gt;&#10;          &lt;Text style={{ flex: 1, fontSize: 14, color: '#4A5568' }}&gt;{t}&lt;/Text&gt;&#10;          &lt;Text style={{ fontSize: 13, fontWeight: 'bold', color: '#D9534F' }}&gt;{w}&lt;/Text&gt;&#10;        &lt;/Box&gt;&#10;      ))}&#10;      &lt;Box style={{ marginTop: 12, padding: '12px 14px', background: '#FFFFFF', borderRadius: 8, border: '1px solid #E5E7EB' }}&gt;&#10;        &lt;Text style={{ fontSize: 13, color: '#4A5568', lineHeight: 1.5 }}&gt;Weekly exercises are &lt;span style={{ fontWeight: 'bold', color: '#1A2230' }}&gt;formative&lt;/span&gt; — not graded; they feed your milestones.&lt;/Text&gt;&#10;      &lt;/Box&gt;&#10;    &lt;/Box&gt;&#10;  &lt;/Box&gt;&#10;  &lt;Box style={{ height: 44, padding: '0 40px', flexDirection: 'row', alignItems: 'center', justifyContent: 'space-between', background: '#F7F9FC', borderTop: '1px solid #E5E7EB' }}&gt;&#10;    &lt;Box style={{ flexDirection: 'row', alignItems: 'center', gap: 8, flex: 1 }}&gt;&#10;      &lt;Text style={{ fontSize: 13, fontWeight: 'bold', color: '#0E3F8C' }}&gt;Milestones&lt;/Text&gt;&#10;      &lt;Text style={{ fontSize: 13, color: '#4A5568' }}&gt;M0 Sep 11 · M1 Oct 4 · M2 Oct 25 · M3 Nov 22 · M4 Dec 6 · M5 defense Dec 14–18&lt;/Text&gt;&#10;    &lt;/Box&gt;&#10;    &lt;Text style={{ fontSize: 14, color: '#1E4FA8', fontWeight: 'bold' }}&gt;06 / 38&lt;/Text&gt;&#10;  &lt;/Box&gt;&#10;&lt;/Slide&gt;"/>
+        <p:cNvPr id="702" name="" descr="&lt;Slide style={{ background: '#FFFFFF', padding: 0 }}&gt;&#10;  &lt;Box style={{ height: 72, background: '#1E4FA8', padding: '0 40px', flexDirection: 'row', alignItems: 'center', justifyContent: 'space-between' }}&gt;&#10;    &lt;Text style={{ fontSize: 15, color: '#B9CDF0', letterSpacing: 1 }}&gt;ISAD · INFORMATION SYSTEMS ANALYSIS &amp;amp; DESIGN&lt;/Text&gt;&#10;    &lt;Text style={{ fontSize: 15, color: '#B9CDF0' }}&gt;W01 · INTRODUCTION&lt;/Text&gt;&#10;  &lt;/Box&gt;&#10;  &lt;Box style={{ padding: '22px 40px 0 40px' }}&gt;&#10;    &lt;Text style={{ fontSize: 33, fontWeight: 'bold', color: '#0E3F8C' }}&gt;Assessment in Detail&lt;/Text&gt;&#10;  &lt;/Box&gt;&#10;  &lt;Box style={{ flex: 1, padding: '16px 40px 0 40px', flexDirection: 'row', gap: 22, alignItems: 'stretch' }}&gt;&#10;    &lt;Box style={{ flex: 1, padding: '18px 18px', background: '#F7F9FC', borderRadius: 12, border: '1px solid #E5E7EB', flexDirection: 'column' }}&gt;&#10;      &lt;Box style={{ flexDirection: 'row', alignItems: 'baseline', marginBottom: 12 }}&gt;&#10;        &lt;Text style={{ fontSize: 40, fontWeight: 'bold', color: '#0E3F8C', lineHeight: 1 }}&gt;40&lt;/Text&gt;&#10;        &lt;Text style={{ fontSize: 20, fontWeight: 'bold', color: '#0E3F8C' }}&gt; pts&lt;/Text&gt;&#10;        &lt;Text style={{ fontSize: 18, fontWeight: 'bold', color: '#1A2230', marginLeft: 10 }}&gt;Formative × 100%&lt;/Text&gt;&#10;      &lt;/Box&gt;&#10;      {[&#10;        ['F1', 'Attendance', '0'],&#10;        ['F2', 'Class participation', '10'],&#10;        ['F3', 'Level-3 project (CampusBites)', '20'],&#10;        ['F4', 'Assignments (5 × 2)', '10'],&#10;      ].map(([id, t, w]) =&gt; (&#10;        &lt;Box key={id} style={{ flexDirection: 'row', alignItems: 'center', gap: 10, padding: '10px 0', borderBottom: '1px solid #E5E7EB' }}&gt;&#10;          &lt;Box style={{ width: 34, height: 22, borderRadius: 5, background: '#E8EFF8', justifyContent: 'center', alignItems: 'center' }}&gt;&#10;            &lt;Text style={{ fontSize: 12, fontWeight: 'bold', color: '#1E4FA8' }}&gt;{id}&lt;/Text&gt;&#10;          &lt;/Box&gt;&#10;          &lt;Text style={{ flex: 1, fontSize: 14, color: '#4A5568' }}&gt;{t}&lt;/Text&gt;&#10;          &lt;Text style={{ fontSize: 14, fontWeight: 'bold', color: '#1E4FA8' }}&gt;{w}&lt;/Text&gt;&#10;        &lt;/Box&gt;&#10;      ))}&#10;      &lt;Box style={{ marginTop: 12, padding: '12px 14px', background: '#FFFFFF', borderRadius: 8, border: '1px solid #E5E7EB' }}&gt;&#10;        &lt;Text style={{ fontSize: 13, color: '#4A5568', lineHeight: 1.5 }}&gt;F3 = milestones &lt;span style={{ fontWeight: 'bold', color: '#1A2230' }}&gt;14&lt;/span&gt; (M0 1 · M1 3 · M2 4 · M3 3 · M4 3) + &lt;span style={{ fontWeight: 'bold', color: '#1A2230' }}&gt;your own&lt;/span&gt; contribution &amp;amp; Git 6.&lt;/Text&gt;&#10;      &lt;/Box&gt;&#10;    &lt;/Box&gt;&#10;    &lt;Box style={{ flex: 1, padding: '18px 18px', background: '#0E3F8C', borderRadius: 12, flexDirection: 'column' }}&gt;&#10;      &lt;Box style={{ flexDirection: 'row', alignItems: 'baseline', marginBottom: 12 }}&gt;&#10;        &lt;Text style={{ fontSize: 40, fontWeight: 'bold', color: '#FFC107', lineHeight: 1 }}&gt;100&lt;/Text&gt;&#10;        &lt;Text style={{ fontSize: 20, fontWeight: 'bold', color: '#FFC107' }}&gt; × 60%&lt;/Text&gt;&#10;        &lt;Text style={{ fontSize: 18, fontWeight: 'bold', color: '#FFFFFF', marginLeft: 10 }}&gt;Summative · W16 defense&lt;/Text&gt;&#10;      &lt;/Box&gt;&#10;      {[&#10;        ['S1', 'Portfolio walkthrough (team)', '30'],&#10;        ['S2', 'Individual Q&amp;A', '55'],&#10;        ['S3', 'English communication', '10'],&#10;        ['S4', 'Reflection &amp; contribution report', '5'],&#10;      ].map(([id, t, w]) =&gt; (&#10;        &lt;Box key={id} style={{ flexDirection: 'row', alignItems: 'center', gap: 10, padding: '10px 0', borderBottom: '1px solid #2B5793' }}&gt;&#10;          &lt;Box style={{ width: 34, height: 22, borderRadius: 5, background: '#2B5793', justifyContent: 'center', alignItems: 'center' }}&gt;&#10;            &lt;Text style={{ fontSize: 12, fontWeight: 'bold', color: '#FFC107' }}&gt;{id}&lt;/Text&gt;&#10;          &lt;/Box&gt;&#10;          &lt;Text style={{ flex: 1, fontSize: 14, color: '#C5D4EA' }}&gt;{t}&lt;/Text&gt;&#10;          &lt;Text style={{ fontSize: 14, fontWeight: 'bold', color: '#FFC107' }}&gt;{w}&lt;/Text&gt;&#10;        &lt;/Box&gt;&#10;      ))}&#10;      &lt;Box style={{ marginTop: 12, padding: '12px 14px', background: '#16325F', borderRadius: 8 }}&gt;&#10;        &lt;Text style={{ fontSize: 13, color: '#B9CDF0', lineHeight: 1.5 }}&gt;Every member is questioned on &lt;span style={{ fontWeight: 'bold', color: '#FFFFFF' }}&gt;any part&lt;/span&gt; of the team's work — not just &quot;your part&quot;.&lt;/Text&gt;&#10;      &lt;/Box&gt;&#10;    &lt;/Box&gt;&#10;    &lt;Box style={{ flex: 1, padding: '18px 18px', background: '#F7F9FC', borderRadius: 12, border: '1px solid #E5E7EB', flexDirection: 'column' }}&gt;&#10;      &lt;Box style={{ flexDirection: 'row', alignItems: 'baseline', marginBottom: 12 }}&gt;&#10;        &lt;Text style={{ fontSize: 40, fontWeight: 'bold', color: '#1E4FA8', lineHeight: 1 }}&gt;+5&lt;/Text&gt;&#10;        &lt;Text style={{ fontSize: 20, fontWeight: 'bold', color: '#1E4FA8' }}&gt; max&lt;/Text&gt;&#10;        &lt;Text style={{ fontSize: 18, fontWeight: 'bold', color: '#1A2230', marginLeft: 10 }}&gt;Bonus · cap 100&lt;/Text&gt;&#10;      &lt;/Box&gt;&#10;      {[&#10;        ['C1', 'Extra patterns (correct)', '+2'],&#10;        ['C2', 'Refactoring narrative', '+2'],&#10;        ['C3', 'Outstanding docs', '+1'],&#10;      ].map(([id, t, w]) =&gt; (&#10;        &lt;Box key={id} style={{ flexDirection: 'row', alignItems: 'center', gap: 10, padding: '10px 0', borderBottom: '1px solid #E5E7EB' }}&gt;&#10;          &lt;Box style={{ width: 34, height: 22, borderRadius: 5, background: '#E8EFF8', justifyContent: 'center', alignItems: 'center' }}&gt;&#10;            &lt;Text style={{ fontSize: 12, fontWeight: 'bold', color: '#1E4FA8' }}&gt;{id}&lt;/Text&gt;&#10;          &lt;/Box&gt;&#10;          &lt;Text style={{ flex: 1, fontSize: 14, color: '#4A5568' }}&gt;{t}&lt;/Text&gt;&#10;          &lt;Text style={{ fontSize: 13, fontWeight: 'bold', color: '#D9534F' }}&gt;{w}&lt;/Text&gt;&#10;        &lt;/Box&gt;&#10;      ))}&#10;      &lt;Box style={{ marginTop: 12, padding: '12px 14px', background: '#FFFFFF', borderRadius: 8, border: '1px solid #E5E7EB' }}&gt;&#10;        &lt;Text style={{ fontSize: 13, color: '#4A5568', lineHeight: 1.5 }}&gt;Weekly exercises feed &lt;span style={{ fontWeight: 'bold', color: '#1A2230' }}&gt;F2 participation&lt;/span&gt; (4 pts) — checked and discussed in class every week.&lt;/Text&gt;&#10;      &lt;/Box&gt;&#10;    &lt;/Box&gt;&#10;  &lt;/Box&gt;&#10;  &lt;Box style={{ height: 44, padding: '0 40px', flexDirection: 'row', alignItems: 'center', justifyContent: 'space-between', background: '#F7F9FC', borderTop: '1px solid #E5E7EB' }}&gt;&#10;    &lt;Box style={{ flexDirection: 'row', alignItems: 'center', gap: 8, flex: 1 }}&gt;&#10;      &lt;Text style={{ fontSize: 13, fontWeight: 'bold', color: '#0E3F8C' }}&gt;Milestones&lt;/Text&gt;&#10;      &lt;Text style={{ fontSize: 13, color: '#4A5568' }}&gt;M0 Sep 11 · M1 Oct 4 · M2 Oct 25 · M3 Nov 22 · M4 Dec 6 · M5 defense Dec 14–18&lt;/Text&gt;&#10;    &lt;/Box&gt;&#10;    &lt;Text style={{ fontSize: 14, color: '#1E4FA8', fontWeight: 'bold' }}&gt;06 / 38&lt;/Text&gt;&#10;  &lt;/Box&gt;&#10;&lt;/Slide&gt;"/>
         <p:cNvGrpSpPr/>
         <p:nvPr/>
       </p:nvGrpSpPr>
@@ -27088,7 +27135,7 @@
       </p:grpSpPr>
       <p:sp>
         <p:nvSpPr>
-          <p:cNvPr id="701" name=""/>
+          <p:cNvPr id="703" name=""/>
           <p:cNvSpPr/>
           <p:nvPr/>
         </p:nvSpPr>
@@ -27112,7 +27159,7 @@
       </p:sp>
       <p:sp>
         <p:nvSpPr>
-          <p:cNvPr id="702" name=""/>
+          <p:cNvPr id="704" name=""/>
           <p:cNvSpPr/>
           <p:nvPr/>
         </p:nvSpPr>
@@ -27136,7 +27183,7 @@
       </p:sp>
       <p:sp>
         <p:nvSpPr>
-          <p:cNvPr id="703" name="" descr="{&quot;isTemplate&quot;:true,&quot;type&quot;:&quot;text&quot;}"/>
+          <p:cNvPr id="705" name="" descr="{&quot;isTemplate&quot;:true,&quot;type&quot;:&quot;text&quot;}"/>
           <p:cNvSpPr txBox="1"/>
           <p:nvPr/>
         </p:nvSpPr>
@@ -27171,7 +27218,7 @@
       </p:sp>
       <p:sp>
         <p:nvSpPr>
-          <p:cNvPr id="704" name="" descr="{&quot;isTemplate&quot;:true,&quot;type&quot;:&quot;text&quot;}"/>
+          <p:cNvPr id="706" name="" descr="{&quot;isTemplate&quot;:true,&quot;type&quot;:&quot;text&quot;}"/>
           <p:cNvSpPr txBox="1"/>
           <p:nvPr/>
         </p:nvSpPr>
@@ -27206,7 +27253,7 @@
       </p:sp>
       <p:sp>
         <p:nvSpPr>
-          <p:cNvPr id="705" name="" descr="{&quot;isTemplate&quot;:true,&quot;type&quot;:&quot;text&quot;}"/>
+          <p:cNvPr id="707" name="" descr="{&quot;isTemplate&quot;:true,&quot;type&quot;:&quot;text&quot;}"/>
           <p:cNvSpPr txBox="1"/>
           <p:nvPr/>
         </p:nvSpPr>
@@ -27241,7 +27288,7 @@
       </p:sp>
       <p:sp>
         <p:nvSpPr>
-          <p:cNvPr id="706" name=""/>
+          <p:cNvPr id="708" name=""/>
           <p:cNvSpPr/>
           <p:nvPr/>
         </p:nvSpPr>
@@ -27272,7 +27319,7 @@
       </p:sp>
       <p:sp>
         <p:nvSpPr>
-          <p:cNvPr id="707" name="" descr="{&quot;isTemplate&quot;:true,&quot;type&quot;:&quot;text&quot;}"/>
+          <p:cNvPr id="709" name="" descr="{&quot;isTemplate&quot;:true,&quot;type&quot;:&quot;text&quot;}"/>
           <p:cNvSpPr txBox="1"/>
           <p:nvPr/>
         </p:nvSpPr>
@@ -27299,22 +27346,22 @@
                 <a:latin typeface="Microsoft YaHei"/>
                 <a:ea typeface="Microsoft YaHei"/>
               </a:rPr>
-              <a:t>50</a:t>
-            </a:r>
-            <a:endParaRPr/>
-          </a:p>
-        </p:txBody>
-      </p:sp>
-      <p:sp>
-        <p:nvSpPr>
-          <p:cNvPr id="708" name="" descr="{&quot;isTemplate&quot;:true,&quot;type&quot;:&quot;text&quot;}"/>
+              <a:t>40</a:t>
+            </a:r>
+            <a:endParaRPr/>
+          </a:p>
+        </p:txBody>
+      </p:sp>
+      <p:sp>
+        <p:nvSpPr>
+          <p:cNvPr id="710" name="" descr="{&quot;isTemplate&quot;:true,&quot;type&quot;:&quot;text&quot;}"/>
           <p:cNvSpPr txBox="1"/>
           <p:nvPr/>
         </p:nvSpPr>
         <p:spPr>
           <a:xfrm rot="0" flipH="0" flipV="0">
             <a:off x="981075" y="1600200"/>
-            <a:ext cx="171450" cy="457200"/>
+            <a:ext cx="342900" cy="457200"/>
           </a:xfrm>
           <a:prstGeom prst="rect"/>
         </p:spPr>
@@ -27334,22 +27381,22 @@
                 <a:latin typeface="Microsoft YaHei"/>
                 <a:ea typeface="Microsoft YaHei"/>
               </a:rPr>
-              <a:t>%</a:t>
-            </a:r>
-            <a:endParaRPr/>
-          </a:p>
-        </p:txBody>
-      </p:sp>
-      <p:sp>
-        <p:nvSpPr>
-          <p:cNvPr id="709" name="" descr="{&quot;isTemplate&quot;:true,&quot;type&quot;:&quot;text&quot;}"/>
-          <p:cNvSpPr txBox="1"/>
-          <p:nvPr/>
-        </p:nvSpPr>
-        <p:spPr>
-          <a:xfrm rot="0" flipH="0" flipV="0">
-            <a:off x="1247775" y="1600200"/>
-            <a:ext cx="1143000" cy="457200"/>
+              <a:t> pts</a:t>
+            </a:r>
+            <a:endParaRPr/>
+          </a:p>
+        </p:txBody>
+      </p:sp>
+      <p:sp>
+        <p:nvSpPr>
+          <p:cNvPr id="711" name="" descr="{&quot;isTemplate&quot;:true,&quot;type&quot;:&quot;text&quot;}"/>
+          <p:cNvSpPr txBox="1"/>
+          <p:nvPr/>
+        </p:nvSpPr>
+        <p:spPr>
+          <a:xfrm rot="0" flipH="0" flipV="0">
+            <a:off x="1419225" y="1600200"/>
+            <a:ext cx="1457325" cy="457200"/>
           </a:xfrm>
           <a:prstGeom prst="rect"/>
         </p:spPr>
@@ -27369,37 +27416,37 @@
                 <a:latin typeface="Microsoft YaHei"/>
                 <a:ea typeface="Microsoft YaHei"/>
               </a:rPr>
-              <a:t>Group project</a:t>
-            </a:r>
-            <a:endParaRPr/>
-          </a:p>
-        </p:txBody>
-      </p:sp>
-      <p:sp>
-        <p:nvSpPr>
-          <p:cNvPr id="710" name=""/>
+              <a:t>Formative × 100%</a:t>
+            </a:r>
+            <a:endParaRPr/>
+          </a:p>
+        </p:txBody>
+      </p:sp>
+      <p:sp>
+        <p:nvSpPr>
+          <p:cNvPr id="712" name=""/>
           <p:cNvSpPr/>
           <p:nvPr/>
         </p:nvSpPr>
         <p:spPr>
           <a:xfrm rot="0" flipH="0" flipV="0">
             <a:off x="552450" y="2171700"/>
-            <a:ext cx="3324225" cy="342900"/>
+            <a:ext cx="3324225" cy="419100"/>
           </a:xfrm>
           <a:custGeom>
             <a:pathLst>
-              <a:path w="349" h="36">
+              <a:path w="349" h="44">
                 <a:moveTo>
-                  <a:pt x="0" y="35"/>
+                  <a:pt x="0" y="43"/>
                 </a:moveTo>
                 <a:lnTo>
-                  <a:pt x="349" y="35"/>
+                  <a:pt x="349" y="43"/>
                 </a:lnTo>
                 <a:lnTo>
-                  <a:pt x="349" y="36"/>
+                  <a:pt x="349" y="44"/>
                 </a:lnTo>
                 <a:lnTo>
-                  <a:pt x="0" y="36"/>
+                  <a:pt x="0" y="44"/>
                 </a:lnTo>
                 <a:close/>
               </a:path>
@@ -27417,13 +27464,13 @@
       </p:sp>
       <p:sp>
         <p:nvSpPr>
-          <p:cNvPr id="711" name=""/>
+          <p:cNvPr id="713" name=""/>
           <p:cNvSpPr/>
           <p:nvPr/>
         </p:nvSpPr>
         <p:spPr>
           <a:xfrm rot="0" flipH="0" flipV="0">
-            <a:off x="552450" y="2228850"/>
+            <a:off x="552450" y="2266950"/>
             <a:ext cx="323850" cy="209550"/>
           </a:xfrm>
           <a:prstGeom prst="roundRect">
@@ -27443,14 +27490,14 @@
       </p:sp>
       <p:sp>
         <p:nvSpPr>
-          <p:cNvPr id="712" name="" descr="{&quot;isTemplate&quot;:true,&quot;type&quot;:&quot;text&quot;}"/>
-          <p:cNvSpPr txBox="1"/>
-          <p:nvPr/>
-        </p:nvSpPr>
-        <p:spPr>
-          <a:xfrm rot="0" flipH="0" flipV="0">
-            <a:off x="638175" y="2266950"/>
-            <a:ext cx="152400" cy="142875"/>
+          <p:cNvPr id="714" name="" descr="{&quot;isTemplate&quot;:true,&quot;type&quot;:&quot;text&quot;}"/>
+          <p:cNvSpPr txBox="1"/>
+          <p:nvPr/>
+        </p:nvSpPr>
+        <p:spPr>
+          <a:xfrm rot="0" flipH="0" flipV="0">
+            <a:off x="647700" y="2305050"/>
+            <a:ext cx="142875" cy="142875"/>
           </a:xfrm>
           <a:prstGeom prst="rect"/>
         </p:spPr>
@@ -27470,22 +27517,22 @@
                 <a:latin typeface="Microsoft YaHei"/>
                 <a:ea typeface="Microsoft YaHei"/>
               </a:rPr>
-              <a:t>A1</a:t>
-            </a:r>
-            <a:endParaRPr/>
-          </a:p>
-        </p:txBody>
-      </p:sp>
-      <p:sp>
-        <p:nvSpPr>
-          <p:cNvPr id="713" name="" descr="{&quot;isTemplate&quot;:true,&quot;type&quot;:&quot;text&quot;}"/>
-          <p:cNvSpPr txBox="1"/>
-          <p:nvPr/>
-        </p:nvSpPr>
-        <p:spPr>
-          <a:xfrm rot="0" flipH="0" flipV="0">
-            <a:off x="971550" y="2257425"/>
-            <a:ext cx="2533650" cy="161925"/>
+              <a:t>F1</a:t>
+            </a:r>
+            <a:endParaRPr/>
+          </a:p>
+        </p:txBody>
+      </p:sp>
+      <p:sp>
+        <p:nvSpPr>
+          <p:cNvPr id="715" name="" descr="{&quot;isTemplate&quot;:true,&quot;type&quot;:&quot;text&quot;}"/>
+          <p:cNvSpPr txBox="1"/>
+          <p:nvPr/>
+        </p:nvSpPr>
+        <p:spPr>
+          <a:xfrm rot="0" flipH="0" flipV="0">
+            <a:off x="971550" y="2295525"/>
+            <a:ext cx="2733675" cy="161925"/>
           </a:xfrm>
           <a:prstGeom prst="rect"/>
         </p:spPr>
@@ -27505,22 +27552,22 @@
                 <a:latin typeface="Microsoft YaHei"/>
                 <a:ea typeface="Microsoft YaHei"/>
               </a:rPr>
-              <a:t>Requirements &amp;amp; use cases</a:t>
-            </a:r>
-            <a:endParaRPr/>
-          </a:p>
-        </p:txBody>
-      </p:sp>
-      <p:sp>
-        <p:nvSpPr>
-          <p:cNvPr id="714" name="" descr="{&quot;isTemplate&quot;:true,&quot;type&quot;:&quot;text&quot;}"/>
-          <p:cNvSpPr txBox="1"/>
-          <p:nvPr/>
-        </p:nvSpPr>
-        <p:spPr>
-          <a:xfrm rot="0" flipH="0" flipV="0">
-            <a:off x="3600450" y="2257425"/>
-            <a:ext cx="276225" cy="161925"/>
+              <a:t>Attendance</a:t>
+            </a:r>
+            <a:endParaRPr/>
+          </a:p>
+        </p:txBody>
+      </p:sp>
+      <p:sp>
+        <p:nvSpPr>
+          <p:cNvPr id="716" name="" descr="{&quot;isTemplate&quot;:true,&quot;type&quot;:&quot;text&quot;}"/>
+          <p:cNvSpPr txBox="1"/>
+          <p:nvPr/>
+        </p:nvSpPr>
+        <p:spPr>
+          <a:xfrm rot="0" flipH="0" flipV="0">
+            <a:off x="3800475" y="2295525"/>
+            <a:ext cx="76200" cy="161925"/>
           </a:xfrm>
           <a:prstGeom prst="rect"/>
         </p:spPr>
@@ -27540,37 +27587,37 @@
                 <a:latin typeface="Microsoft YaHei"/>
                 <a:ea typeface="Microsoft YaHei"/>
               </a:rPr>
-              <a:t>15%</a:t>
-            </a:r>
-            <a:endParaRPr/>
-          </a:p>
-        </p:txBody>
-      </p:sp>
-      <p:sp>
-        <p:nvSpPr>
-          <p:cNvPr id="715" name=""/>
+              <a:t>0</a:t>
+            </a:r>
+            <a:endParaRPr/>
+          </a:p>
+        </p:txBody>
+      </p:sp>
+      <p:sp>
+        <p:nvSpPr>
+          <p:cNvPr id="717" name=""/>
           <p:cNvSpPr/>
           <p:nvPr/>
         </p:nvSpPr>
         <p:spPr>
           <a:xfrm rot="0" flipH="0" flipV="0">
-            <a:off x="552450" y="2505075"/>
-            <a:ext cx="3324225" cy="342900"/>
+            <a:off x="552450" y="2581275"/>
+            <a:ext cx="3324225" cy="419100"/>
           </a:xfrm>
           <a:custGeom>
             <a:pathLst>
-              <a:path w="349" h="36">
+              <a:path w="349" h="44">
                 <a:moveTo>
-                  <a:pt x="0" y="35"/>
+                  <a:pt x="0" y="43"/>
                 </a:moveTo>
                 <a:lnTo>
-                  <a:pt x="349" y="35"/>
+                  <a:pt x="349" y="43"/>
                 </a:lnTo>
                 <a:lnTo>
-                  <a:pt x="349" y="36"/>
+                  <a:pt x="349" y="44"/>
                 </a:lnTo>
                 <a:lnTo>
-                  <a:pt x="0" y="36"/>
+                  <a:pt x="0" y="44"/>
                 </a:lnTo>
                 <a:close/>
               </a:path>
@@ -27588,13 +27635,13 @@
       </p:sp>
       <p:sp>
         <p:nvSpPr>
-          <p:cNvPr id="716" name=""/>
+          <p:cNvPr id="718" name=""/>
           <p:cNvSpPr/>
           <p:nvPr/>
         </p:nvSpPr>
         <p:spPr>
           <a:xfrm rot="0" flipH="0" flipV="0">
-            <a:off x="552450" y="2562225"/>
+            <a:off x="552450" y="2676525"/>
             <a:ext cx="323850" cy="209550"/>
           </a:xfrm>
           <a:prstGeom prst="roundRect">
@@ -27614,14 +27661,14 @@
       </p:sp>
       <p:sp>
         <p:nvSpPr>
-          <p:cNvPr id="717" name="" descr="{&quot;isTemplate&quot;:true,&quot;type&quot;:&quot;text&quot;}"/>
-          <p:cNvSpPr txBox="1"/>
-          <p:nvPr/>
-        </p:nvSpPr>
-        <p:spPr>
-          <a:xfrm rot="0" flipH="0" flipV="0">
-            <a:off x="638175" y="2600325"/>
-            <a:ext cx="152400" cy="142875"/>
+          <p:cNvPr id="719" name="" descr="{&quot;isTemplate&quot;:true,&quot;type&quot;:&quot;text&quot;}"/>
+          <p:cNvSpPr txBox="1"/>
+          <p:nvPr/>
+        </p:nvSpPr>
+        <p:spPr>
+          <a:xfrm rot="0" flipH="0" flipV="0">
+            <a:off x="647700" y="2714625"/>
+            <a:ext cx="142875" cy="142875"/>
           </a:xfrm>
           <a:prstGeom prst="rect"/>
         </p:spPr>
@@ -27641,22 +27688,22 @@
                 <a:latin typeface="Microsoft YaHei"/>
                 <a:ea typeface="Microsoft YaHei"/>
               </a:rPr>
-              <a:t>A2</a:t>
-            </a:r>
-            <a:endParaRPr/>
-          </a:p>
-        </p:txBody>
-      </p:sp>
-      <p:sp>
-        <p:nvSpPr>
-          <p:cNvPr id="718" name="" descr="{&quot;isTemplate&quot;:true,&quot;type&quot;:&quot;text&quot;}"/>
-          <p:cNvSpPr txBox="1"/>
-          <p:nvPr/>
-        </p:nvSpPr>
-        <p:spPr>
-          <a:xfrm rot="0" flipH="0" flipV="0">
-            <a:off x="971550" y="2590800"/>
-            <a:ext cx="2533650" cy="161925"/>
+              <a:t>F2</a:t>
+            </a:r>
+            <a:endParaRPr/>
+          </a:p>
+        </p:txBody>
+      </p:sp>
+      <p:sp>
+        <p:nvSpPr>
+          <p:cNvPr id="720" name="" descr="{&quot;isTemplate&quot;:true,&quot;type&quot;:&quot;text&quot;}"/>
+          <p:cNvSpPr txBox="1"/>
+          <p:nvPr/>
+        </p:nvSpPr>
+        <p:spPr>
+          <a:xfrm rot="0" flipH="0" flipV="0">
+            <a:off x="971550" y="2705100"/>
+            <a:ext cx="2657475" cy="161925"/>
           </a:xfrm>
           <a:prstGeom prst="rect"/>
         </p:spPr>
@@ -27676,22 +27723,22 @@
                 <a:latin typeface="Microsoft YaHei"/>
                 <a:ea typeface="Microsoft YaHei"/>
               </a:rPr>
-              <a:t>Analysis models</a:t>
-            </a:r>
-            <a:endParaRPr/>
-          </a:p>
-        </p:txBody>
-      </p:sp>
-      <p:sp>
-        <p:nvSpPr>
-          <p:cNvPr id="719" name="" descr="{&quot;isTemplate&quot;:true,&quot;type&quot;:&quot;text&quot;}"/>
-          <p:cNvSpPr txBox="1"/>
-          <p:nvPr/>
-        </p:nvSpPr>
-        <p:spPr>
-          <a:xfrm rot="0" flipH="0" flipV="0">
-            <a:off x="3600450" y="2590800"/>
-            <a:ext cx="276225" cy="161925"/>
+              <a:t>Class participation</a:t>
+            </a:r>
+            <a:endParaRPr/>
+          </a:p>
+        </p:txBody>
+      </p:sp>
+      <p:sp>
+        <p:nvSpPr>
+          <p:cNvPr id="721" name="" descr="{&quot;isTemplate&quot;:true,&quot;type&quot;:&quot;text&quot;}"/>
+          <p:cNvSpPr txBox="1"/>
+          <p:nvPr/>
+        </p:nvSpPr>
+        <p:spPr>
+          <a:xfrm rot="0" flipH="0" flipV="0">
+            <a:off x="3724275" y="2705100"/>
+            <a:ext cx="152400" cy="161925"/>
           </a:xfrm>
           <a:prstGeom prst="rect"/>
         </p:spPr>
@@ -27711,37 +27758,37 @@
                 <a:latin typeface="Microsoft YaHei"/>
                 <a:ea typeface="Microsoft YaHei"/>
               </a:rPr>
-              <a:t>25%</a:t>
-            </a:r>
-            <a:endParaRPr/>
-          </a:p>
-        </p:txBody>
-      </p:sp>
-      <p:sp>
-        <p:nvSpPr>
-          <p:cNvPr id="720" name=""/>
+              <a:t>10</a:t>
+            </a:r>
+            <a:endParaRPr/>
+          </a:p>
+        </p:txBody>
+      </p:sp>
+      <p:sp>
+        <p:nvSpPr>
+          <p:cNvPr id="722" name=""/>
           <p:cNvSpPr/>
           <p:nvPr/>
         </p:nvSpPr>
         <p:spPr>
           <a:xfrm rot="0" flipH="0" flipV="0">
-            <a:off x="552450" y="2838450"/>
-            <a:ext cx="3324225" cy="342900"/>
+            <a:off x="552450" y="2990850"/>
+            <a:ext cx="3324225" cy="419100"/>
           </a:xfrm>
           <a:custGeom>
             <a:pathLst>
-              <a:path w="349" h="36">
+              <a:path w="349" h="44">
                 <a:moveTo>
-                  <a:pt x="0" y="35"/>
+                  <a:pt x="0" y="43"/>
                 </a:moveTo>
                 <a:lnTo>
-                  <a:pt x="349" y="35"/>
+                  <a:pt x="349" y="43"/>
                 </a:lnTo>
                 <a:lnTo>
-                  <a:pt x="349" y="36"/>
+                  <a:pt x="349" y="44"/>
                 </a:lnTo>
                 <a:lnTo>
-                  <a:pt x="0" y="36"/>
+                  <a:pt x="0" y="44"/>
                 </a:lnTo>
                 <a:close/>
               </a:path>
@@ -27759,13 +27806,13 @@
       </p:sp>
       <p:sp>
         <p:nvSpPr>
-          <p:cNvPr id="721" name=""/>
+          <p:cNvPr id="723" name=""/>
           <p:cNvSpPr/>
           <p:nvPr/>
         </p:nvSpPr>
         <p:spPr>
           <a:xfrm rot="0" flipH="0" flipV="0">
-            <a:off x="552450" y="2895600"/>
+            <a:off x="552450" y="3086100"/>
             <a:ext cx="323850" cy="209550"/>
           </a:xfrm>
           <a:prstGeom prst="roundRect">
@@ -27785,14 +27832,14 @@
       </p:sp>
       <p:sp>
         <p:nvSpPr>
-          <p:cNvPr id="722" name="" descr="{&quot;isTemplate&quot;:true,&quot;type&quot;:&quot;text&quot;}"/>
-          <p:cNvSpPr txBox="1"/>
-          <p:nvPr/>
-        </p:nvSpPr>
-        <p:spPr>
-          <a:xfrm rot="0" flipH="0" flipV="0">
-            <a:off x="638175" y="2933700"/>
-            <a:ext cx="152400" cy="142875"/>
+          <p:cNvPr id="724" name="" descr="{&quot;isTemplate&quot;:true,&quot;type&quot;:&quot;text&quot;}"/>
+          <p:cNvSpPr txBox="1"/>
+          <p:nvPr/>
+        </p:nvSpPr>
+        <p:spPr>
+          <a:xfrm rot="0" flipH="0" flipV="0">
+            <a:off x="647700" y="3124200"/>
+            <a:ext cx="142875" cy="142875"/>
           </a:xfrm>
           <a:prstGeom prst="rect"/>
         </p:spPr>
@@ -27812,22 +27859,22 @@
                 <a:latin typeface="Microsoft YaHei"/>
                 <a:ea typeface="Microsoft YaHei"/>
               </a:rPr>
-              <a:t>A3</a:t>
-            </a:r>
-            <a:endParaRPr/>
-          </a:p>
-        </p:txBody>
-      </p:sp>
-      <p:sp>
-        <p:nvSpPr>
-          <p:cNvPr id="723" name="" descr="{&quot;isTemplate&quot;:true,&quot;type&quot;:&quot;text&quot;}"/>
-          <p:cNvSpPr txBox="1"/>
-          <p:nvPr/>
-        </p:nvSpPr>
-        <p:spPr>
-          <a:xfrm rot="0" flipH="0" flipV="0">
-            <a:off x="971550" y="2924175"/>
-            <a:ext cx="2533650" cy="161925"/>
+              <a:t>F3</a:t>
+            </a:r>
+            <a:endParaRPr/>
+          </a:p>
+        </p:txBody>
+      </p:sp>
+      <p:sp>
+        <p:nvSpPr>
+          <p:cNvPr id="725" name="" descr="{&quot;isTemplate&quot;:true,&quot;type&quot;:&quot;text&quot;}"/>
+          <p:cNvSpPr txBox="1"/>
+          <p:nvPr/>
+        </p:nvSpPr>
+        <p:spPr>
+          <a:xfrm rot="0" flipH="0" flipV="0">
+            <a:off x="971550" y="3114675"/>
+            <a:ext cx="2657475" cy="161925"/>
           </a:xfrm>
           <a:prstGeom prst="rect"/>
         </p:spPr>
@@ -27847,22 +27894,22 @@
                 <a:latin typeface="Microsoft YaHei"/>
                 <a:ea typeface="Microsoft YaHei"/>
               </a:rPr>
-              <a:t>Design class diagram</a:t>
-            </a:r>
-            <a:endParaRPr/>
-          </a:p>
-        </p:txBody>
-      </p:sp>
-      <p:sp>
-        <p:nvSpPr>
-          <p:cNvPr id="724" name="" descr="{&quot;isTemplate&quot;:true,&quot;type&quot;:&quot;text&quot;}"/>
-          <p:cNvSpPr txBox="1"/>
-          <p:nvPr/>
-        </p:nvSpPr>
-        <p:spPr>
-          <a:xfrm rot="0" flipH="0" flipV="0">
-            <a:off x="3600450" y="2924175"/>
-            <a:ext cx="276225" cy="161925"/>
+              <a:t>Level-3 project (CampusBites)</a:t>
+            </a:r>
+            <a:endParaRPr/>
+          </a:p>
+        </p:txBody>
+      </p:sp>
+      <p:sp>
+        <p:nvSpPr>
+          <p:cNvPr id="726" name="" descr="{&quot;isTemplate&quot;:true,&quot;type&quot;:&quot;text&quot;}"/>
+          <p:cNvSpPr txBox="1"/>
+          <p:nvPr/>
+        </p:nvSpPr>
+        <p:spPr>
+          <a:xfrm rot="0" flipH="0" flipV="0">
+            <a:off x="3724275" y="3114675"/>
+            <a:ext cx="152400" cy="161925"/>
           </a:xfrm>
           <a:prstGeom prst="rect"/>
         </p:spPr>
@@ -27882,37 +27929,37 @@
                 <a:latin typeface="Microsoft YaHei"/>
                 <a:ea typeface="Microsoft YaHei"/>
               </a:rPr>
-              <a:t>20%</a:t>
-            </a:r>
-            <a:endParaRPr/>
-          </a:p>
-        </p:txBody>
-      </p:sp>
-      <p:sp>
-        <p:nvSpPr>
-          <p:cNvPr id="725" name=""/>
+              <a:t>20</a:t>
+            </a:r>
+            <a:endParaRPr/>
+          </a:p>
+        </p:txBody>
+      </p:sp>
+      <p:sp>
+        <p:nvSpPr>
+          <p:cNvPr id="727" name=""/>
           <p:cNvSpPr/>
           <p:nvPr/>
         </p:nvSpPr>
         <p:spPr>
           <a:xfrm rot="0" flipH="0" flipV="0">
-            <a:off x="552450" y="3171825"/>
-            <a:ext cx="3324225" cy="342900"/>
+            <a:off x="552450" y="3400425"/>
+            <a:ext cx="3324225" cy="419100"/>
           </a:xfrm>
           <a:custGeom>
             <a:pathLst>
-              <a:path w="349" h="36">
+              <a:path w="349" h="44">
                 <a:moveTo>
-                  <a:pt x="0" y="35"/>
+                  <a:pt x="0" y="43"/>
                 </a:moveTo>
                 <a:lnTo>
-                  <a:pt x="349" y="35"/>
+                  <a:pt x="349" y="43"/>
                 </a:lnTo>
                 <a:lnTo>
-                  <a:pt x="349" y="36"/>
+                  <a:pt x="349" y="44"/>
                 </a:lnTo>
                 <a:lnTo>
-                  <a:pt x="0" y="36"/>
+                  <a:pt x="0" y="44"/>
                 </a:lnTo>
                 <a:close/>
               </a:path>
@@ -27930,13 +27977,13 @@
       </p:sp>
       <p:sp>
         <p:nvSpPr>
-          <p:cNvPr id="726" name=""/>
+          <p:cNvPr id="728" name=""/>
           <p:cNvSpPr/>
           <p:nvPr/>
         </p:nvSpPr>
         <p:spPr>
           <a:xfrm rot="0" flipH="0" flipV="0">
-            <a:off x="552450" y="3228975"/>
+            <a:off x="552450" y="3495675"/>
             <a:ext cx="323850" cy="209550"/>
           </a:xfrm>
           <a:prstGeom prst="roundRect">
@@ -27956,14 +28003,14 @@
       </p:sp>
       <p:sp>
         <p:nvSpPr>
-          <p:cNvPr id="727" name="" descr="{&quot;isTemplate&quot;:true,&quot;type&quot;:&quot;text&quot;}"/>
-          <p:cNvSpPr txBox="1"/>
-          <p:nvPr/>
-        </p:nvSpPr>
-        <p:spPr>
-          <a:xfrm rot="0" flipH="0" flipV="0">
-            <a:off x="638175" y="3267075"/>
-            <a:ext cx="152400" cy="142875"/>
+          <p:cNvPr id="729" name="" descr="{&quot;isTemplate&quot;:true,&quot;type&quot;:&quot;text&quot;}"/>
+          <p:cNvSpPr txBox="1"/>
+          <p:nvPr/>
+        </p:nvSpPr>
+        <p:spPr>
+          <a:xfrm rot="0" flipH="0" flipV="0">
+            <a:off x="647700" y="3533775"/>
+            <a:ext cx="142875" cy="142875"/>
           </a:xfrm>
           <a:prstGeom prst="rect"/>
         </p:spPr>
@@ -27983,22 +28030,22 @@
                 <a:latin typeface="Microsoft YaHei"/>
                 <a:ea typeface="Microsoft YaHei"/>
               </a:rPr>
-              <a:t>A4</a:t>
-            </a:r>
-            <a:endParaRPr/>
-          </a:p>
-        </p:txBody>
-      </p:sp>
-      <p:sp>
-        <p:nvSpPr>
-          <p:cNvPr id="728" name="" descr="{&quot;isTemplate&quot;:true,&quot;type&quot;:&quot;text&quot;}"/>
-          <p:cNvSpPr txBox="1"/>
-          <p:nvPr/>
-        </p:nvSpPr>
-        <p:spPr>
-          <a:xfrm rot="0" flipH="0" flipV="0">
-            <a:off x="971550" y="3257550"/>
-            <a:ext cx="2533650" cy="161925"/>
+              <a:t>F4</a:t>
+            </a:r>
+            <a:endParaRPr/>
+          </a:p>
+        </p:txBody>
+      </p:sp>
+      <p:sp>
+        <p:nvSpPr>
+          <p:cNvPr id="730" name="" descr="{&quot;isTemplate&quot;:true,&quot;type&quot;:&quot;text&quot;}"/>
+          <p:cNvSpPr txBox="1"/>
+          <p:nvPr/>
+        </p:nvSpPr>
+        <p:spPr>
+          <a:xfrm rot="0" flipH="0" flipV="0">
+            <a:off x="971550" y="3524250"/>
+            <a:ext cx="2657475" cy="161925"/>
           </a:xfrm>
           <a:prstGeom prst="rect"/>
         </p:spPr>
@@ -28018,22 +28065,22 @@
                 <a:latin typeface="Microsoft YaHei"/>
                 <a:ea typeface="Microsoft YaHei"/>
               </a:rPr>
-              <a:t>GRASP / SOLID application</a:t>
-            </a:r>
-            <a:endParaRPr/>
-          </a:p>
-        </p:txBody>
-      </p:sp>
-      <p:sp>
-        <p:nvSpPr>
-          <p:cNvPr id="729" name="" descr="{&quot;isTemplate&quot;:true,&quot;type&quot;:&quot;text&quot;}"/>
-          <p:cNvSpPr txBox="1"/>
-          <p:nvPr/>
-        </p:nvSpPr>
-        <p:spPr>
-          <a:xfrm rot="0" flipH="0" flipV="0">
-            <a:off x="3600450" y="3257550"/>
-            <a:ext cx="276225" cy="161925"/>
+              <a:t>Assignments (5 × 2)</a:t>
+            </a:r>
+            <a:endParaRPr/>
+          </a:p>
+        </p:txBody>
+      </p:sp>
+      <p:sp>
+        <p:nvSpPr>
+          <p:cNvPr id="731" name="" descr="{&quot;isTemplate&quot;:true,&quot;type&quot;:&quot;text&quot;}"/>
+          <p:cNvSpPr txBox="1"/>
+          <p:nvPr/>
+        </p:nvSpPr>
+        <p:spPr>
+          <a:xfrm rot="0" flipH="0" flipV="0">
+            <a:off x="3724275" y="3524250"/>
+            <a:ext cx="152400" cy="161925"/>
           </a:xfrm>
           <a:prstGeom prst="rect"/>
         </p:spPr>
@@ -28053,72 +28100,37 @@
                 <a:latin typeface="Microsoft YaHei"/>
                 <a:ea typeface="Microsoft YaHei"/>
               </a:rPr>
-              <a:t>15%</a:t>
-            </a:r>
-            <a:endParaRPr/>
-          </a:p>
-        </p:txBody>
-      </p:sp>
-      <p:sp>
-        <p:nvSpPr>
-          <p:cNvPr id="730" name=""/>
+              <a:t>10</a:t>
+            </a:r>
+            <a:endParaRPr/>
+          </a:p>
+        </p:txBody>
+      </p:sp>
+      <p:sp>
+        <p:nvSpPr>
+          <p:cNvPr id="732" name=""/>
           <p:cNvSpPr/>
           <p:nvPr/>
         </p:nvSpPr>
         <p:spPr>
           <a:xfrm rot="0" flipH="0" flipV="0">
-            <a:off x="552450" y="3505200"/>
-            <a:ext cx="3324225" cy="342900"/>
-          </a:xfrm>
-          <a:custGeom>
-            <a:pathLst>
-              <a:path w="349" h="36">
-                <a:moveTo>
-                  <a:pt x="0" y="35"/>
-                </a:moveTo>
-                <a:lnTo>
-                  <a:pt x="349" y="35"/>
-                </a:lnTo>
-                <a:lnTo>
-                  <a:pt x="349" y="36"/>
-                </a:lnTo>
-                <a:lnTo>
-                  <a:pt x="0" y="36"/>
-                </a:lnTo>
-                <a:close/>
-              </a:path>
-            </a:pathLst>
-          </a:custGeom>
-          <a:solidFill>
-            <a:srgbClr val="E5E7EB"/>
-          </a:solidFill>
-          <a:ln/>
-        </p:spPr>
-        <p:txBody>
-          <a:bodyPr/>
-          <a:p/>
-        </p:txBody>
-      </p:sp>
-      <p:sp>
-        <p:nvSpPr>
-          <p:cNvPr id="731" name=""/>
-          <p:cNvSpPr/>
-          <p:nvPr/>
-        </p:nvSpPr>
-        <p:spPr>
-          <a:xfrm rot="0" flipH="0" flipV="0">
-            <a:off x="552450" y="3562350"/>
-            <a:ext cx="323850" cy="209550"/>
+            <a:off x="552450" y="3924300"/>
+            <a:ext cx="3324225" cy="676275"/>
           </a:xfrm>
           <a:prstGeom prst="roundRect">
             <a:avLst>
-              <a:gd name="adj" fmla="val 22727"/>
+              <a:gd name="adj" fmla="val 11268"/>
             </a:avLst>
           </a:prstGeom>
           <a:solidFill>
-            <a:srgbClr val="E8EFF8"/>
+            <a:srgbClr val="FFFFFF"/>
           </a:solidFill>
-          <a:ln/>
+          <a:ln w="12700">
+            <a:solidFill>
+              <a:srgbClr val="E5E7EB"/>
+            </a:solidFill>
+            <a:prstDash val="solid"/>
+          </a:ln>
         </p:spPr>
         <p:txBody>
           <a:bodyPr/>
@@ -28127,283 +28139,84 @@
       </p:sp>
       <p:sp>
         <p:nvSpPr>
-          <p:cNvPr id="732" name="" descr="{&quot;isTemplate&quot;:true,&quot;type&quot;:&quot;text&quot;}"/>
-          <p:cNvSpPr txBox="1"/>
-          <p:nvPr/>
-        </p:nvSpPr>
-        <p:spPr>
-          <a:xfrm rot="0" flipH="0" flipV="0">
-            <a:off x="638175" y="3600450"/>
-            <a:ext cx="152400" cy="142875"/>
-          </a:xfrm>
-          <a:prstGeom prst="rect"/>
-        </p:spPr>
-        <p:txBody>
-          <a:bodyPr wrap="none" lIns="0" tIns="0" rIns="0" bIns="0"/>
-          <a:p>
-            <a:pPr>
-              <a:lnSpc>
-                <a:spcPct val="100000"/>
-              </a:lnSpc>
-            </a:pPr>
-            <a:r>
-              <a:rPr lang="en-US" sz="900" b="1">
-                <a:solidFill>
-                  <a:srgbClr val="1E4FA8"/>
-                </a:solidFill>
-                <a:latin typeface="Microsoft YaHei"/>
-                <a:ea typeface="Microsoft YaHei"/>
-              </a:rPr>
-              <a:t>A5</a:t>
-            </a:r>
-            <a:endParaRPr/>
-          </a:p>
-        </p:txBody>
-      </p:sp>
-      <p:sp>
-        <p:nvSpPr>
           <p:cNvPr id="733" name="" descr="{&quot;isTemplate&quot;:true,&quot;type&quot;:&quot;text&quot;}"/>
           <p:cNvSpPr txBox="1"/>
           <p:nvPr/>
         </p:nvSpPr>
         <p:spPr>
           <a:xfrm rot="0" flipH="0" flipV="0">
-            <a:off x="971550" y="3590925"/>
-            <a:ext cx="2533650" cy="161925"/>
-          </a:xfrm>
-          <a:prstGeom prst="rect"/>
-        </p:spPr>
-        <p:txBody>
-          <a:bodyPr wrap="none" lIns="0" tIns="0" rIns="0" bIns="0"/>
-          <a:p>
-            <a:pPr>
-              <a:lnSpc>
-                <a:spcPct val="100000"/>
-              </a:lnSpc>
-            </a:pPr>
-            <a:r>
-              <a:rPr lang="en-US" sz="1050">
+            <a:off x="685800" y="4038600"/>
+            <a:ext cx="3057525" cy="447675"/>
+          </a:xfrm>
+          <a:prstGeom prst="rect"/>
+        </p:spPr>
+        <p:txBody>
+          <a:bodyPr wrap="square" lIns="0" tIns="0" rIns="0" bIns="0">
+            <a:normAutofit/>
+          </a:bodyPr>
+          <a:p>
+            <a:pPr>
+              <a:lnSpc>
+                <a:spcPct val="150000"/>
+              </a:lnSpc>
+            </a:pPr>
+            <a:r>
+              <a:rPr lang="en-US" sz="975">
                 <a:solidFill>
                   <a:srgbClr val="4A5568"/>
                 </a:solidFill>
                 <a:latin typeface="Microsoft YaHei"/>
                 <a:ea typeface="Microsoft YaHei"/>
               </a:rPr>
-              <a:t>Pattern catalog (5+)</a:t>
-            </a:r>
-            <a:endParaRPr/>
-          </a:p>
-        </p:txBody>
-      </p:sp>
-      <p:sp>
-        <p:nvSpPr>
-          <p:cNvPr id="734" name="" descr="{&quot;isTemplate&quot;:true,&quot;type&quot;:&quot;text&quot;}"/>
-          <p:cNvSpPr txBox="1"/>
-          <p:nvPr/>
-        </p:nvSpPr>
-        <p:spPr>
-          <a:xfrm rot="0" flipH="0" flipV="0">
-            <a:off x="3600450" y="3590925"/>
-            <a:ext cx="276225" cy="161925"/>
-          </a:xfrm>
-          <a:prstGeom prst="rect"/>
-        </p:spPr>
-        <p:txBody>
-          <a:bodyPr wrap="none" lIns="0" tIns="0" rIns="0" bIns="0"/>
-          <a:p>
-            <a:pPr>
-              <a:lnSpc>
-                <a:spcPct val="100000"/>
-              </a:lnSpc>
-            </a:pPr>
-            <a:r>
-              <a:rPr lang="en-US" sz="1050" b="1">
-                <a:solidFill>
-                  <a:srgbClr val="1E4FA8"/>
-                </a:solidFill>
-                <a:latin typeface="Microsoft YaHei"/>
-                <a:ea typeface="Microsoft YaHei"/>
-              </a:rPr>
-              <a:t>20%</a:t>
-            </a:r>
-            <a:endParaRPr/>
-          </a:p>
-        </p:txBody>
-      </p:sp>
-      <p:sp>
-        <p:nvSpPr>
-          <p:cNvPr id="735" name=""/>
-          <p:cNvSpPr/>
-          <p:nvPr/>
-        </p:nvSpPr>
-        <p:spPr>
-          <a:xfrm rot="0" flipH="0" flipV="0">
-            <a:off x="552450" y="3838575"/>
-            <a:ext cx="3324225" cy="342900"/>
-          </a:xfrm>
-          <a:custGeom>
-            <a:pathLst>
-              <a:path w="349" h="36">
-                <a:moveTo>
-                  <a:pt x="0" y="35"/>
-                </a:moveTo>
-                <a:lnTo>
-                  <a:pt x="349" y="35"/>
-                </a:lnTo>
-                <a:lnTo>
-                  <a:pt x="349" y="36"/>
-                </a:lnTo>
-                <a:lnTo>
-                  <a:pt x="0" y="36"/>
-                </a:lnTo>
-                <a:close/>
-              </a:path>
-            </a:pathLst>
-          </a:custGeom>
-          <a:solidFill>
-            <a:srgbClr val="E5E7EB"/>
-          </a:solidFill>
-          <a:ln/>
-        </p:spPr>
-        <p:txBody>
-          <a:bodyPr/>
-          <a:p/>
-        </p:txBody>
-      </p:sp>
-      <p:sp>
-        <p:nvSpPr>
-          <p:cNvPr id="736" name=""/>
-          <p:cNvSpPr/>
-          <p:nvPr/>
-        </p:nvSpPr>
-        <p:spPr>
-          <a:xfrm rot="0" flipH="0" flipV="0">
-            <a:off x="552450" y="3895725"/>
-            <a:ext cx="323850" cy="209550"/>
-          </a:xfrm>
-          <a:prstGeom prst="roundRect">
-            <a:avLst>
-              <a:gd name="adj" fmla="val 22727"/>
-            </a:avLst>
-          </a:prstGeom>
-          <a:solidFill>
-            <a:srgbClr val="E8EFF8"/>
-          </a:solidFill>
-          <a:ln/>
-        </p:spPr>
-        <p:txBody>
-          <a:bodyPr/>
-          <a:p/>
-        </p:txBody>
-      </p:sp>
-      <p:sp>
-        <p:nvSpPr>
-          <p:cNvPr id="737" name="" descr="{&quot;isTemplate&quot;:true,&quot;type&quot;:&quot;text&quot;}"/>
-          <p:cNvSpPr txBox="1"/>
-          <p:nvPr/>
-        </p:nvSpPr>
-        <p:spPr>
-          <a:xfrm rot="0" flipH="0" flipV="0">
-            <a:off x="638175" y="3933825"/>
-            <a:ext cx="152400" cy="142875"/>
-          </a:xfrm>
-          <a:prstGeom prst="rect"/>
-        </p:spPr>
-        <p:txBody>
-          <a:bodyPr wrap="none" lIns="0" tIns="0" rIns="0" bIns="0"/>
-          <a:p>
-            <a:pPr>
-              <a:lnSpc>
-                <a:spcPct val="100000"/>
-              </a:lnSpc>
-            </a:pPr>
-            <a:r>
-              <a:rPr lang="en-US" sz="900" b="1">
-                <a:solidFill>
-                  <a:srgbClr val="1E4FA8"/>
-                </a:solidFill>
-                <a:latin typeface="Microsoft YaHei"/>
-                <a:ea typeface="Microsoft YaHei"/>
-              </a:rPr>
-              <a:t>A6</a:t>
-            </a:r>
-            <a:endParaRPr/>
-          </a:p>
-        </p:txBody>
-      </p:sp>
-      <p:sp>
-        <p:nvSpPr>
-          <p:cNvPr id="738" name="" descr="{&quot;isTemplate&quot;:true,&quot;type&quot;:&quot;text&quot;}"/>
-          <p:cNvSpPr txBox="1"/>
-          <p:nvPr/>
-        </p:nvSpPr>
-        <p:spPr>
-          <a:xfrm rot="0" flipH="0" flipV="0">
-            <a:off x="971550" y="3924300"/>
-            <a:ext cx="2609850" cy="161925"/>
-          </a:xfrm>
-          <a:prstGeom prst="rect"/>
-        </p:spPr>
-        <p:txBody>
-          <a:bodyPr wrap="none" lIns="0" tIns="0" rIns="0" bIns="0"/>
-          <a:p>
-            <a:pPr>
-              <a:lnSpc>
-                <a:spcPct val="100000"/>
-              </a:lnSpc>
-            </a:pPr>
-            <a:r>
-              <a:rPr lang="en-US" sz="1050">
+              <a:t>F3 = milestones </a:t>
+            </a:r>
+            <a:r>
+              <a:rPr lang="en-US" sz="975" b="1">
+                <a:solidFill>
+                  <a:srgbClr val="1A2230"/>
+                </a:solidFill>
+                <a:latin typeface="Microsoft YaHei"/>
+                <a:ea typeface="Microsoft YaHei"/>
+              </a:rPr>
+              <a:t>14</a:t>
+            </a:r>
+            <a:r>
+              <a:rPr lang="en-US" sz="975">
                 <a:solidFill>
                   <a:srgbClr val="4A5568"/>
                 </a:solidFill>
                 <a:latin typeface="Microsoft YaHei"/>
                 <a:ea typeface="Microsoft YaHei"/>
               </a:rPr>
-              <a:t>English documentation</a:t>
-            </a:r>
-            <a:endParaRPr/>
-          </a:p>
-        </p:txBody>
-      </p:sp>
-      <p:sp>
-        <p:nvSpPr>
-          <p:cNvPr id="739" name="" descr="{&quot;isTemplate&quot;:true,&quot;type&quot;:&quot;text&quot;}"/>
-          <p:cNvSpPr txBox="1"/>
-          <p:nvPr/>
-        </p:nvSpPr>
-        <p:spPr>
-          <a:xfrm rot="0" flipH="0" flipV="0">
-            <a:off x="3676650" y="3924300"/>
-            <a:ext cx="200025" cy="161925"/>
-          </a:xfrm>
-          <a:prstGeom prst="rect"/>
-        </p:spPr>
-        <p:txBody>
-          <a:bodyPr wrap="none" lIns="0" tIns="0" rIns="0" bIns="0"/>
-          <a:p>
-            <a:pPr>
-              <a:lnSpc>
-                <a:spcPct val="100000"/>
-              </a:lnSpc>
-            </a:pPr>
-            <a:r>
-              <a:rPr lang="en-US" sz="1050" b="1">
-                <a:solidFill>
-                  <a:srgbClr val="1E4FA8"/>
-                </a:solidFill>
-                <a:latin typeface="Microsoft YaHei"/>
-                <a:ea typeface="Microsoft YaHei"/>
-              </a:rPr>
-              <a:t>5%</a:t>
-            </a:r>
-            <a:endParaRPr/>
-          </a:p>
-        </p:txBody>
-      </p:sp>
-      <p:sp>
-        <p:nvSpPr>
-          <p:cNvPr id="740" name=""/>
+              <a:t> (M0 1 · M1 3 · M2 4 · M3 3 · M4 3) + </a:t>
+            </a:r>
+            <a:r>
+              <a:rPr lang="en-US" sz="975" b="1">
+                <a:solidFill>
+                  <a:srgbClr val="1A2230"/>
+                </a:solidFill>
+                <a:latin typeface="Microsoft YaHei"/>
+                <a:ea typeface="Microsoft YaHei"/>
+              </a:rPr>
+              <a:t>your own</a:t>
+            </a:r>
+            <a:r>
+              <a:rPr lang="en-US" sz="975">
+                <a:solidFill>
+                  <a:srgbClr val="4A5568"/>
+                </a:solidFill>
+                <a:latin typeface="Microsoft YaHei"/>
+                <a:ea typeface="Microsoft YaHei"/>
+              </a:rPr>
+              <a:t> contribution &amp; Git 6.</a:t>
+            </a:r>
+            <a:endParaRPr/>
+          </a:p>
+        </p:txBody>
+      </p:sp>
+      <p:sp>
+        <p:nvSpPr>
+          <p:cNvPr id="734" name=""/>
           <p:cNvSpPr/>
           <p:nvPr/>
         </p:nvSpPr>
@@ -28429,14 +28242,14 @@
       </p:sp>
       <p:sp>
         <p:nvSpPr>
-          <p:cNvPr id="741" name="" descr="{&quot;isTemplate&quot;:true,&quot;type&quot;:&quot;text&quot;}"/>
+          <p:cNvPr id="735" name="" descr="{&quot;isTemplate&quot;:true,&quot;type&quot;:&quot;text&quot;}"/>
           <p:cNvSpPr txBox="1"/>
           <p:nvPr/>
         </p:nvSpPr>
         <p:spPr>
           <a:xfrm rot="0" flipH="0" flipV="0">
             <a:off x="4429125" y="1600200"/>
-            <a:ext cx="428625" cy="457200"/>
+            <a:ext cx="619125" cy="457200"/>
           </a:xfrm>
           <a:prstGeom prst="rect"/>
         </p:spPr>
@@ -28456,22 +28269,22 @@
                 <a:latin typeface="Microsoft YaHei"/>
                 <a:ea typeface="Microsoft YaHei"/>
               </a:rPr>
-              <a:t>40</a:t>
-            </a:r>
-            <a:endParaRPr/>
-          </a:p>
-        </p:txBody>
-      </p:sp>
-      <p:sp>
-        <p:nvSpPr>
-          <p:cNvPr id="742" name="" descr="{&quot;isTemplate&quot;:true,&quot;type&quot;:&quot;text&quot;}"/>
-          <p:cNvSpPr txBox="1"/>
-          <p:nvPr/>
-        </p:nvSpPr>
-        <p:spPr>
-          <a:xfrm rot="0" flipH="0" flipV="0">
-            <a:off x="4857750" y="1600200"/>
-            <a:ext cx="171450" cy="457200"/>
+              <a:t>100</a:t>
+            </a:r>
+            <a:endParaRPr/>
+          </a:p>
+        </p:txBody>
+      </p:sp>
+      <p:sp>
+        <p:nvSpPr>
+          <p:cNvPr id="736" name="" descr="{&quot;isTemplate&quot;:true,&quot;type&quot;:&quot;text&quot;}"/>
+          <p:cNvSpPr txBox="1"/>
+          <p:nvPr/>
+        </p:nvSpPr>
+        <p:spPr>
+          <a:xfrm rot="0" flipH="0" flipV="0">
+            <a:off x="5048250" y="1600200"/>
+            <a:ext cx="571500" cy="457200"/>
           </a:xfrm>
           <a:prstGeom prst="rect"/>
         </p:spPr>
@@ -28491,22 +28304,22 @@
                 <a:latin typeface="Microsoft YaHei"/>
                 <a:ea typeface="Microsoft YaHei"/>
               </a:rPr>
-              <a:t>%</a:t>
-            </a:r>
-            <a:endParaRPr/>
-          </a:p>
-        </p:txBody>
-      </p:sp>
-      <p:sp>
-        <p:nvSpPr>
-          <p:cNvPr id="743" name="" descr="{&quot;isTemplate&quot;:true,&quot;type&quot;:&quot;text&quot;}"/>
-          <p:cNvSpPr txBox="1"/>
-          <p:nvPr/>
-        </p:nvSpPr>
-        <p:spPr>
-          <a:xfrm rot="0" flipH="0" flipV="0">
-            <a:off x="5124450" y="1600200"/>
-            <a:ext cx="809625" cy="457200"/>
+              <a:t> × 60%</a:t>
+            </a:r>
+            <a:endParaRPr/>
+          </a:p>
+        </p:txBody>
+      </p:sp>
+      <p:sp>
+        <p:nvSpPr>
+          <p:cNvPr id="737" name="" descr="{&quot;isTemplate&quot;:true,&quot;type&quot;:&quot;text&quot;}"/>
+          <p:cNvSpPr txBox="1"/>
+          <p:nvPr/>
+        </p:nvSpPr>
+        <p:spPr>
+          <a:xfrm rot="0" flipH="0" flipV="0">
+            <a:off x="5715000" y="1600200"/>
+            <a:ext cx="2047875" cy="457200"/>
           </a:xfrm>
           <a:prstGeom prst="rect"/>
         </p:spPr>
@@ -28526,37 +28339,37 @@
                 <a:latin typeface="Microsoft YaHei"/>
                 <a:ea typeface="Microsoft YaHei"/>
               </a:rPr>
-              <a:t>Individual</a:t>
-            </a:r>
-            <a:endParaRPr/>
-          </a:p>
-        </p:txBody>
-      </p:sp>
-      <p:sp>
-        <p:nvSpPr>
-          <p:cNvPr id="744" name=""/>
+              <a:t>Summative · W16 defense</a:t>
+            </a:r>
+            <a:endParaRPr/>
+          </a:p>
+        </p:txBody>
+      </p:sp>
+      <p:sp>
+        <p:nvSpPr>
+          <p:cNvPr id="738" name=""/>
           <p:cNvSpPr/>
           <p:nvPr/>
         </p:nvSpPr>
         <p:spPr>
           <a:xfrm rot="0" flipH="0" flipV="0">
             <a:off x="4429125" y="2171700"/>
-            <a:ext cx="3333750" cy="381000"/>
+            <a:ext cx="3333750" cy="419100"/>
           </a:xfrm>
           <a:custGeom>
             <a:pathLst>
-              <a:path w="350" h="40">
+              <a:path w="350" h="44">
                 <a:moveTo>
-                  <a:pt x="0" y="39"/>
+                  <a:pt x="0" y="43"/>
                 </a:moveTo>
                 <a:lnTo>
-                  <a:pt x="350" y="39"/>
+                  <a:pt x="350" y="43"/>
                 </a:lnTo>
                 <a:lnTo>
-                  <a:pt x="350" y="40"/>
+                  <a:pt x="350" y="44"/>
                 </a:lnTo>
                 <a:lnTo>
-                  <a:pt x="0" y="40"/>
+                  <a:pt x="0" y="44"/>
                 </a:lnTo>
                 <a:close/>
               </a:path>
@@ -28574,13 +28387,13 @@
       </p:sp>
       <p:sp>
         <p:nvSpPr>
-          <p:cNvPr id="745" name=""/>
+          <p:cNvPr id="739" name=""/>
           <p:cNvSpPr/>
           <p:nvPr/>
         </p:nvSpPr>
         <p:spPr>
           <a:xfrm rot="0" flipH="0" flipV="0">
-            <a:off x="4429125" y="2247900"/>
+            <a:off x="4429125" y="2266950"/>
             <a:ext cx="323850" cy="209550"/>
           </a:xfrm>
           <a:prstGeom prst="roundRect">
@@ -28600,14 +28413,14 @@
       </p:sp>
       <p:sp>
         <p:nvSpPr>
-          <p:cNvPr id="746" name="" descr="{&quot;isTemplate&quot;:true,&quot;type&quot;:&quot;text&quot;}"/>
-          <p:cNvSpPr txBox="1"/>
-          <p:nvPr/>
-        </p:nvSpPr>
-        <p:spPr>
-          <a:xfrm rot="0" flipH="0" flipV="0">
-            <a:off x="4514850" y="2286000"/>
-            <a:ext cx="152400" cy="142875"/>
+          <p:cNvPr id="740" name="" descr="{&quot;isTemplate&quot;:true,&quot;type&quot;:&quot;text&quot;}"/>
+          <p:cNvSpPr txBox="1"/>
+          <p:nvPr/>
+        </p:nvSpPr>
+        <p:spPr>
+          <a:xfrm rot="0" flipH="0" flipV="0">
+            <a:off x="4524375" y="2305050"/>
+            <a:ext cx="142875" cy="142875"/>
           </a:xfrm>
           <a:prstGeom prst="rect"/>
         </p:spPr>
@@ -28627,22 +28440,22 @@
                 <a:latin typeface="Microsoft YaHei"/>
                 <a:ea typeface="Microsoft YaHei"/>
               </a:rPr>
-              <a:t>B1</a:t>
-            </a:r>
-            <a:endParaRPr/>
-          </a:p>
-        </p:txBody>
-      </p:sp>
-      <p:sp>
-        <p:nvSpPr>
-          <p:cNvPr id="747" name="" descr="{&quot;isTemplate&quot;:true,&quot;type&quot;:&quot;text&quot;}"/>
-          <p:cNvSpPr txBox="1"/>
-          <p:nvPr/>
-        </p:nvSpPr>
-        <p:spPr>
-          <a:xfrm rot="0" flipH="0" flipV="0">
-            <a:off x="4848225" y="2276475"/>
-            <a:ext cx="2543175" cy="161925"/>
+              <a:t>S1</a:t>
+            </a:r>
+            <a:endParaRPr/>
+          </a:p>
+        </p:txBody>
+      </p:sp>
+      <p:sp>
+        <p:nvSpPr>
+          <p:cNvPr id="741" name="" descr="{&quot;isTemplate&quot;:true,&quot;type&quot;:&quot;text&quot;}"/>
+          <p:cNvSpPr txBox="1"/>
+          <p:nvPr/>
+        </p:nvSpPr>
+        <p:spPr>
+          <a:xfrm rot="0" flipH="0" flipV="0">
+            <a:off x="4848225" y="2295525"/>
+            <a:ext cx="2667000" cy="161925"/>
           </a:xfrm>
           <a:prstGeom prst="rect"/>
         </p:spPr>
@@ -28662,22 +28475,22 @@
                 <a:latin typeface="Microsoft YaHei"/>
                 <a:ea typeface="Microsoft YaHei"/>
               </a:rPr>
-              <a:t>Defense Q&amp;amp;A (W16)</a:t>
-            </a:r>
-            <a:endParaRPr/>
-          </a:p>
-        </p:txBody>
-      </p:sp>
-      <p:sp>
-        <p:nvSpPr>
-          <p:cNvPr id="748" name="" descr="{&quot;isTemplate&quot;:true,&quot;type&quot;:&quot;text&quot;}"/>
-          <p:cNvSpPr txBox="1"/>
-          <p:nvPr/>
-        </p:nvSpPr>
-        <p:spPr>
-          <a:xfrm rot="0" flipH="0" flipV="0">
-            <a:off x="7486650" y="2276475"/>
-            <a:ext cx="276225" cy="161925"/>
+              <a:t>Portfolio walkthrough (team)</a:t>
+            </a:r>
+            <a:endParaRPr/>
+          </a:p>
+        </p:txBody>
+      </p:sp>
+      <p:sp>
+        <p:nvSpPr>
+          <p:cNvPr id="742" name="" descr="{&quot;isTemplate&quot;:true,&quot;type&quot;:&quot;text&quot;}"/>
+          <p:cNvSpPr txBox="1"/>
+          <p:nvPr/>
+        </p:nvSpPr>
+        <p:spPr>
+          <a:xfrm rot="0" flipH="0" flipV="0">
+            <a:off x="7610475" y="2295525"/>
+            <a:ext cx="152400" cy="161925"/>
           </a:xfrm>
           <a:prstGeom prst="rect"/>
         </p:spPr>
@@ -28697,37 +28510,37 @@
                 <a:latin typeface="Microsoft YaHei"/>
                 <a:ea typeface="Microsoft YaHei"/>
               </a:rPr>
-              <a:t>25%</a:t>
-            </a:r>
-            <a:endParaRPr/>
-          </a:p>
-        </p:txBody>
-      </p:sp>
-      <p:sp>
-        <p:nvSpPr>
-          <p:cNvPr id="749" name=""/>
+              <a:t>30</a:t>
+            </a:r>
+            <a:endParaRPr/>
+          </a:p>
+        </p:txBody>
+      </p:sp>
+      <p:sp>
+        <p:nvSpPr>
+          <p:cNvPr id="743" name=""/>
           <p:cNvSpPr/>
           <p:nvPr/>
         </p:nvSpPr>
         <p:spPr>
           <a:xfrm rot="0" flipH="0" flipV="0">
-            <a:off x="4429125" y="2543175"/>
-            <a:ext cx="3333750" cy="381000"/>
+            <a:off x="4429125" y="2581275"/>
+            <a:ext cx="3333750" cy="419100"/>
           </a:xfrm>
           <a:custGeom>
             <a:pathLst>
-              <a:path w="350" h="40">
+              <a:path w="350" h="44">
                 <a:moveTo>
-                  <a:pt x="0" y="39"/>
+                  <a:pt x="0" y="43"/>
                 </a:moveTo>
                 <a:lnTo>
-                  <a:pt x="350" y="39"/>
+                  <a:pt x="350" y="43"/>
                 </a:lnTo>
                 <a:lnTo>
-                  <a:pt x="350" y="40"/>
+                  <a:pt x="350" y="44"/>
                 </a:lnTo>
                 <a:lnTo>
-                  <a:pt x="0" y="40"/>
+                  <a:pt x="0" y="44"/>
                 </a:lnTo>
                 <a:close/>
               </a:path>
@@ -28745,13 +28558,13 @@
       </p:sp>
       <p:sp>
         <p:nvSpPr>
-          <p:cNvPr id="750" name=""/>
+          <p:cNvPr id="744" name=""/>
           <p:cNvSpPr/>
           <p:nvPr/>
         </p:nvSpPr>
         <p:spPr>
           <a:xfrm rot="0" flipH="0" flipV="0">
-            <a:off x="4429125" y="2619375"/>
+            <a:off x="4429125" y="2676525"/>
             <a:ext cx="323850" cy="209550"/>
           </a:xfrm>
           <a:prstGeom prst="roundRect">
@@ -28771,107 +28584,318 @@
       </p:sp>
       <p:sp>
         <p:nvSpPr>
+          <p:cNvPr id="745" name="" descr="{&quot;isTemplate&quot;:true,&quot;type&quot;:&quot;text&quot;}"/>
+          <p:cNvSpPr txBox="1"/>
+          <p:nvPr/>
+        </p:nvSpPr>
+        <p:spPr>
+          <a:xfrm rot="0" flipH="0" flipV="0">
+            <a:off x="4524375" y="2714625"/>
+            <a:ext cx="142875" cy="142875"/>
+          </a:xfrm>
+          <a:prstGeom prst="rect"/>
+        </p:spPr>
+        <p:txBody>
+          <a:bodyPr wrap="none" lIns="0" tIns="0" rIns="0" bIns="0"/>
+          <a:p>
+            <a:pPr>
+              <a:lnSpc>
+                <a:spcPct val="100000"/>
+              </a:lnSpc>
+            </a:pPr>
+            <a:r>
+              <a:rPr lang="en-US" sz="900" b="1">
+                <a:solidFill>
+                  <a:srgbClr val="FFC107"/>
+                </a:solidFill>
+                <a:latin typeface="Microsoft YaHei"/>
+                <a:ea typeface="Microsoft YaHei"/>
+              </a:rPr>
+              <a:t>S2</a:t>
+            </a:r>
+            <a:endParaRPr/>
+          </a:p>
+        </p:txBody>
+      </p:sp>
+      <p:sp>
+        <p:nvSpPr>
+          <p:cNvPr id="746" name="" descr="{&quot;isTemplate&quot;:true,&quot;type&quot;:&quot;text&quot;}"/>
+          <p:cNvSpPr txBox="1"/>
+          <p:nvPr/>
+        </p:nvSpPr>
+        <p:spPr>
+          <a:xfrm rot="0" flipH="0" flipV="0">
+            <a:off x="4848225" y="2705100"/>
+            <a:ext cx="2667000" cy="161925"/>
+          </a:xfrm>
+          <a:prstGeom prst="rect"/>
+        </p:spPr>
+        <p:txBody>
+          <a:bodyPr wrap="none" lIns="0" tIns="0" rIns="0" bIns="0"/>
+          <a:p>
+            <a:pPr>
+              <a:lnSpc>
+                <a:spcPct val="100000"/>
+              </a:lnSpc>
+            </a:pPr>
+            <a:r>
+              <a:rPr lang="en-US" sz="1050">
+                <a:solidFill>
+                  <a:srgbClr val="C5D4EA"/>
+                </a:solidFill>
+                <a:latin typeface="Microsoft YaHei"/>
+                <a:ea typeface="Microsoft YaHei"/>
+              </a:rPr>
+              <a:t>Individual Q&amp;A</a:t>
+            </a:r>
+            <a:endParaRPr/>
+          </a:p>
+        </p:txBody>
+      </p:sp>
+      <p:sp>
+        <p:nvSpPr>
+          <p:cNvPr id="747" name="" descr="{&quot;isTemplate&quot;:true,&quot;type&quot;:&quot;text&quot;}"/>
+          <p:cNvSpPr txBox="1"/>
+          <p:nvPr/>
+        </p:nvSpPr>
+        <p:spPr>
+          <a:xfrm rot="0" flipH="0" flipV="0">
+            <a:off x="7610475" y="2705100"/>
+            <a:ext cx="152400" cy="161925"/>
+          </a:xfrm>
+          <a:prstGeom prst="rect"/>
+        </p:spPr>
+        <p:txBody>
+          <a:bodyPr wrap="none" lIns="0" tIns="0" rIns="0" bIns="0"/>
+          <a:p>
+            <a:pPr>
+              <a:lnSpc>
+                <a:spcPct val="100000"/>
+              </a:lnSpc>
+            </a:pPr>
+            <a:r>
+              <a:rPr lang="en-US" sz="1050" b="1">
+                <a:solidFill>
+                  <a:srgbClr val="FFC107"/>
+                </a:solidFill>
+                <a:latin typeface="Microsoft YaHei"/>
+                <a:ea typeface="Microsoft YaHei"/>
+              </a:rPr>
+              <a:t>55</a:t>
+            </a:r>
+            <a:endParaRPr/>
+          </a:p>
+        </p:txBody>
+      </p:sp>
+      <p:sp>
+        <p:nvSpPr>
+          <p:cNvPr id="748" name=""/>
+          <p:cNvSpPr/>
+          <p:nvPr/>
+        </p:nvSpPr>
+        <p:spPr>
+          <a:xfrm rot="0" flipH="0" flipV="0">
+            <a:off x="4429125" y="2990850"/>
+            <a:ext cx="3333750" cy="419100"/>
+          </a:xfrm>
+          <a:custGeom>
+            <a:pathLst>
+              <a:path w="350" h="44">
+                <a:moveTo>
+                  <a:pt x="0" y="43"/>
+                </a:moveTo>
+                <a:lnTo>
+                  <a:pt x="350" y="43"/>
+                </a:lnTo>
+                <a:lnTo>
+                  <a:pt x="350" y="44"/>
+                </a:lnTo>
+                <a:lnTo>
+                  <a:pt x="0" y="44"/>
+                </a:lnTo>
+                <a:close/>
+              </a:path>
+            </a:pathLst>
+          </a:custGeom>
+          <a:solidFill>
+            <a:srgbClr val="2B5793"/>
+          </a:solidFill>
+          <a:ln/>
+        </p:spPr>
+        <p:txBody>
+          <a:bodyPr/>
+          <a:p/>
+        </p:txBody>
+      </p:sp>
+      <p:sp>
+        <p:nvSpPr>
+          <p:cNvPr id="749" name=""/>
+          <p:cNvSpPr/>
+          <p:nvPr/>
+        </p:nvSpPr>
+        <p:spPr>
+          <a:xfrm rot="0" flipH="0" flipV="0">
+            <a:off x="4429125" y="3086100"/>
+            <a:ext cx="323850" cy="209550"/>
+          </a:xfrm>
+          <a:prstGeom prst="roundRect">
+            <a:avLst>
+              <a:gd name="adj" fmla="val 22727"/>
+            </a:avLst>
+          </a:prstGeom>
+          <a:solidFill>
+            <a:srgbClr val="2B5793"/>
+          </a:solidFill>
+          <a:ln/>
+        </p:spPr>
+        <p:txBody>
+          <a:bodyPr/>
+          <a:p/>
+        </p:txBody>
+      </p:sp>
+      <p:sp>
+        <p:nvSpPr>
+          <p:cNvPr id="750" name="" descr="{&quot;isTemplate&quot;:true,&quot;type&quot;:&quot;text&quot;}"/>
+          <p:cNvSpPr txBox="1"/>
+          <p:nvPr/>
+        </p:nvSpPr>
+        <p:spPr>
+          <a:xfrm rot="0" flipH="0" flipV="0">
+            <a:off x="4524375" y="3124200"/>
+            <a:ext cx="142875" cy="142875"/>
+          </a:xfrm>
+          <a:prstGeom prst="rect"/>
+        </p:spPr>
+        <p:txBody>
+          <a:bodyPr wrap="none" lIns="0" tIns="0" rIns="0" bIns="0"/>
+          <a:p>
+            <a:pPr>
+              <a:lnSpc>
+                <a:spcPct val="100000"/>
+              </a:lnSpc>
+            </a:pPr>
+            <a:r>
+              <a:rPr lang="en-US" sz="900" b="1">
+                <a:solidFill>
+                  <a:srgbClr val="FFC107"/>
+                </a:solidFill>
+                <a:latin typeface="Microsoft YaHei"/>
+                <a:ea typeface="Microsoft YaHei"/>
+              </a:rPr>
+              <a:t>S3</a:t>
+            </a:r>
+            <a:endParaRPr/>
+          </a:p>
+        </p:txBody>
+      </p:sp>
+      <p:sp>
+        <p:nvSpPr>
           <p:cNvPr id="751" name="" descr="{&quot;isTemplate&quot;:true,&quot;type&quot;:&quot;text&quot;}"/>
           <p:cNvSpPr txBox="1"/>
           <p:nvPr/>
         </p:nvSpPr>
         <p:spPr>
           <a:xfrm rot="0" flipH="0" flipV="0">
-            <a:off x="4514850" y="2657475"/>
-            <a:ext cx="152400" cy="142875"/>
-          </a:xfrm>
-          <a:prstGeom prst="rect"/>
-        </p:spPr>
-        <p:txBody>
-          <a:bodyPr wrap="none" lIns="0" tIns="0" rIns="0" bIns="0"/>
-          <a:p>
-            <a:pPr>
-              <a:lnSpc>
-                <a:spcPct val="100000"/>
-              </a:lnSpc>
-            </a:pPr>
-            <a:r>
-              <a:rPr lang="en-US" sz="900" b="1">
+            <a:off x="4848225" y="3114675"/>
+            <a:ext cx="2667000" cy="161925"/>
+          </a:xfrm>
+          <a:prstGeom prst="rect"/>
+        </p:spPr>
+        <p:txBody>
+          <a:bodyPr wrap="none" lIns="0" tIns="0" rIns="0" bIns="0"/>
+          <a:p>
+            <a:pPr>
+              <a:lnSpc>
+                <a:spcPct val="100000"/>
+              </a:lnSpc>
+            </a:pPr>
+            <a:r>
+              <a:rPr lang="en-US" sz="1050">
+                <a:solidFill>
+                  <a:srgbClr val="C5D4EA"/>
+                </a:solidFill>
+                <a:latin typeface="Microsoft YaHei"/>
+                <a:ea typeface="Microsoft YaHei"/>
+              </a:rPr>
+              <a:t>English communication</a:t>
+            </a:r>
+            <a:endParaRPr/>
+          </a:p>
+        </p:txBody>
+      </p:sp>
+      <p:sp>
+        <p:nvSpPr>
+          <p:cNvPr id="752" name="" descr="{&quot;isTemplate&quot;:true,&quot;type&quot;:&quot;text&quot;}"/>
+          <p:cNvSpPr txBox="1"/>
+          <p:nvPr/>
+        </p:nvSpPr>
+        <p:spPr>
+          <a:xfrm rot="0" flipH="0" flipV="0">
+            <a:off x="7610475" y="3114675"/>
+            <a:ext cx="152400" cy="161925"/>
+          </a:xfrm>
+          <a:prstGeom prst="rect"/>
+        </p:spPr>
+        <p:txBody>
+          <a:bodyPr wrap="none" lIns="0" tIns="0" rIns="0" bIns="0"/>
+          <a:p>
+            <a:pPr>
+              <a:lnSpc>
+                <a:spcPct val="100000"/>
+              </a:lnSpc>
+            </a:pPr>
+            <a:r>
+              <a:rPr lang="en-US" sz="1050" b="1">
                 <a:solidFill>
                   <a:srgbClr val="FFC107"/>
                 </a:solidFill>
                 <a:latin typeface="Microsoft YaHei"/>
                 <a:ea typeface="Microsoft YaHei"/>
               </a:rPr>
-              <a:t>B2</a:t>
-            </a:r>
-            <a:endParaRPr/>
-          </a:p>
-        </p:txBody>
-      </p:sp>
-      <p:sp>
-        <p:nvSpPr>
-          <p:cNvPr id="752" name="" descr="{&quot;isTemplate&quot;:true,&quot;type&quot;:&quot;text&quot;}"/>
-          <p:cNvSpPr txBox="1"/>
-          <p:nvPr/>
-        </p:nvSpPr>
-        <p:spPr>
-          <a:xfrm rot="0" flipH="0" flipV="0">
-            <a:off x="4848225" y="2647950"/>
-            <a:ext cx="2543175" cy="161925"/>
-          </a:xfrm>
-          <a:prstGeom prst="rect"/>
-        </p:spPr>
-        <p:txBody>
-          <a:bodyPr wrap="none" lIns="0" tIns="0" rIns="0" bIns="0"/>
-          <a:p>
-            <a:pPr>
-              <a:lnSpc>
-                <a:spcPct val="100000"/>
-              </a:lnSpc>
-            </a:pPr>
-            <a:r>
-              <a:rPr lang="en-US" sz="1050">
-                <a:solidFill>
-                  <a:srgbClr val="C5D4EA"/>
-                </a:solidFill>
-                <a:latin typeface="Microsoft YaHei"/>
-                <a:ea typeface="Microsoft YaHei"/>
-              </a:rPr>
-              <a:t>Contribution &amp;amp; Git log</a:t>
-            </a:r>
-            <a:endParaRPr/>
-          </a:p>
-        </p:txBody>
-      </p:sp>
-      <p:sp>
-        <p:nvSpPr>
-          <p:cNvPr id="753" name="" descr="{&quot;isTemplate&quot;:true,&quot;type&quot;:&quot;text&quot;}"/>
-          <p:cNvSpPr txBox="1"/>
-          <p:nvPr/>
-        </p:nvSpPr>
-        <p:spPr>
-          <a:xfrm rot="0" flipH="0" flipV="0">
-            <a:off x="7486650" y="2647950"/>
-            <a:ext cx="276225" cy="161925"/>
-          </a:xfrm>
-          <a:prstGeom prst="rect"/>
-        </p:spPr>
-        <p:txBody>
-          <a:bodyPr wrap="none" lIns="0" tIns="0" rIns="0" bIns="0"/>
-          <a:p>
-            <a:pPr>
-              <a:lnSpc>
-                <a:spcPct val="100000"/>
-              </a:lnSpc>
-            </a:pPr>
-            <a:r>
-              <a:rPr lang="en-US" sz="1050" b="1">
-                <a:solidFill>
-                  <a:srgbClr val="FFC107"/>
-                </a:solidFill>
-                <a:latin typeface="Microsoft YaHei"/>
-                <a:ea typeface="Microsoft YaHei"/>
-              </a:rPr>
-              <a:t>15%</a:t>
-            </a:r>
-            <a:endParaRPr/>
-          </a:p>
+              <a:t>10</a:t>
+            </a:r>
+            <a:endParaRPr/>
+          </a:p>
+        </p:txBody>
+      </p:sp>
+      <p:sp>
+        <p:nvSpPr>
+          <p:cNvPr id="753" name=""/>
+          <p:cNvSpPr/>
+          <p:nvPr/>
+        </p:nvSpPr>
+        <p:spPr>
+          <a:xfrm rot="0" flipH="0" flipV="0">
+            <a:off x="4429125" y="3400425"/>
+            <a:ext cx="3333750" cy="419100"/>
+          </a:xfrm>
+          <a:custGeom>
+            <a:pathLst>
+              <a:path w="350" h="44">
+                <a:moveTo>
+                  <a:pt x="0" y="43"/>
+                </a:moveTo>
+                <a:lnTo>
+                  <a:pt x="350" y="43"/>
+                </a:lnTo>
+                <a:lnTo>
+                  <a:pt x="350" y="44"/>
+                </a:lnTo>
+                <a:lnTo>
+                  <a:pt x="0" y="44"/>
+                </a:lnTo>
+                <a:close/>
+              </a:path>
+            </a:pathLst>
+          </a:custGeom>
+          <a:solidFill>
+            <a:srgbClr val="2B5793"/>
+          </a:solidFill>
+          <a:ln/>
+        </p:spPr>
+        <p:txBody>
+          <a:bodyPr/>
+          <a:p/>
         </p:txBody>
       </p:sp>
       <p:sp>
@@ -28882,7 +28906,138 @@
         </p:nvSpPr>
         <p:spPr>
           <a:xfrm rot="0" flipH="0" flipV="0">
-            <a:off x="4429125" y="3028950"/>
+            <a:off x="4429125" y="3495675"/>
+            <a:ext cx="323850" cy="209550"/>
+          </a:xfrm>
+          <a:prstGeom prst="roundRect">
+            <a:avLst>
+              <a:gd name="adj" fmla="val 22727"/>
+            </a:avLst>
+          </a:prstGeom>
+          <a:solidFill>
+            <a:srgbClr val="2B5793"/>
+          </a:solidFill>
+          <a:ln/>
+        </p:spPr>
+        <p:txBody>
+          <a:bodyPr/>
+          <a:p/>
+        </p:txBody>
+      </p:sp>
+      <p:sp>
+        <p:nvSpPr>
+          <p:cNvPr id="755" name="" descr="{&quot;isTemplate&quot;:true,&quot;type&quot;:&quot;text&quot;}"/>
+          <p:cNvSpPr txBox="1"/>
+          <p:nvPr/>
+        </p:nvSpPr>
+        <p:spPr>
+          <a:xfrm rot="0" flipH="0" flipV="0">
+            <a:off x="4524375" y="3533775"/>
+            <a:ext cx="142875" cy="142875"/>
+          </a:xfrm>
+          <a:prstGeom prst="rect"/>
+        </p:spPr>
+        <p:txBody>
+          <a:bodyPr wrap="none" lIns="0" tIns="0" rIns="0" bIns="0"/>
+          <a:p>
+            <a:pPr>
+              <a:lnSpc>
+                <a:spcPct val="100000"/>
+              </a:lnSpc>
+            </a:pPr>
+            <a:r>
+              <a:rPr lang="en-US" sz="900" b="1">
+                <a:solidFill>
+                  <a:srgbClr val="FFC107"/>
+                </a:solidFill>
+                <a:latin typeface="Microsoft YaHei"/>
+                <a:ea typeface="Microsoft YaHei"/>
+              </a:rPr>
+              <a:t>S4</a:t>
+            </a:r>
+            <a:endParaRPr/>
+          </a:p>
+        </p:txBody>
+      </p:sp>
+      <p:sp>
+        <p:nvSpPr>
+          <p:cNvPr id="756" name="" descr="{&quot;isTemplate&quot;:true,&quot;type&quot;:&quot;text&quot;}"/>
+          <p:cNvSpPr txBox="1"/>
+          <p:nvPr/>
+        </p:nvSpPr>
+        <p:spPr>
+          <a:xfrm rot="0" flipH="0" flipV="0">
+            <a:off x="4848225" y="3524250"/>
+            <a:ext cx="2743200" cy="161925"/>
+          </a:xfrm>
+          <a:prstGeom prst="rect"/>
+        </p:spPr>
+        <p:txBody>
+          <a:bodyPr wrap="none" lIns="0" tIns="0" rIns="0" bIns="0"/>
+          <a:p>
+            <a:pPr>
+              <a:lnSpc>
+                <a:spcPct val="100000"/>
+              </a:lnSpc>
+            </a:pPr>
+            <a:r>
+              <a:rPr lang="en-US" sz="1050">
+                <a:solidFill>
+                  <a:srgbClr val="C5D4EA"/>
+                </a:solidFill>
+                <a:latin typeface="Microsoft YaHei"/>
+                <a:ea typeface="Microsoft YaHei"/>
+              </a:rPr>
+              <a:t>Reflection &amp; contribution report</a:t>
+            </a:r>
+            <a:endParaRPr/>
+          </a:p>
+        </p:txBody>
+      </p:sp>
+      <p:sp>
+        <p:nvSpPr>
+          <p:cNvPr id="757" name="" descr="{&quot;isTemplate&quot;:true,&quot;type&quot;:&quot;text&quot;}"/>
+          <p:cNvSpPr txBox="1"/>
+          <p:nvPr/>
+        </p:nvSpPr>
+        <p:spPr>
+          <a:xfrm rot="0" flipH="0" flipV="0">
+            <a:off x="7686675" y="3524250"/>
+            <a:ext cx="76200" cy="161925"/>
+          </a:xfrm>
+          <a:prstGeom prst="rect"/>
+        </p:spPr>
+        <p:txBody>
+          <a:bodyPr wrap="none" lIns="0" tIns="0" rIns="0" bIns="0"/>
+          <a:p>
+            <a:pPr>
+              <a:lnSpc>
+                <a:spcPct val="100000"/>
+              </a:lnSpc>
+            </a:pPr>
+            <a:r>
+              <a:rPr lang="en-US" sz="1050" b="1">
+                <a:solidFill>
+                  <a:srgbClr val="FFC107"/>
+                </a:solidFill>
+                <a:latin typeface="Microsoft YaHei"/>
+                <a:ea typeface="Microsoft YaHei"/>
+              </a:rPr>
+              <a:t>5</a:t>
+            </a:r>
+            <a:endParaRPr/>
+          </a:p>
+        </p:txBody>
+      </p:sp>
+      <p:sp>
+        <p:nvSpPr>
+          <p:cNvPr id="758" name=""/>
+          <p:cNvSpPr/>
+          <p:nvPr/>
+        </p:nvSpPr>
+        <p:spPr>
+          <a:xfrm rot="0" flipH="0" flipV="0">
+            <a:off x="4429125" y="3924300"/>
             <a:ext cx="3333750" cy="676275"/>
           </a:xfrm>
           <a:prstGeom prst="roundRect">
@@ -28902,13 +29057,13 @@
       </p:sp>
       <p:sp>
         <p:nvSpPr>
-          <p:cNvPr id="755" name="" descr="{&quot;isTemplate&quot;:true,&quot;type&quot;:&quot;text&quot;}"/>
-          <p:cNvSpPr txBox="1"/>
-          <p:nvPr/>
-        </p:nvSpPr>
-        <p:spPr>
-          <a:xfrm rot="0" flipH="0" flipV="0">
-            <a:off x="4562475" y="3143250"/>
+          <p:cNvPr id="759" name="" descr="{&quot;isTemplate&quot;:true,&quot;type&quot;:&quot;text&quot;}"/>
+          <p:cNvSpPr txBox="1"/>
+          <p:nvPr/>
+        </p:nvSpPr>
+        <p:spPr>
+          <a:xfrm rot="0" flipH="0" flipV="0">
+            <a:off x="4562475" y="4038600"/>
             <a:ext cx="3067050" cy="447675"/>
           </a:xfrm>
           <a:prstGeom prst="rect"/>
@@ -28959,7 +29114,7 @@
       </p:sp>
       <p:sp>
         <p:nvSpPr>
-          <p:cNvPr id="756" name=""/>
+          <p:cNvPr id="760" name=""/>
           <p:cNvSpPr/>
           <p:nvPr/>
         </p:nvSpPr>
@@ -28990,14 +29145,14 @@
       </p:sp>
       <p:sp>
         <p:nvSpPr>
-          <p:cNvPr id="757" name="" descr="{&quot;isTemplate&quot;:true,&quot;type&quot;:&quot;text&quot;}"/>
+          <p:cNvPr id="761" name="" descr="{&quot;isTemplate&quot;:true,&quot;type&quot;:&quot;text&quot;}"/>
           <p:cNvSpPr txBox="1"/>
           <p:nvPr/>
         </p:nvSpPr>
         <p:spPr>
           <a:xfrm rot="0" flipH="0" flipV="0">
             <a:off x="8315325" y="1600200"/>
-            <a:ext cx="428625" cy="457200"/>
+            <a:ext cx="438150" cy="457200"/>
           </a:xfrm>
           <a:prstGeom prst="rect"/>
         </p:spPr>
@@ -29017,22 +29172,22 @@
                 <a:latin typeface="Microsoft YaHei"/>
                 <a:ea typeface="Microsoft YaHei"/>
               </a:rPr>
-              <a:t>10</a:t>
-            </a:r>
-            <a:endParaRPr/>
-          </a:p>
-        </p:txBody>
-      </p:sp>
-      <p:sp>
-        <p:nvSpPr>
-          <p:cNvPr id="758" name="" descr="{&quot;isTemplate&quot;:true,&quot;type&quot;:&quot;text&quot;}"/>
-          <p:cNvSpPr txBox="1"/>
-          <p:nvPr/>
-        </p:nvSpPr>
-        <p:spPr>
-          <a:xfrm rot="0" flipH="0" flipV="0">
-            <a:off x="8743950" y="1600200"/>
-            <a:ext cx="171450" cy="457200"/>
+              <a:t>+5</a:t>
+            </a:r>
+            <a:endParaRPr/>
+          </a:p>
+        </p:txBody>
+      </p:sp>
+      <p:sp>
+        <p:nvSpPr>
+          <p:cNvPr id="762" name="" descr="{&quot;isTemplate&quot;:true,&quot;type&quot;:&quot;text&quot;}"/>
+          <p:cNvSpPr txBox="1"/>
+          <p:nvPr/>
+        </p:nvSpPr>
+        <p:spPr>
+          <a:xfrm rot="0" flipH="0" flipV="0">
+            <a:off x="8753475" y="1600200"/>
+            <a:ext cx="438150" cy="457200"/>
           </a:xfrm>
           <a:prstGeom prst="rect"/>
         </p:spPr>
@@ -29052,22 +29207,22 @@
                 <a:latin typeface="Microsoft YaHei"/>
                 <a:ea typeface="Microsoft YaHei"/>
               </a:rPr>
-              <a:t>%</a:t>
-            </a:r>
-            <a:endParaRPr/>
-          </a:p>
-        </p:txBody>
-      </p:sp>
-      <p:sp>
-        <p:nvSpPr>
-          <p:cNvPr id="759" name="" descr="{&quot;isTemplate&quot;:true,&quot;type&quot;:&quot;text&quot;}"/>
-          <p:cNvSpPr txBox="1"/>
-          <p:nvPr/>
-        </p:nvSpPr>
-        <p:spPr>
-          <a:xfrm rot="0" flipH="0" flipV="0">
-            <a:off x="9010650" y="1600200"/>
-            <a:ext cx="533400" cy="457200"/>
+              <a:t> max</a:t>
+            </a:r>
+            <a:endParaRPr/>
+          </a:p>
+        </p:txBody>
+      </p:sp>
+      <p:sp>
+        <p:nvSpPr>
+          <p:cNvPr id="763" name="" descr="{&quot;isTemplate&quot;:true,&quot;type&quot;:&quot;text&quot;}"/>
+          <p:cNvSpPr txBox="1"/>
+          <p:nvPr/>
+        </p:nvSpPr>
+        <p:spPr>
+          <a:xfrm rot="0" flipH="0" flipV="0">
+            <a:off x="9286875" y="1600200"/>
+            <a:ext cx="1323975" cy="457200"/>
           </a:xfrm>
           <a:prstGeom prst="rect"/>
         </p:spPr>
@@ -29087,37 +29242,37 @@
                 <a:latin typeface="Microsoft YaHei"/>
                 <a:ea typeface="Microsoft YaHei"/>
               </a:rPr>
-              <a:t>Bonus</a:t>
-            </a:r>
-            <a:endParaRPr/>
-          </a:p>
-        </p:txBody>
-      </p:sp>
-      <p:sp>
-        <p:nvSpPr>
-          <p:cNvPr id="760" name=""/>
+              <a:t>Bonus · cap 100</a:t>
+            </a:r>
+            <a:endParaRPr/>
+          </a:p>
+        </p:txBody>
+      </p:sp>
+      <p:sp>
+        <p:nvSpPr>
+          <p:cNvPr id="764" name=""/>
           <p:cNvSpPr/>
           <p:nvPr/>
         </p:nvSpPr>
         <p:spPr>
           <a:xfrm rot="0" flipH="0" flipV="0">
             <a:off x="8315325" y="2171700"/>
-            <a:ext cx="3324225" cy="342900"/>
+            <a:ext cx="3324225" cy="419100"/>
           </a:xfrm>
           <a:custGeom>
             <a:pathLst>
-              <a:path w="349" h="36">
+              <a:path w="349" h="44">
                 <a:moveTo>
-                  <a:pt x="0" y="35"/>
+                  <a:pt x="0" y="43"/>
                 </a:moveTo>
                 <a:lnTo>
-                  <a:pt x="349" y="35"/>
+                  <a:pt x="349" y="43"/>
                 </a:lnTo>
                 <a:lnTo>
-                  <a:pt x="349" y="36"/>
+                  <a:pt x="349" y="44"/>
                 </a:lnTo>
                 <a:lnTo>
-                  <a:pt x="0" y="36"/>
+                  <a:pt x="0" y="44"/>
                 </a:lnTo>
                 <a:close/>
               </a:path>
@@ -29135,13 +29290,13 @@
       </p:sp>
       <p:sp>
         <p:nvSpPr>
-          <p:cNvPr id="761" name=""/>
+          <p:cNvPr id="765" name=""/>
           <p:cNvSpPr/>
           <p:nvPr/>
         </p:nvSpPr>
         <p:spPr>
           <a:xfrm rot="0" flipH="0" flipV="0">
-            <a:off x="8315325" y="2228850"/>
+            <a:off x="8315325" y="2266950"/>
             <a:ext cx="323850" cy="209550"/>
           </a:xfrm>
           <a:prstGeom prst="roundRect">
@@ -29161,13 +29316,13 @@
       </p:sp>
       <p:sp>
         <p:nvSpPr>
-          <p:cNvPr id="762" name="" descr="{&quot;isTemplate&quot;:true,&quot;type&quot;:&quot;text&quot;}"/>
-          <p:cNvSpPr txBox="1"/>
-          <p:nvPr/>
-        </p:nvSpPr>
-        <p:spPr>
-          <a:xfrm rot="0" flipH="0" flipV="0">
-            <a:off x="8401050" y="2266950"/>
+          <p:cNvPr id="766" name="" descr="{&quot;isTemplate&quot;:true,&quot;type&quot;:&quot;text&quot;}"/>
+          <p:cNvSpPr txBox="1"/>
+          <p:nvPr/>
+        </p:nvSpPr>
+        <p:spPr>
+          <a:xfrm rot="0" flipH="0" flipV="0">
+            <a:off x="8401050" y="2305050"/>
             <a:ext cx="152400" cy="142875"/>
           </a:xfrm>
           <a:prstGeom prst="rect"/>
@@ -29196,14 +29351,14 @@
       </p:sp>
       <p:sp>
         <p:nvSpPr>
-          <p:cNvPr id="763" name="" descr="{&quot;isTemplate&quot;:true,&quot;type&quot;:&quot;text&quot;}"/>
-          <p:cNvSpPr txBox="1"/>
-          <p:nvPr/>
-        </p:nvSpPr>
-        <p:spPr>
-          <a:xfrm rot="0" flipH="0" flipV="0">
-            <a:off x="8734425" y="2257425"/>
-            <a:ext cx="2266950" cy="161925"/>
+          <p:cNvPr id="767" name="" descr="{&quot;isTemplate&quot;:true,&quot;type&quot;:&quot;text&quot;}"/>
+          <p:cNvSpPr txBox="1"/>
+          <p:nvPr/>
+        </p:nvSpPr>
+        <p:spPr>
+          <a:xfrm rot="0" flipH="0" flipV="0">
+            <a:off x="8734425" y="2295525"/>
+            <a:ext cx="2667000" cy="161925"/>
           </a:xfrm>
           <a:prstGeom prst="rect"/>
         </p:spPr>
@@ -29231,14 +29386,14 @@
       </p:sp>
       <p:sp>
         <p:nvSpPr>
-          <p:cNvPr id="764" name="" descr="{&quot;isTemplate&quot;:true,&quot;type&quot;:&quot;text&quot;}"/>
-          <p:cNvSpPr txBox="1"/>
-          <p:nvPr/>
-        </p:nvSpPr>
-        <p:spPr>
-          <a:xfrm rot="0" flipH="0" flipV="0">
-            <a:off x="11096625" y="2257425"/>
-            <a:ext cx="542925" cy="152400"/>
+          <p:cNvPr id="768" name="" descr="{&quot;isTemplate&quot;:true,&quot;type&quot;:&quot;text&quot;}"/>
+          <p:cNvSpPr txBox="1"/>
+          <p:nvPr/>
+        </p:nvSpPr>
+        <p:spPr>
+          <a:xfrm rot="0" flipH="0" flipV="0">
+            <a:off x="11496675" y="2295525"/>
+            <a:ext cx="142875" cy="152400"/>
           </a:xfrm>
           <a:prstGeom prst="rect"/>
         </p:spPr>
@@ -29258,37 +29413,37 @@
                 <a:latin typeface="Microsoft YaHei"/>
                 <a:ea typeface="Microsoft YaHei"/>
               </a:rPr>
-              <a:t>+6% max</a:t>
-            </a:r>
-            <a:endParaRPr/>
-          </a:p>
-        </p:txBody>
-      </p:sp>
-      <p:sp>
-        <p:nvSpPr>
-          <p:cNvPr id="765" name=""/>
+              <a:t>+2</a:t>
+            </a:r>
+            <a:endParaRPr/>
+          </a:p>
+        </p:txBody>
+      </p:sp>
+      <p:sp>
+        <p:nvSpPr>
+          <p:cNvPr id="769" name=""/>
           <p:cNvSpPr/>
           <p:nvPr/>
         </p:nvSpPr>
         <p:spPr>
           <a:xfrm rot="0" flipH="0" flipV="0">
-            <a:off x="8315325" y="2505075"/>
-            <a:ext cx="3324225" cy="342900"/>
+            <a:off x="8315325" y="2581275"/>
+            <a:ext cx="3324225" cy="419100"/>
           </a:xfrm>
           <a:custGeom>
             <a:pathLst>
-              <a:path w="349" h="36">
+              <a:path w="349" h="44">
                 <a:moveTo>
-                  <a:pt x="0" y="35"/>
+                  <a:pt x="0" y="43"/>
                 </a:moveTo>
                 <a:lnTo>
-                  <a:pt x="349" y="35"/>
+                  <a:pt x="349" y="43"/>
                 </a:lnTo>
                 <a:lnTo>
-                  <a:pt x="349" y="36"/>
+                  <a:pt x="349" y="44"/>
                 </a:lnTo>
                 <a:lnTo>
-                  <a:pt x="0" y="36"/>
+                  <a:pt x="0" y="44"/>
                 </a:lnTo>
                 <a:close/>
               </a:path>
@@ -29306,13 +29461,13 @@
       </p:sp>
       <p:sp>
         <p:nvSpPr>
-          <p:cNvPr id="766" name=""/>
+          <p:cNvPr id="770" name=""/>
           <p:cNvSpPr/>
           <p:nvPr/>
         </p:nvSpPr>
         <p:spPr>
           <a:xfrm rot="0" flipH="0" flipV="0">
-            <a:off x="8315325" y="2562225"/>
+            <a:off x="8315325" y="2676525"/>
             <a:ext cx="323850" cy="209550"/>
           </a:xfrm>
           <a:prstGeom prst="roundRect">
@@ -29332,13 +29487,13 @@
       </p:sp>
       <p:sp>
         <p:nvSpPr>
-          <p:cNvPr id="767" name="" descr="{&quot;isTemplate&quot;:true,&quot;type&quot;:&quot;text&quot;}"/>
-          <p:cNvSpPr txBox="1"/>
-          <p:nvPr/>
-        </p:nvSpPr>
-        <p:spPr>
-          <a:xfrm rot="0" flipH="0" flipV="0">
-            <a:off x="8401050" y="2600325"/>
+          <p:cNvPr id="771" name="" descr="{&quot;isTemplate&quot;:true,&quot;type&quot;:&quot;text&quot;}"/>
+          <p:cNvSpPr txBox="1"/>
+          <p:nvPr/>
+        </p:nvSpPr>
+        <p:spPr>
+          <a:xfrm rot="0" flipH="0" flipV="0">
+            <a:off x="8401050" y="2714625"/>
             <a:ext cx="152400" cy="142875"/>
           </a:xfrm>
           <a:prstGeom prst="rect"/>
@@ -29367,14 +29522,14 @@
       </p:sp>
       <p:sp>
         <p:nvSpPr>
-          <p:cNvPr id="768" name="" descr="{&quot;isTemplate&quot;:true,&quot;type&quot;:&quot;text&quot;}"/>
-          <p:cNvSpPr txBox="1"/>
-          <p:nvPr/>
-        </p:nvSpPr>
-        <p:spPr>
-          <a:xfrm rot="0" flipH="0" flipV="0">
-            <a:off x="8734425" y="2590800"/>
-            <a:ext cx="2552700" cy="161925"/>
+          <p:cNvPr id="772" name="" descr="{&quot;isTemplate&quot;:true,&quot;type&quot;:&quot;text&quot;}"/>
+          <p:cNvSpPr txBox="1"/>
+          <p:nvPr/>
+        </p:nvSpPr>
+        <p:spPr>
+          <a:xfrm rot="0" flipH="0" flipV="0">
+            <a:off x="8734425" y="2705100"/>
+            <a:ext cx="2667000" cy="161925"/>
           </a:xfrm>
           <a:prstGeom prst="rect"/>
         </p:spPr>
@@ -29402,14 +29557,14 @@
       </p:sp>
       <p:sp>
         <p:nvSpPr>
-          <p:cNvPr id="769" name="" descr="{&quot;isTemplate&quot;:true,&quot;type&quot;:&quot;text&quot;}"/>
-          <p:cNvSpPr txBox="1"/>
-          <p:nvPr/>
-        </p:nvSpPr>
-        <p:spPr>
-          <a:xfrm rot="0" flipH="0" flipV="0">
-            <a:off x="11382375" y="2590800"/>
-            <a:ext cx="257175" cy="152400"/>
+          <p:cNvPr id="773" name="" descr="{&quot;isTemplate&quot;:true,&quot;type&quot;:&quot;text&quot;}"/>
+          <p:cNvSpPr txBox="1"/>
+          <p:nvPr/>
+        </p:nvSpPr>
+        <p:spPr>
+          <a:xfrm rot="0" flipH="0" flipV="0">
+            <a:off x="11496675" y="2705100"/>
+            <a:ext cx="142875" cy="152400"/>
           </a:xfrm>
           <a:prstGeom prst="rect"/>
         </p:spPr>
@@ -29429,37 +29584,37 @@
                 <a:latin typeface="Microsoft YaHei"/>
                 <a:ea typeface="Microsoft YaHei"/>
               </a:rPr>
-              <a:t>+4%</a:t>
-            </a:r>
-            <a:endParaRPr/>
-          </a:p>
-        </p:txBody>
-      </p:sp>
-      <p:sp>
-        <p:nvSpPr>
-          <p:cNvPr id="770" name=""/>
+              <a:t>+2</a:t>
+            </a:r>
+            <a:endParaRPr/>
+          </a:p>
+        </p:txBody>
+      </p:sp>
+      <p:sp>
+        <p:nvSpPr>
+          <p:cNvPr id="774" name=""/>
           <p:cNvSpPr/>
           <p:nvPr/>
         </p:nvSpPr>
         <p:spPr>
           <a:xfrm rot="0" flipH="0" flipV="0">
-            <a:off x="8315325" y="2838450"/>
-            <a:ext cx="3324225" cy="342900"/>
+            <a:off x="8315325" y="2990850"/>
+            <a:ext cx="3324225" cy="419100"/>
           </a:xfrm>
           <a:custGeom>
             <a:pathLst>
-              <a:path w="349" h="36">
+              <a:path w="349" h="44">
                 <a:moveTo>
-                  <a:pt x="0" y="35"/>
+                  <a:pt x="0" y="43"/>
                 </a:moveTo>
                 <a:lnTo>
-                  <a:pt x="349" y="35"/>
+                  <a:pt x="349" y="43"/>
                 </a:lnTo>
                 <a:lnTo>
-                  <a:pt x="349" y="36"/>
+                  <a:pt x="349" y="44"/>
                 </a:lnTo>
                 <a:lnTo>
-                  <a:pt x="0" y="36"/>
+                  <a:pt x="0" y="44"/>
                 </a:lnTo>
                 <a:close/>
               </a:path>
@@ -29477,13 +29632,13 @@
       </p:sp>
       <p:sp>
         <p:nvSpPr>
-          <p:cNvPr id="771" name=""/>
+          <p:cNvPr id="775" name=""/>
           <p:cNvSpPr/>
           <p:nvPr/>
         </p:nvSpPr>
         <p:spPr>
           <a:xfrm rot="0" flipH="0" flipV="0">
-            <a:off x="8315325" y="2895600"/>
+            <a:off x="8315325" y="3086100"/>
             <a:ext cx="323850" cy="209550"/>
           </a:xfrm>
           <a:prstGeom prst="roundRect">
@@ -29503,13 +29658,13 @@
       </p:sp>
       <p:sp>
         <p:nvSpPr>
-          <p:cNvPr id="772" name="" descr="{&quot;isTemplate&quot;:true,&quot;type&quot;:&quot;text&quot;}"/>
-          <p:cNvSpPr txBox="1"/>
-          <p:nvPr/>
-        </p:nvSpPr>
-        <p:spPr>
-          <a:xfrm rot="0" flipH="0" flipV="0">
-            <a:off x="8401050" y="2933700"/>
+          <p:cNvPr id="776" name="" descr="{&quot;isTemplate&quot;:true,&quot;type&quot;:&quot;text&quot;}"/>
+          <p:cNvSpPr txBox="1"/>
+          <p:nvPr/>
+        </p:nvSpPr>
+        <p:spPr>
+          <a:xfrm rot="0" flipH="0" flipV="0">
+            <a:off x="8401050" y="3124200"/>
             <a:ext cx="152400" cy="142875"/>
           </a:xfrm>
           <a:prstGeom prst="rect"/>
@@ -29538,14 +29693,14 @@
       </p:sp>
       <p:sp>
         <p:nvSpPr>
-          <p:cNvPr id="773" name="" descr="{&quot;isTemplate&quot;:true,&quot;type&quot;:&quot;text&quot;}"/>
-          <p:cNvSpPr txBox="1"/>
-          <p:nvPr/>
-        </p:nvSpPr>
-        <p:spPr>
-          <a:xfrm rot="0" flipH="0" flipV="0">
-            <a:off x="8734425" y="2924175"/>
-            <a:ext cx="2552700" cy="161925"/>
+          <p:cNvPr id="777" name="" descr="{&quot;isTemplate&quot;:true,&quot;type&quot;:&quot;text&quot;}"/>
+          <p:cNvSpPr txBox="1"/>
+          <p:nvPr/>
+        </p:nvSpPr>
+        <p:spPr>
+          <a:xfrm rot="0" flipH="0" flipV="0">
+            <a:off x="8734425" y="3114675"/>
+            <a:ext cx="2667000" cy="161925"/>
           </a:xfrm>
           <a:prstGeom prst="rect"/>
         </p:spPr>
@@ -29573,14 +29728,14 @@
       </p:sp>
       <p:sp>
         <p:nvSpPr>
-          <p:cNvPr id="774" name="" descr="{&quot;isTemplate&quot;:true,&quot;type&quot;:&quot;text&quot;}"/>
-          <p:cNvSpPr txBox="1"/>
-          <p:nvPr/>
-        </p:nvSpPr>
-        <p:spPr>
-          <a:xfrm rot="0" flipH="0" flipV="0">
-            <a:off x="11382375" y="2924175"/>
-            <a:ext cx="257175" cy="152400"/>
+          <p:cNvPr id="778" name="" descr="{&quot;isTemplate&quot;:true,&quot;type&quot;:&quot;text&quot;}"/>
+          <p:cNvSpPr txBox="1"/>
+          <p:nvPr/>
+        </p:nvSpPr>
+        <p:spPr>
+          <a:xfrm rot="0" flipH="0" flipV="0">
+            <a:off x="11496675" y="3114675"/>
+            <a:ext cx="142875" cy="152400"/>
           </a:xfrm>
           <a:prstGeom prst="rect"/>
         </p:spPr>
@@ -29600,192 +29755,21 @@
                 <a:latin typeface="Microsoft YaHei"/>
                 <a:ea typeface="Microsoft YaHei"/>
               </a:rPr>
-              <a:t>+2%</a:t>
-            </a:r>
-            <a:endParaRPr/>
-          </a:p>
-        </p:txBody>
-      </p:sp>
-      <p:sp>
-        <p:nvSpPr>
-          <p:cNvPr id="775" name=""/>
+              <a:t>+1</a:t>
+            </a:r>
+            <a:endParaRPr/>
+          </a:p>
+        </p:txBody>
+      </p:sp>
+      <p:sp>
+        <p:nvSpPr>
+          <p:cNvPr id="779" name=""/>
           <p:cNvSpPr/>
           <p:nvPr/>
         </p:nvSpPr>
         <p:spPr>
           <a:xfrm rot="0" flipH="0" flipV="0">
-            <a:off x="8315325" y="3171825"/>
-            <a:ext cx="3324225" cy="342900"/>
-          </a:xfrm>
-          <a:custGeom>
-            <a:pathLst>
-              <a:path w="349" h="36">
-                <a:moveTo>
-                  <a:pt x="0" y="35"/>
-                </a:moveTo>
-                <a:lnTo>
-                  <a:pt x="349" y="35"/>
-                </a:lnTo>
-                <a:lnTo>
-                  <a:pt x="349" y="36"/>
-                </a:lnTo>
-                <a:lnTo>
-                  <a:pt x="0" y="36"/>
-                </a:lnTo>
-                <a:close/>
-              </a:path>
-            </a:pathLst>
-          </a:custGeom>
-          <a:solidFill>
-            <a:srgbClr val="E5E7EB"/>
-          </a:solidFill>
-          <a:ln/>
-        </p:spPr>
-        <p:txBody>
-          <a:bodyPr/>
-          <a:p/>
-        </p:txBody>
-      </p:sp>
-      <p:sp>
-        <p:nvSpPr>
-          <p:cNvPr id="776" name=""/>
-          <p:cNvSpPr/>
-          <p:nvPr/>
-        </p:nvSpPr>
-        <p:spPr>
-          <a:xfrm rot="0" flipH="0" flipV="0">
-            <a:off x="8315325" y="3228975"/>
-            <a:ext cx="323850" cy="209550"/>
-          </a:xfrm>
-          <a:prstGeom prst="roundRect">
-            <a:avLst>
-              <a:gd name="adj" fmla="val 22727"/>
-            </a:avLst>
-          </a:prstGeom>
-          <a:solidFill>
-            <a:srgbClr val="E8EFF8"/>
-          </a:solidFill>
-          <a:ln/>
-        </p:spPr>
-        <p:txBody>
-          <a:bodyPr/>
-          <a:p/>
-        </p:txBody>
-      </p:sp>
-      <p:sp>
-        <p:nvSpPr>
-          <p:cNvPr id="777" name="" descr="{&quot;isTemplate&quot;:true,&quot;type&quot;:&quot;text&quot;}"/>
-          <p:cNvSpPr txBox="1"/>
-          <p:nvPr/>
-        </p:nvSpPr>
-        <p:spPr>
-          <a:xfrm rot="0" flipH="0" flipV="0">
-            <a:off x="8401050" y="3267075"/>
-            <a:ext cx="152400" cy="142875"/>
-          </a:xfrm>
-          <a:prstGeom prst="rect"/>
-        </p:spPr>
-        <p:txBody>
-          <a:bodyPr wrap="none" lIns="0" tIns="0" rIns="0" bIns="0"/>
-          <a:p>
-            <a:pPr>
-              <a:lnSpc>
-                <a:spcPct val="100000"/>
-              </a:lnSpc>
-            </a:pPr>
-            <a:r>
-              <a:rPr lang="en-US" sz="900" b="1">
-                <a:solidFill>
-                  <a:srgbClr val="1E4FA8"/>
-                </a:solidFill>
-                <a:latin typeface="Microsoft YaHei"/>
-                <a:ea typeface="Microsoft YaHei"/>
-              </a:rPr>
-              <a:t>C4</a:t>
-            </a:r>
-            <a:endParaRPr/>
-          </a:p>
-        </p:txBody>
-      </p:sp>
-      <p:sp>
-        <p:nvSpPr>
-          <p:cNvPr id="778" name="" descr="{&quot;isTemplate&quot;:true,&quot;type&quot;:&quot;text&quot;}"/>
-          <p:cNvSpPr txBox="1"/>
-          <p:nvPr/>
-        </p:nvSpPr>
-        <p:spPr>
-          <a:xfrm rot="0" flipH="0" flipV="0">
-            <a:off x="8734425" y="3257550"/>
-            <a:ext cx="2552700" cy="161925"/>
-          </a:xfrm>
-          <a:prstGeom prst="rect"/>
-        </p:spPr>
-        <p:txBody>
-          <a:bodyPr wrap="none" lIns="0" tIns="0" rIns="0" bIns="0"/>
-          <a:p>
-            <a:pPr>
-              <a:lnSpc>
-                <a:spcPct val="100000"/>
-              </a:lnSpc>
-            </a:pPr>
-            <a:r>
-              <a:rPr lang="en-US" sz="1050">
-                <a:solidFill>
-                  <a:srgbClr val="4A5568"/>
-                </a:solidFill>
-                <a:latin typeface="Microsoft YaHei"/>
-                <a:ea typeface="Microsoft YaHei"/>
-              </a:rPr>
-              <a:t>Sharp review questions</a:t>
-            </a:r>
-            <a:endParaRPr/>
-          </a:p>
-        </p:txBody>
-      </p:sp>
-      <p:sp>
-        <p:nvSpPr>
-          <p:cNvPr id="779" name="" descr="{&quot;isTemplate&quot;:true,&quot;type&quot;:&quot;text&quot;}"/>
-          <p:cNvSpPr txBox="1"/>
-          <p:nvPr/>
-        </p:nvSpPr>
-        <p:spPr>
-          <a:xfrm rot="0" flipH="0" flipV="0">
-            <a:off x="11382375" y="3257550"/>
-            <a:ext cx="257175" cy="152400"/>
-          </a:xfrm>
-          <a:prstGeom prst="rect"/>
-        </p:spPr>
-        <p:txBody>
-          <a:bodyPr wrap="none" lIns="0" tIns="0" rIns="0" bIns="0"/>
-          <a:p>
-            <a:pPr>
-              <a:lnSpc>
-                <a:spcPct val="100000"/>
-              </a:lnSpc>
-            </a:pPr>
-            <a:r>
-              <a:rPr lang="en-US" sz="975" b="1">
-                <a:solidFill>
-                  <a:srgbClr val="D9534F"/>
-                </a:solidFill>
-                <a:latin typeface="Microsoft YaHei"/>
-                <a:ea typeface="Microsoft YaHei"/>
-              </a:rPr>
-              <a:t>+2%</a:t>
-            </a:r>
-            <a:endParaRPr/>
-          </a:p>
-        </p:txBody>
-      </p:sp>
-      <p:sp>
-        <p:nvSpPr>
-          <p:cNvPr id="780" name=""/>
-          <p:cNvSpPr/>
-          <p:nvPr/>
-        </p:nvSpPr>
-        <p:spPr>
-          <a:xfrm rot="0" flipH="0" flipV="0">
-            <a:off x="8315325" y="3619500"/>
+            <a:off x="8315325" y="3514725"/>
             <a:ext cx="3324225" cy="676275"/>
           </a:xfrm>
           <a:prstGeom prst="roundRect">
@@ -29810,13 +29794,13 @@
       </p:sp>
       <p:sp>
         <p:nvSpPr>
-          <p:cNvPr id="781" name="" descr="{&quot;isTemplate&quot;:true,&quot;type&quot;:&quot;text&quot;}"/>
-          <p:cNvSpPr txBox="1"/>
-          <p:nvPr/>
-        </p:nvSpPr>
-        <p:spPr>
-          <a:xfrm rot="0" flipH="0" flipV="0">
-            <a:off x="8448675" y="3733800"/>
+          <p:cNvPr id="780" name="" descr="{&quot;isTemplate&quot;:true,&quot;type&quot;:&quot;text&quot;}"/>
+          <p:cNvSpPr txBox="1"/>
+          <p:nvPr/>
+        </p:nvSpPr>
+        <p:spPr>
+          <a:xfrm rot="0" flipH="0" flipV="0">
+            <a:off x="8448675" y="3629025"/>
             <a:ext cx="3057525" cy="447675"/>
           </a:xfrm>
           <a:prstGeom prst="rect"/>
@@ -29839,7 +29823,7 @@
                 <a:latin typeface="Microsoft YaHei"/>
                 <a:ea typeface="Microsoft YaHei"/>
               </a:rPr>
-              <a:t>Weekly exercises are </a:t>
+              <a:t>Weekly exercises feed </a:t>
             </a:r>
             <a:r>
               <a:rPr lang="en-US" sz="975" b="1">
@@ -29849,7 +29833,7 @@
                 <a:latin typeface="Microsoft YaHei"/>
                 <a:ea typeface="Microsoft YaHei"/>
               </a:rPr>
-              <a:t>formative</a:t>
+              <a:t>F2 participation</a:t>
             </a:r>
             <a:r>
               <a:rPr lang="en-US" sz="975">
@@ -29859,15 +29843,15 @@
                 <a:latin typeface="Microsoft YaHei"/>
                 <a:ea typeface="Microsoft YaHei"/>
               </a:rPr>
-              <a:t> — not graded; they feed your milestones.</a:t>
-            </a:r>
-            <a:endParaRPr/>
-          </a:p>
-        </p:txBody>
-      </p:sp>
-      <p:sp>
-        <p:nvSpPr>
-          <p:cNvPr id="782" name=""/>
+              <a:t> (4 pts) — checked and discussed in class every week.</a:t>
+            </a:r>
+            <a:endParaRPr/>
+          </a:p>
+        </p:txBody>
+      </p:sp>
+      <p:sp>
+        <p:nvSpPr>
+          <p:cNvPr id="781" name=""/>
           <p:cNvSpPr/>
           <p:nvPr/>
         </p:nvSpPr>
@@ -29891,7 +29875,7 @@
       </p:sp>
       <p:sp>
         <p:nvSpPr>
-          <p:cNvPr id="783" name=""/>
+          <p:cNvPr id="782" name=""/>
           <p:cNvSpPr/>
           <p:nvPr/>
         </p:nvSpPr>
@@ -29931,7 +29915,7 @@
       </p:sp>
       <p:sp>
         <p:nvSpPr>
-          <p:cNvPr id="784" name="" descr="{&quot;isTemplate&quot;:true,&quot;type&quot;:&quot;text&quot;}"/>
+          <p:cNvPr id="783" name="" descr="{&quot;isTemplate&quot;:true,&quot;type&quot;:&quot;text&quot;}"/>
           <p:cNvSpPr txBox="1"/>
           <p:nvPr/>
         </p:nvSpPr>
@@ -29966,7 +29950,7 @@
       </p:sp>
       <p:sp>
         <p:nvSpPr>
-          <p:cNvPr id="785" name="" descr="{&quot;isTemplate&quot;:true,&quot;type&quot;:&quot;text&quot;}"/>
+          <p:cNvPr id="784" name="" descr="{&quot;isTemplate&quot;:true,&quot;type&quot;:&quot;text&quot;}"/>
           <p:cNvSpPr txBox="1"/>
           <p:nvPr/>
         </p:nvSpPr>
@@ -30001,7 +29985,7 @@
       </p:sp>
       <p:sp>
         <p:nvSpPr>
-          <p:cNvPr id="786" name="" descr="{&quot;isTemplate&quot;:true,&quot;type&quot;:&quot;text&quot;}"/>
+          <p:cNvPr id="785" name="" descr="{&quot;isTemplate&quot;:true,&quot;type&quot;:&quot;text&quot;}"/>
           <p:cNvSpPr txBox="1"/>
           <p:nvPr/>
         </p:nvSpPr>
@@ -30044,7 +30028,7 @@
   <p:cSld>
     <p:spTree>
       <p:nvGrpSpPr>
-        <p:cNvPr id="787" name="" descr="&lt;Slide style={{ background: '#FFFFFF', padding: 0 }}&gt;&#10;  &lt;Box style={{ height: 72, background: '#1E4FA8', padding: '0 40px', flexDirection: 'row', alignItems: 'center', justifyContent: 'space-between' }}&gt;&#10;    &lt;Text style={{ fontSize: 15, color: '#B9CDF0', letterSpacing: 1 }}&gt;ISAD · INFORMATION SYSTEMS ANALYSIS &amp;amp; DESIGN&lt;/Text&gt;&#10;    &lt;Text style={{ fontSize: 15, color: '#B9CDF0' }}&gt;W01 · INTRODUCTION&lt;/Text&gt;&#10;  &lt;/Box&gt;&#10;  &lt;Box style={{ padding: '24px 40px 0 40px' }}&gt;&#10;    &lt;Text style={{ fontSize: 34, fontWeight: 'bold', color: '#0E3F8C' }}&gt;The Running Project: CampusBites&lt;/Text&gt;&#10;  &lt;/Box&gt;&#10;  &lt;Box style={{ flex: 1, padding: '18px 40px 0 40px', flexDirection: 'row', gap: 30 }}&gt;&#10;    &lt;Box style={{ flex: 3, justifyContent: 'center', alignItems: 'center' }}&gt;&#10;      &lt;svg width={460} height={400} viewBox='0 0 460 400'&gt;&#10;        &lt;line x1='90' y1='91' x2='200' y2='172' stroke='#D6DCE5' strokeWidth='2' /&gt;&#10;        &lt;line x1='370' y1='91' x2='260' y2='172' stroke='#D6DCE5' strokeWidth='2' /&gt;&#10;        &lt;line x1='90' y1='309' x2='200' y2='228' stroke='#D6DCE5' strokeWidth='2' /&gt;&#10;        &lt;line x1='370' y1='309' x2='260' y2='228' stroke='#D6DCE5' strokeWidth='2' /&gt;&#10;        &lt;rect x='180' y='160' width='100' height='80' rx='12' fill='#1E4FA8' /&gt;&#10;        &lt;text x='230' y='196' textAnchor='middle' fill='#FFFFFF' fontSize='17' fontWeight='bold'&gt;CampusBites&lt;/text&gt;&#10;        &lt;text x='230' y='218' textAnchor='middle' fill='#B9CDF0' fontSize='13'&gt;platform&lt;/text&gt;&#10;        &lt;rect x='30' y='35' width='120' height='56' rx='10' fill='#E8EFF8' stroke='#3D7BD9' strokeWidth='2' /&gt;&#10;        &lt;text x='90' y='58' textAnchor='middle' fill='#0E3F8C' fontSize='16' fontWeight='bold'&gt;Student&lt;/text&gt;&#10;        &lt;text x='90' y='78' textAnchor='middle' fill='#4A5568' fontSize='13'&gt;customer&lt;/text&gt;&#10;        &lt;rect x='310' y='35' width='120' height='56' rx='10' fill='#E8EFF8' stroke='#3D7BD9' strokeWidth='2' /&gt;&#10;        &lt;text x='370' y='58' textAnchor='middle' fill='#0E3F8C' fontSize='16' fontWeight='bold'&gt;Restaurant&lt;/text&gt;&#10;        &lt;text x='370' y='78' textAnchor='middle' fill='#4A5568' fontSize='13'&gt;vendor&lt;/text&gt;&#10;        &lt;rect x='30' y='289' width='120' height='56' rx='10' fill='#E8EFF8' stroke='#3D7BD9' strokeWidth='2' /&gt;&#10;        &lt;text x='90' y='312' textAnchor='middle' fill='#0E3F8C' fontSize='16' fontWeight='bold'&gt;Courier&lt;/text&gt;&#10;        &lt;text x='90' y='332' textAnchor='middle' fill='#4A5568' fontSize='13'&gt;rider&lt;/text&gt;&#10;        &lt;rect x='310' y='289' width='120' height='56' rx='10' fill='#E8EFF8' stroke='#3D7BD9' strokeWidth='2' /&gt;&#10;        &lt;text x='370' y='312' textAnchor='middle' fill='#0E3F8C' fontSize='16' fontWeight='bold'&gt;Payment&lt;/text&gt;&#10;        &lt;text x='370' y='332' textAnchor='middle' fill='#4A5568' fontSize='13'&gt;service&lt;/text&gt;&#10;      &lt;/svg&gt;&#10;    &lt;/Box&gt;&#10;    &lt;Box style={{ flex: 2, flexDirection: 'column', gap: 14, justifyContent: 'center' }}&gt;&#10;      &lt;Text style={{ fontSize: 20, color: '#4A5568', lineHeight: 1.5 }}&gt;A campus &lt;span style={{ fontWeight: 'bold', color: '#1A2230' }}&gt;food ordering &amp;amp; delivery&lt;/span&gt; platform you will analyse and design for 16 weeks.&lt;/Text&gt;&#10;      &lt;Box style={{ padding: '16px 18px', background: '#F7F9FC', borderRadius: 10, border: '1px solid #E5E7EB', flexDirection: 'column', gap: 8 }}&gt;&#10;        &lt;Text style={{ fontSize: 15, fontWeight: 'bold', color: '#0E3F8C' }}&gt;Why this domain? It is pattern-rich&lt;/Text&gt;&#10;        &lt;Text style={{ fontSize: 14, color: '#4A5568', lineHeight: 1.55 }}&gt;Order lifecycle → &lt;span style={{ fontWeight: 'bold' }}&gt;State&lt;/span&gt; · Payment → &lt;span style={{ fontWeight: 'bold' }}&gt;Strategy&lt;/span&gt; · Order tracking → &lt;span style={{ fontWeight: 'bold' }}&gt;Observer&lt;/span&gt; · Campus card → &lt;span style={{ fontWeight: 'bold' }}&gt;Adapter&lt;/span&gt; · Toppings → &lt;span style={{ fontWeight: 'bold' }}&gt;Decorator&lt;/span&gt;&lt;/Text&gt;&#10;      &lt;/Box&gt;&#10;      &lt;Box style={{ flexDirection: 'row', alignItems: 'center', gap: 12 }}&gt;&#10;        &lt;FAIcon name='users' style={{ fill: '#1E4FA8', width: 24, height: 24 }} /&gt;&#10;        &lt;Text style={{ fontSize: 16, color: '#1A2230' }}&gt;One team of four — &lt;span style={{ fontWeight: 'bold' }}&gt;small cohort, everyone counts&lt;/span&gt;&lt;/Text&gt;&#10;      &lt;/Box&gt;&#10;    &lt;/Box&gt;&#10;  &lt;/Box&gt;&#10;  &lt;Box style={{ height: 40, padding: '0 40px', flexDirection: 'row', alignItems: 'center', justifyContent: 'space-between' }}&gt;&#10;    &lt;Text style={{ fontSize: 13, color: '#8B97A8' }}&gt;ISAD · Fall 2026&lt;/Text&gt;&#10;    &lt;Text style={{ fontSize: 14, color: '#1E4FA8', fontWeight: 'bold' }}&gt;07 / 38&lt;/Text&gt;&#10;  &lt;/Box&gt;&#10;&lt;/Slide&gt;"/>
+        <p:cNvPr id="786" name="" descr="&lt;Slide style={{ background: '#FFFFFF', padding: 0 }}&gt;&#10;  &lt;Box style={{ height: 72, background: '#1E4FA8', padding: '0 40px', flexDirection: 'row', alignItems: 'center', justifyContent: 'space-between' }}&gt;&#10;    &lt;Text style={{ fontSize: 15, color: '#B9CDF0', letterSpacing: 1 }}&gt;ISAD · INFORMATION SYSTEMS ANALYSIS &amp;amp; DESIGN&lt;/Text&gt;&#10;    &lt;Text style={{ fontSize: 15, color: '#B9CDF0' }}&gt;W01 · INTRODUCTION&lt;/Text&gt;&#10;  &lt;/Box&gt;&#10;  &lt;Box style={{ padding: '24px 40px 0 40px' }}&gt;&#10;    &lt;Text style={{ fontSize: 34, fontWeight: 'bold', color: '#0E3F8C' }}&gt;The Running Project: CampusBites&lt;/Text&gt;&#10;  &lt;/Box&gt;&#10;  &lt;Box style={{ flex: 1, padding: '18px 40px 0 40px', flexDirection: 'row', gap: 30 }}&gt;&#10;    &lt;Box style={{ flex: 3, justifyContent: 'center', alignItems: 'center' }}&gt;&#10;      &lt;svg width={460} height={400} viewBox='0 0 460 400'&gt;&#10;        &lt;line x1='90' y1='91' x2='200' y2='172' stroke='#D6DCE5' strokeWidth='2' /&gt;&#10;        &lt;line x1='370' y1='91' x2='260' y2='172' stroke='#D6DCE5' strokeWidth='2' /&gt;&#10;        &lt;line x1='90' y1='309' x2='200' y2='228' stroke='#D6DCE5' strokeWidth='2' /&gt;&#10;        &lt;line x1='370' y1='309' x2='260' y2='228' stroke='#D6DCE5' strokeWidth='2' /&gt;&#10;        &lt;rect x='180' y='160' width='100' height='80' rx='12' fill='#1E4FA8' /&gt;&#10;        &lt;text x='230' y='196' textAnchor='middle' fill='#FFFFFF' fontSize='17' fontWeight='bold'&gt;CampusBites&lt;/text&gt;&#10;        &lt;text x='230' y='218' textAnchor='middle' fill='#B9CDF0' fontSize='13'&gt;platform&lt;/text&gt;&#10;        &lt;rect x='30' y='35' width='120' height='56' rx='10' fill='#E8EFF8' stroke='#3D7BD9' strokeWidth='2' /&gt;&#10;        &lt;text x='90' y='58' textAnchor='middle' fill='#0E3F8C' fontSize='16' fontWeight='bold'&gt;Student&lt;/text&gt;&#10;        &lt;text x='90' y='78' textAnchor='middle' fill='#4A5568' fontSize='13'&gt;customer&lt;/text&gt;&#10;        &lt;rect x='310' y='35' width='120' height='56' rx='10' fill='#E8EFF8' stroke='#3D7BD9' strokeWidth='2' /&gt;&#10;        &lt;text x='370' y='58' textAnchor='middle' fill='#0E3F8C' fontSize='16' fontWeight='bold'&gt;Restaurant&lt;/text&gt;&#10;        &lt;text x='370' y='78' textAnchor='middle' fill='#4A5568' fontSize='13'&gt;vendor&lt;/text&gt;&#10;        &lt;rect x='30' y='289' width='120' height='56' rx='10' fill='#E8EFF8' stroke='#3D7BD9' strokeWidth='2' /&gt;&#10;        &lt;text x='90' y='312' textAnchor='middle' fill='#0E3F8C' fontSize='16' fontWeight='bold'&gt;Courier&lt;/text&gt;&#10;        &lt;text x='90' y='332' textAnchor='middle' fill='#4A5568' fontSize='13'&gt;rider&lt;/text&gt;&#10;        &lt;rect x='310' y='289' width='120' height='56' rx='10' fill='#E8EFF8' stroke='#3D7BD9' strokeWidth='2' /&gt;&#10;        &lt;text x='370' y='312' textAnchor='middle' fill='#0E3F8C' fontSize='16' fontWeight='bold'&gt;Payment&lt;/text&gt;&#10;        &lt;text x='370' y='332' textAnchor='middle' fill='#4A5568' fontSize='13'&gt;service&lt;/text&gt;&#10;      &lt;/svg&gt;&#10;    &lt;/Box&gt;&#10;    &lt;Box style={{ flex: 2, flexDirection: 'column', gap: 14, justifyContent: 'center' }}&gt;&#10;      &lt;Text style={{ fontSize: 20, color: '#4A5568', lineHeight: 1.5 }}&gt;A campus &lt;span style={{ fontWeight: 'bold', color: '#1A2230' }}&gt;food ordering &amp;amp; delivery&lt;/span&gt; platform you will analyse and design for 16 weeks.&lt;/Text&gt;&#10;      &lt;Box style={{ padding: '16px 18px', background: '#F7F9FC', borderRadius: 10, border: '1px solid #E5E7EB', flexDirection: 'column', gap: 8 }}&gt;&#10;        &lt;Text style={{ fontSize: 15, fontWeight: 'bold', color: '#0E3F8C' }}&gt;Why this domain? It is pattern-rich&lt;/Text&gt;&#10;        &lt;Text style={{ fontSize: 14, color: '#4A5568', lineHeight: 1.55 }}&gt;Order lifecycle → &lt;span style={{ fontWeight: 'bold' }}&gt;State&lt;/span&gt; · Payment → &lt;span style={{ fontWeight: 'bold' }}&gt;Strategy&lt;/span&gt; · Order tracking → &lt;span style={{ fontWeight: 'bold' }}&gt;Observer&lt;/span&gt; · Campus card → &lt;span style={{ fontWeight: 'bold' }}&gt;Adapter&lt;/span&gt; · Toppings → &lt;span style={{ fontWeight: 'bold' }}&gt;Decorator&lt;/span&gt;&lt;/Text&gt;&#10;      &lt;/Box&gt;&#10;      &lt;Box style={{ flexDirection: 'row', alignItems: 'center', gap: 12 }}&gt;&#10;        &lt;FAIcon name='users' style={{ fill: '#1E4FA8', width: 24, height: 24 }} /&gt;&#10;        &lt;Text style={{ fontSize: 16, color: '#1A2230' }}&gt;One team of four — &lt;span style={{ fontWeight: 'bold' }}&gt;small cohort, everyone counts&lt;/span&gt;&lt;/Text&gt;&#10;      &lt;/Box&gt;&#10;    &lt;/Box&gt;&#10;  &lt;/Box&gt;&#10;  &lt;Box style={{ height: 40, padding: '0 40px', flexDirection: 'row', alignItems: 'center', justifyContent: 'space-between' }}&gt;&#10;    &lt;Text style={{ fontSize: 13, color: '#8B97A8' }}&gt;ISAD · Fall 2026&lt;/Text&gt;&#10;    &lt;Text style={{ fontSize: 14, color: '#1E4FA8', fontWeight: 'bold' }}&gt;07 / 38&lt;/Text&gt;&#10;  &lt;/Box&gt;&#10;&lt;/Slide&gt;"/>
         <p:cNvGrpSpPr/>
         <p:nvPr/>
       </p:nvGrpSpPr>
@@ -30058,7 +30042,7 @@
       </p:grpSpPr>
       <p:sp>
         <p:nvSpPr>
-          <p:cNvPr id="788" name=""/>
+          <p:cNvPr id="787" name=""/>
           <p:cNvSpPr/>
           <p:nvPr/>
         </p:nvSpPr>
@@ -30082,7 +30066,7 @@
       </p:sp>
       <p:sp>
         <p:nvSpPr>
-          <p:cNvPr id="789" name=""/>
+          <p:cNvPr id="788" name=""/>
           <p:cNvSpPr/>
           <p:nvPr/>
         </p:nvSpPr>
@@ -30106,7 +30090,7 @@
       </p:sp>
       <p:sp>
         <p:nvSpPr>
-          <p:cNvPr id="790" name="" descr="{&quot;isTemplate&quot;:true,&quot;type&quot;:&quot;text&quot;}"/>
+          <p:cNvPr id="789" name="" descr="{&quot;isTemplate&quot;:true,&quot;type&quot;:&quot;text&quot;}"/>
           <p:cNvSpPr txBox="1"/>
           <p:nvPr/>
         </p:nvSpPr>
@@ -30141,7 +30125,7 @@
       </p:sp>
       <p:sp>
         <p:nvSpPr>
-          <p:cNvPr id="791" name="" descr="{&quot;isTemplate&quot;:true,&quot;type&quot;:&quot;text&quot;}"/>
+          <p:cNvPr id="790" name="" descr="{&quot;isTemplate&quot;:true,&quot;type&quot;:&quot;text&quot;}"/>
           <p:cNvSpPr txBox="1"/>
           <p:nvPr/>
         </p:nvSpPr>
@@ -30176,7 +30160,7 @@
       </p:sp>
       <p:sp>
         <p:nvSpPr>
-          <p:cNvPr id="792" name="" descr="{&quot;isTemplate&quot;:true,&quot;type&quot;:&quot;text&quot;}"/>
+          <p:cNvPr id="791" name="" descr="{&quot;isTemplate&quot;:true,&quot;type&quot;:&quot;text&quot;}"/>
           <p:cNvSpPr txBox="1"/>
           <p:nvPr/>
         </p:nvSpPr>
@@ -30211,7 +30195,7 @@
       </p:sp>
       <p:pic>
         <p:nvPicPr>
-          <p:cNvPr id="793" name=""/>
+          <p:cNvPr id="792" name=""/>
           <p:cNvPicPr>
             <a:picLocks noChangeAspect="1"/>
           </p:cNvPicPr>
@@ -30242,7 +30226,7 @@
       </p:pic>
       <p:sp>
         <p:nvSpPr>
-          <p:cNvPr id="794" name="" descr="{&quot;isTemplate&quot;:true,&quot;type&quot;:&quot;text&quot;}"/>
+          <p:cNvPr id="793" name="" descr="{&quot;isTemplate&quot;:true,&quot;type&quot;:&quot;text&quot;}"/>
           <p:cNvSpPr txBox="1"/>
           <p:nvPr/>
         </p:nvSpPr>
@@ -30299,7 +30283,7 @@
       </p:sp>
       <p:sp>
         <p:nvSpPr>
-          <p:cNvPr id="795" name=""/>
+          <p:cNvPr id="794" name=""/>
           <p:cNvSpPr/>
           <p:nvPr/>
         </p:nvSpPr>
@@ -30330,7 +30314,7 @@
       </p:sp>
       <p:sp>
         <p:nvSpPr>
-          <p:cNvPr id="796" name="" descr="{&quot;isTemplate&quot;:true,&quot;type&quot;:&quot;text&quot;}"/>
+          <p:cNvPr id="795" name="" descr="{&quot;isTemplate&quot;:true,&quot;type&quot;:&quot;text&quot;}"/>
           <p:cNvSpPr txBox="1"/>
           <p:nvPr/>
         </p:nvSpPr>
@@ -30365,7 +30349,7 @@
       </p:sp>
       <p:sp>
         <p:nvSpPr>
-          <p:cNvPr id="797" name="" descr="{&quot;isTemplate&quot;:true,&quot;type&quot;:&quot;text&quot;}"/>
+          <p:cNvPr id="796" name="" descr="{&quot;isTemplate&quot;:true,&quot;type&quot;:&quot;text&quot;}"/>
           <p:cNvSpPr txBox="1"/>
           <p:nvPr/>
         </p:nvSpPr>
@@ -30492,7 +30476,7 @@
       </p:sp>
       <p:pic>
         <p:nvPicPr>
-          <p:cNvPr id="798" name=""/>
+          <p:cNvPr id="797" name=""/>
           <p:cNvPicPr>
             <a:picLocks noChangeAspect="1"/>
           </p:cNvPicPr>
@@ -30523,7 +30507,7 @@
       </p:pic>
       <p:sp>
         <p:nvSpPr>
-          <p:cNvPr id="799" name="" descr="{&quot;isTemplate&quot;:true,&quot;type&quot;:&quot;text&quot;}"/>
+          <p:cNvPr id="798" name="" descr="{&quot;isTemplate&quot;:true,&quot;type&quot;:&quot;text&quot;}"/>
           <p:cNvSpPr txBox="1"/>
           <p:nvPr/>
         </p:nvSpPr>
@@ -30568,7 +30552,7 @@
       </p:sp>
       <p:sp>
         <p:nvSpPr>
-          <p:cNvPr id="800" name="" descr="{&quot;isTemplate&quot;:true,&quot;type&quot;:&quot;text&quot;}"/>
+          <p:cNvPr id="799" name="" descr="{&quot;isTemplate&quot;:true,&quot;type&quot;:&quot;text&quot;}"/>
           <p:cNvSpPr txBox="1"/>
           <p:nvPr/>
         </p:nvSpPr>
@@ -30603,7 +30587,7 @@
       </p:sp>
       <p:sp>
         <p:nvSpPr>
-          <p:cNvPr id="801" name="" descr="{&quot;isTemplate&quot;:true,&quot;type&quot;:&quot;text&quot;}"/>
+          <p:cNvPr id="800" name="" descr="{&quot;isTemplate&quot;:true,&quot;type&quot;:&quot;text&quot;}"/>
           <p:cNvSpPr txBox="1"/>
           <p:nvPr/>
         </p:nvSpPr>
@@ -30646,7 +30630,7 @@
   <p:cSld>
     <p:spTree>
       <p:nvGrpSpPr>
-        <p:cNvPr id="802" name="" descr="&lt;Slide style={{ background: '#0E3F8C', padding: 0 }}&gt;&#10;  &lt;Box style={{ flexDirection: 'row', height: '100%', position: 'relative' }}&gt;&#10;    &lt;Box style={{ position: 'absolute', top: 0, left: 0, right: 0, height: 8, background: '#1E4FA8' }} /&gt;&#10;    &lt;Box style={{ width: 300, justifyContent: 'center', alignItems: 'center', borderRight: '1px solid #2B5793' }}&gt;&#10;      &lt;Text style={{ fontSize: 220, fontWeight: 'bold', color: '#3D7BD9', fontFamily: 'Georgia, serif', lineHeight: 1 }}&gt;02&lt;/Text&gt;&#10;    &lt;/Box&gt;&#10;    &lt;Box style={{ flex: 1, padding: '70px 64px', flexDirection: 'column', justifyContent: 'center' }}&gt;&#10;      &lt;Text style={{ fontSize: 15, color: '#7FA2D6', letterSpacing: 2, marginBottom: 18 }}&gt;PART 1 · LECTURE&lt;/Text&gt;&#10;      &lt;Text style={{ fontSize: 48, fontWeight: 'bold', color: '#FFFFFF', lineHeight: 1.18 }}&gt;What Is an&lt;br /&gt;Information System?&lt;/Text&gt;&#10;      &lt;Box style={{ width: 64, height: 4, background: '#FFC107', marginTop: 26, marginBottom: 26 }} /&gt;&#10;      &lt;Box style={{ flexDirection: 'column', gap: 12 }}&gt;&#10;        {[&#10;          'A definition beyond just software',&#10;          'The four elements: people, process, data, technology',&#10;          'Why information systems fail — and who fixes them',&#10;        ].map((t) =&gt; (&#10;          &lt;Box key={t} style={{ flexDirection: 'row', alignItems: 'center', gap: 12 }}&gt;&#10;            &lt;Box style={{ width: 8, height: 8, borderRadius: 4, background: '#3D7BD9' }} /&gt;&#10;            &lt;Text style={{ fontSize: 20, color: '#C5D4EA' }}&gt;{t}&lt;/Text&gt;&#10;          &lt;/Box&gt;&#10;        ))}&#10;      &lt;/Box&gt;&#10;    &lt;/Box&gt;&#10;  &lt;/Box&gt;&#10;&lt;/Slide&gt;"/>
+        <p:cNvPr id="801" name="" descr="&lt;Slide style={{ background: '#0E3F8C', padding: 0 }}&gt;&#10;  &lt;Box style={{ flexDirection: 'row', height: '100%', position: 'relative' }}&gt;&#10;    &lt;Box style={{ position: 'absolute', top: 0, left: 0, right: 0, height: 8, background: '#1E4FA8' }} /&gt;&#10;    &lt;Box style={{ width: 300, justifyContent: 'center', alignItems: 'center', borderRight: '1px solid #2B5793' }}&gt;&#10;      &lt;Text style={{ fontSize: 220, fontWeight: 'bold', color: '#3D7BD9', fontFamily: 'Georgia, serif', lineHeight: 1 }}&gt;02&lt;/Text&gt;&#10;    &lt;/Box&gt;&#10;    &lt;Box style={{ flex: 1, padding: '70px 64px', flexDirection: 'column', justifyContent: 'center' }}&gt;&#10;      &lt;Text style={{ fontSize: 15, color: '#7FA2D6', letterSpacing: 2, marginBottom: 18 }}&gt;PART 1 · LECTURE&lt;/Text&gt;&#10;      &lt;Text style={{ fontSize: 48, fontWeight: 'bold', color: '#FFFFFF', lineHeight: 1.18 }}&gt;What Is an&lt;br /&gt;Information System?&lt;/Text&gt;&#10;      &lt;Box style={{ width: 64, height: 4, background: '#FFC107', marginTop: 26, marginBottom: 26 }} /&gt;&#10;      &lt;Box style={{ flexDirection: 'column', gap: 12 }}&gt;&#10;        {[&#10;          'A definition beyond just software',&#10;          'The four elements: people, process, data, technology',&#10;          'Why information systems fail — and who fixes them',&#10;        ].map((t) =&gt; (&#10;          &lt;Box key={t} style={{ flexDirection: 'row', alignItems: 'center', gap: 12 }}&gt;&#10;            &lt;Box style={{ width: 8, height: 8, borderRadius: 4, background: '#3D7BD9' }} /&gt;&#10;            &lt;Text style={{ fontSize: 20, color: '#C5D4EA' }}&gt;{t}&lt;/Text&gt;&#10;          &lt;/Box&gt;&#10;        ))}&#10;      &lt;/Box&gt;&#10;    &lt;/Box&gt;&#10;  &lt;/Box&gt;&#10;&lt;/Slide&gt;"/>
         <p:cNvGrpSpPr/>
         <p:nvPr/>
       </p:nvGrpSpPr>
@@ -30660,7 +30644,7 @@
       </p:grpSpPr>
       <p:sp>
         <p:nvSpPr>
-          <p:cNvPr id="803" name=""/>
+          <p:cNvPr id="802" name=""/>
           <p:cNvSpPr/>
           <p:nvPr/>
         </p:nvSpPr>
@@ -30684,7 +30668,7 @@
       </p:sp>
       <p:sp>
         <p:nvSpPr>
-          <p:cNvPr id="804" name=""/>
+          <p:cNvPr id="803" name=""/>
           <p:cNvSpPr/>
           <p:nvPr/>
         </p:nvSpPr>
@@ -30724,7 +30708,7 @@
       </p:sp>
       <p:sp>
         <p:nvSpPr>
-          <p:cNvPr id="805" name="" descr="{&quot;isTemplate&quot;:true,&quot;type&quot;:&quot;text&quot;}"/>
+          <p:cNvPr id="804" name="" descr="{&quot;isTemplate&quot;:true,&quot;type&quot;:&quot;text&quot;}"/>
           <p:cNvSpPr txBox="1"/>
           <p:nvPr/>
         </p:nvSpPr>
@@ -30759,7 +30743,7 @@
       </p:sp>
       <p:sp>
         <p:nvSpPr>
-          <p:cNvPr id="806" name="" descr="{&quot;isTemplate&quot;:true,&quot;type&quot;:&quot;text&quot;}"/>
+          <p:cNvPr id="805" name="" descr="{&quot;isTemplate&quot;:true,&quot;type&quot;:&quot;text&quot;}"/>
           <p:cNvSpPr txBox="1"/>
           <p:nvPr/>
         </p:nvSpPr>
@@ -30794,7 +30778,7 @@
       </p:sp>
       <p:sp>
         <p:nvSpPr>
-          <p:cNvPr id="807" name="" descr="{&quot;isTemplate&quot;:true,&quot;type&quot;:&quot;text&quot;}"/>
+          <p:cNvPr id="806" name="" descr="{&quot;isTemplate&quot;:true,&quot;type&quot;:&quot;text&quot;}"/>
           <p:cNvSpPr txBox="1"/>
           <p:nvPr/>
         </p:nvSpPr>
@@ -30847,7 +30831,7 @@
       </p:sp>
       <p:sp>
         <p:nvSpPr>
-          <p:cNvPr id="808" name=""/>
+          <p:cNvPr id="807" name=""/>
           <p:cNvSpPr/>
           <p:nvPr/>
         </p:nvSpPr>
@@ -30871,7 +30855,7 @@
       </p:sp>
       <p:sp>
         <p:nvSpPr>
-          <p:cNvPr id="809" name=""/>
+          <p:cNvPr id="808" name=""/>
           <p:cNvSpPr/>
           <p:nvPr/>
         </p:nvSpPr>
@@ -30897,7 +30881,7 @@
       </p:sp>
       <p:sp>
         <p:nvSpPr>
-          <p:cNvPr id="810" name="" descr="{&quot;isTemplate&quot;:true,&quot;type&quot;:&quot;text&quot;}"/>
+          <p:cNvPr id="809" name="" descr="{&quot;isTemplate&quot;:true,&quot;type&quot;:&quot;text&quot;}"/>
           <p:cNvSpPr txBox="1"/>
           <p:nvPr/>
         </p:nvSpPr>
@@ -30932,7 +30916,7 @@
       </p:sp>
       <p:sp>
         <p:nvSpPr>
-          <p:cNvPr id="811" name=""/>
+          <p:cNvPr id="810" name=""/>
           <p:cNvSpPr/>
           <p:nvPr/>
         </p:nvSpPr>
@@ -30958,7 +30942,7 @@
       </p:sp>
       <p:sp>
         <p:nvSpPr>
-          <p:cNvPr id="812" name="" descr="{&quot;isTemplate&quot;:true,&quot;type&quot;:&quot;text&quot;}"/>
+          <p:cNvPr id="811" name="" descr="{&quot;isTemplate&quot;:true,&quot;type&quot;:&quot;text&quot;}"/>
           <p:cNvSpPr txBox="1"/>
           <p:nvPr/>
         </p:nvSpPr>
@@ -30993,7 +30977,7 @@
       </p:sp>
       <p:sp>
         <p:nvSpPr>
-          <p:cNvPr id="813" name=""/>
+          <p:cNvPr id="812" name=""/>
           <p:cNvSpPr/>
           <p:nvPr/>
         </p:nvSpPr>
@@ -31019,7 +31003,7 @@
       </p:sp>
       <p:sp>
         <p:nvSpPr>
-          <p:cNvPr id="814" name="" descr="{&quot;isTemplate&quot;:true,&quot;type&quot;:&quot;text&quot;}"/>
+          <p:cNvPr id="813" name="" descr="{&quot;isTemplate&quot;:true,&quot;type&quot;:&quot;text&quot;}"/>
           <p:cNvSpPr txBox="1"/>
           <p:nvPr/>
         </p:nvSpPr>
@@ -31054,7 +31038,7 @@
       </p:sp>
       <p:sp>
         <p:nvSpPr>
-          <p:cNvPr id="815" name=""/>
+          <p:cNvPr id="814" name=""/>
           <p:cNvSpPr/>
           <p:nvPr/>
         </p:nvSpPr>
@@ -31086,7 +31070,7 @@
   <p:cSld>
     <p:spTree>
       <p:nvGrpSpPr>
-        <p:cNvPr id="816" name="" descr="&lt;Slide style={{ background: '#FFFFFF', padding: 0 }}&gt;&#10;  &lt;Box style={{ height: 72, background: '#1E4FA8', padding: '0 40px', flexDirection: 'row', alignItems: 'center', justifyContent: 'space-between' }}&gt;&#10;    &lt;Text style={{ fontSize: 15, color: '#B9CDF0', letterSpacing: 1 }}&gt;ISAD · INFORMATION SYSTEMS ANALYSIS &amp;amp; DESIGN&lt;/Text&gt;&#10;    &lt;Text style={{ fontSize: 15, color: '#B9CDF0' }}&gt;W01 · INTRODUCTION&lt;/Text&gt;&#10;  &lt;/Box&gt;&#10;  &lt;Box style={{ padding: '24px 40px 0 40px' }}&gt;&#10;    &lt;Text style={{ fontSize: 34, fontWeight: 'bold', color: '#0E3F8C' }}&gt;Defining an Information System&lt;/Text&gt;&#10;  &lt;/Box&gt;&#10;  &lt;Box style={{ flex: 1, padding: '18px 40px 0 40px', flexDirection: 'row', gap: 28 }}&gt;&#10;    &lt;Box style={{ width: 320, padding: '28px 24px', background: '#0E3F8C', borderRadius: 12, flexDirection: 'column', justifyContent: 'center', gap: 16 }}&gt;&#10;      &lt;FAIcon name='info-circle' style={{ fill: '#FFC107', width: 40, height: 40 }} /&gt;&#10;      &lt;Text style={{ fontSize: 26, fontWeight: 'bold', color: '#FFFFFF', lineHeight: 1.3 }}&gt;Definition&lt;/Text&gt;&#10;      &lt;Text style={{ fontSize: 17, color: '#C5D4EA', lineHeight: 1.55 }}&gt;An organised combination of people, process, data and technology that collects, processes, stores and distributes information to support a goal.&lt;/Text&gt;&#10;    &lt;/Box&gt;&#10;    &lt;Box style={{ flex: 1, flexDirection: 'column', gap: 16, justifyContent: 'center' }}&gt;&#10;      {[&#10;        ['It is more than software', 'Software is one part. The system also lives in how people work and how information flows.'],&#10;        ['It has a purpose', 'Every information system exists to support a decision or an activity — ordering food, enrolling, booking a room.'],&#10;        ['It transforms data into information', 'Raw data (a list of orders) becomes information (a delivery route for a courier) through processing.'],&#10;      ].map(([t, d]) =&gt; (&#10;        &lt;Box key={t} style={{ flexDirection: 'row', gap: 14, padding: '16px 18px', background: '#F7F9FC', borderRadius: 10, border: '1px solid #E5E7EB', alignItems: 'flex-start' }}&gt;&#10;          &lt;FAIcon name='check-circle' style={{ fill: '#1E4FA8', width: 24, height: 24 }} /&gt;&#10;          &lt;Box style={{ flexDirection: 'column', gap: 4 }}&gt;&#10;            &lt;Text style={{ fontSize: 19, fontWeight: 'bold', color: '#1A2230' }}&gt;{t}&lt;/Text&gt;&#10;            &lt;Text style={{ fontSize: 15, color: '#4A5568', lineHeight: 1.5 }}&gt;{d}&lt;/Text&gt;&#10;          &lt;/Box&gt;&#10;        &lt;/Box&gt;&#10;      ))}&#10;    &lt;/Box&gt;&#10;  &lt;/Box&gt;&#10;  &lt;Box style={{ height: 40, padding: '0 40px', flexDirection: 'row', alignItems: 'center', justifyContent: 'space-between' }}&gt;&#10;    &lt;Text style={{ fontSize: 13, color: '#8B97A8' }}&gt;ISAD · Fall 2026&lt;/Text&gt;&#10;    &lt;Text style={{ fontSize: 14, color: '#1E4FA8', fontWeight: 'bold' }}&gt;09 / 38&lt;/Text&gt;&#10;  &lt;/Box&gt;&#10;&lt;/Slide&gt;"/>
+        <p:cNvPr id="815" name="" descr="&lt;Slide style={{ background: '#FFFFFF', padding: 0 }}&gt;&#10;  &lt;Box style={{ height: 72, background: '#1E4FA8', padding: '0 40px', flexDirection: 'row', alignItems: 'center', justifyContent: 'space-between' }}&gt;&#10;    &lt;Text style={{ fontSize: 15, color: '#B9CDF0', letterSpacing: 1 }}&gt;ISAD · INFORMATION SYSTEMS ANALYSIS &amp;amp; DESIGN&lt;/Text&gt;&#10;    &lt;Text style={{ fontSize: 15, color: '#B9CDF0' }}&gt;W01 · INTRODUCTION&lt;/Text&gt;&#10;  &lt;/Box&gt;&#10;  &lt;Box style={{ padding: '24px 40px 0 40px' }}&gt;&#10;    &lt;Text style={{ fontSize: 34, fontWeight: 'bold', color: '#0E3F8C' }}&gt;Defining an Information System&lt;/Text&gt;&#10;  &lt;/Box&gt;&#10;  &lt;Box style={{ flex: 1, padding: '18px 40px 0 40px', flexDirection: 'row', gap: 28 }}&gt;&#10;    &lt;Box style={{ width: 320, padding: '28px 24px', background: '#0E3F8C', borderRadius: 12, flexDirection: 'column', justifyContent: 'center', gap: 16 }}&gt;&#10;      &lt;FAIcon name='info-circle' style={{ fill: '#FFC107', width: 40, height: 40 }} /&gt;&#10;      &lt;Text style={{ fontSize: 26, fontWeight: 'bold', color: '#FFFFFF', lineHeight: 1.3 }}&gt;Definition&lt;/Text&gt;&#10;      &lt;Text style={{ fontSize: 17, color: '#C5D4EA', lineHeight: 1.55 }}&gt;An organised combination of people, process, data and technology that collects, processes, stores and distributes information to support a goal.&lt;/Text&gt;&#10;    &lt;/Box&gt;&#10;    &lt;Box style={{ flex: 1, flexDirection: 'column', gap: 16, justifyContent: 'center' }}&gt;&#10;      {[&#10;        ['It is more than software', 'Software is one part. The system also lives in how people work and how information flows.'],&#10;        ['It has a purpose', 'Every information system exists to support a decision or an activity — ordering food, enrolling, booking a room.'],&#10;        ['It transforms data into information', 'Raw data (a list of orders) becomes information (a delivery route for a courier) through processing.'],&#10;      ].map(([t, d]) =&gt; (&#10;        &lt;Box key={t} style={{ flexDirection: 'row', gap: 14, padding: '16px 18px', background: '#F7F9FC', borderRadius: 10, border: '1px solid #E5E7EB', alignItems: 'flex-start' }}&gt;&#10;          &lt;FAIcon name='check-circle' style={{ fill: '#1E4FA8', width: 24, height: 24 }} /&gt;&#10;          &lt;Box style={{ flexDirection: 'column', gap: 4 }}&gt;&#10;            &lt;Text style={{ fontSize: 19, fontWeight: 'bold', color: '#1A2230' }}&gt;{t}&lt;/Text&gt;&#10;            &lt;Text style={{ fontSize: 15, color: '#4A5568', lineHeight: 1.5 }}&gt;{d}&lt;/Text&gt;&#10;          &lt;/Box&gt;&#10;        &lt;/Box&gt;&#10;      ))}&#10;    &lt;/Box&gt;&#10;  &lt;/Box&gt;&#10;  &lt;Box style={{ height: 40, padding: '0 40px', flexDirection: 'row', alignItems: 'center', justifyContent: 'space-between' }}&gt;&#10;    &lt;Text style={{ fontSize: 13, color: '#8B97A8' }}&gt;ISAD · Fall 2026&lt;/Text&gt;&#10;    &lt;Text style={{ fontSize: 14, color: '#1E4FA8', fontWeight: 'bold' }}&gt;09 / 38&lt;/Text&gt;&#10;  &lt;/Box&gt;&#10;&lt;/Slide&gt;"/>
         <p:cNvGrpSpPr/>
         <p:nvPr/>
       </p:nvGrpSpPr>
@@ -31100,7 +31084,7 @@
       </p:grpSpPr>
       <p:sp>
         <p:nvSpPr>
-          <p:cNvPr id="817" name=""/>
+          <p:cNvPr id="816" name=""/>
           <p:cNvSpPr/>
           <p:nvPr/>
         </p:nvSpPr>
@@ -31124,7 +31108,7 @@
       </p:sp>
       <p:sp>
         <p:nvSpPr>
-          <p:cNvPr id="818" name=""/>
+          <p:cNvPr id="817" name=""/>
           <p:cNvSpPr/>
           <p:nvPr/>
         </p:nvSpPr>
@@ -31148,7 +31132,7 @@
       </p:sp>
       <p:sp>
         <p:nvSpPr>
-          <p:cNvPr id="819" name="" descr="{&quot;isTemplate&quot;:true,&quot;type&quot;:&quot;text&quot;}"/>
+          <p:cNvPr id="818" name="" descr="{&quot;isTemplate&quot;:true,&quot;type&quot;:&quot;text&quot;}"/>
           <p:cNvSpPr txBox="1"/>
           <p:nvPr/>
         </p:nvSpPr>
@@ -31183,7 +31167,7 @@
       </p:sp>
       <p:sp>
         <p:nvSpPr>
-          <p:cNvPr id="820" name="" descr="{&quot;isTemplate&quot;:true,&quot;type&quot;:&quot;text&quot;}"/>
+          <p:cNvPr id="819" name="" descr="{&quot;isTemplate&quot;:true,&quot;type&quot;:&quot;text&quot;}"/>
           <p:cNvSpPr txBox="1"/>
           <p:nvPr/>
         </p:nvSpPr>
@@ -31218,7 +31202,7 @@
       </p:sp>
       <p:sp>
         <p:nvSpPr>
-          <p:cNvPr id="821" name="" descr="{&quot;isTemplate&quot;:true,&quot;type&quot;:&quot;text&quot;}"/>
+          <p:cNvPr id="820" name="" descr="{&quot;isTemplate&quot;:true,&quot;type&quot;:&quot;text&quot;}"/>
           <p:cNvSpPr txBox="1"/>
           <p:nvPr/>
         </p:nvSpPr>
@@ -31253,7 +31237,7 @@
       </p:sp>
       <p:sp>
         <p:nvSpPr>
-          <p:cNvPr id="822" name=""/>
+          <p:cNvPr id="821" name=""/>
           <p:cNvSpPr/>
           <p:nvPr/>
         </p:nvSpPr>
@@ -31279,7 +31263,7 @@
       </p:sp>
       <p:pic>
         <p:nvPicPr>
-          <p:cNvPr id="823" name=""/>
+          <p:cNvPr id="822" name=""/>
           <p:cNvPicPr>
             <a:picLocks noChangeAspect="1"/>
           </p:cNvPicPr>
@@ -31310,7 +31294,7 @@
       </p:pic>
       <p:sp>
         <p:nvSpPr>
-          <p:cNvPr id="824" name="" descr="{&quot;isTemplate&quot;:true,&quot;type&quot;:&quot;text&quot;}"/>
+          <p:cNvPr id="823" name="" descr="{&quot;isTemplate&quot;:true,&quot;type&quot;:&quot;text&quot;}"/>
           <p:cNvSpPr txBox="1"/>
           <p:nvPr/>
         </p:nvSpPr>
@@ -31345,7 +31329,7 @@
       </p:sp>
       <p:sp>
         <p:nvSpPr>
-          <p:cNvPr id="825" name="" descr="{&quot;isTemplate&quot;:true,&quot;type&quot;:&quot;text&quot;}"/>
+          <p:cNvPr id="824" name="" descr="{&quot;isTemplate&quot;:true,&quot;type&quot;:&quot;text&quot;}"/>
           <p:cNvSpPr txBox="1"/>
           <p:nvPr/>
         </p:nvSpPr>
@@ -31382,7 +31366,7 @@
       </p:sp>
       <p:sp>
         <p:nvSpPr>
-          <p:cNvPr id="826" name=""/>
+          <p:cNvPr id="825" name=""/>
           <p:cNvSpPr/>
           <p:nvPr/>
         </p:nvSpPr>
@@ -31413,7 +31397,7 @@
       </p:sp>
       <p:pic>
         <p:nvPicPr>
-          <p:cNvPr id="827" name=""/>
+          <p:cNvPr id="826" name=""/>
           <p:cNvPicPr>
             <a:picLocks noChangeAspect="1"/>
           </p:cNvPicPr>
@@ -31444,7 +31428,7 @@
       </p:pic>
       <p:sp>
         <p:nvSpPr>
-          <p:cNvPr id="828" name="" descr="{&quot;isTemplate&quot;:true,&quot;type&quot;:&quot;text&quot;}"/>
+          <p:cNvPr id="827" name="" descr="{&quot;isTemplate&quot;:true,&quot;type&quot;:&quot;text&quot;}"/>
           <p:cNvSpPr txBox="1"/>
           <p:nvPr/>
         </p:nvSpPr>
@@ -31479,7 +31463,7 @@
       </p:sp>
       <p:sp>
         <p:nvSpPr>
-          <p:cNvPr id="829" name="" descr="{&quot;isTemplate&quot;:true,&quot;type&quot;:&quot;text&quot;}"/>
+          <p:cNvPr id="828" name="" descr="{&quot;isTemplate&quot;:true,&quot;type&quot;:&quot;text&quot;}"/>
           <p:cNvSpPr txBox="1"/>
           <p:nvPr/>
         </p:nvSpPr>
@@ -31514,7 +31498,7 @@
       </p:sp>
       <p:sp>
         <p:nvSpPr>
-          <p:cNvPr id="830" name=""/>
+          <p:cNvPr id="829" name=""/>
           <p:cNvSpPr/>
           <p:nvPr/>
         </p:nvSpPr>
@@ -31545,7 +31529,7 @@
       </p:sp>
       <p:pic>
         <p:nvPicPr>
-          <p:cNvPr id="831" name=""/>
+          <p:cNvPr id="830" name=""/>
           <p:cNvPicPr>
             <a:picLocks noChangeAspect="1"/>
           </p:cNvPicPr>
@@ -31576,7 +31560,7 @@
       </p:pic>
       <p:sp>
         <p:nvSpPr>
-          <p:cNvPr id="832" name="" descr="{&quot;isTemplate&quot;:true,&quot;type&quot;:&quot;text&quot;}"/>
+          <p:cNvPr id="831" name="" descr="{&quot;isTemplate&quot;:true,&quot;type&quot;:&quot;text&quot;}"/>
           <p:cNvSpPr txBox="1"/>
           <p:nvPr/>
         </p:nvSpPr>
@@ -31611,7 +31595,7 @@
       </p:sp>
       <p:sp>
         <p:nvSpPr>
-          <p:cNvPr id="833" name="" descr="{&quot;isTemplate&quot;:true,&quot;type&quot;:&quot;text&quot;}"/>
+          <p:cNvPr id="832" name="" descr="{&quot;isTemplate&quot;:true,&quot;type&quot;:&quot;text&quot;}"/>
           <p:cNvSpPr txBox="1"/>
           <p:nvPr/>
         </p:nvSpPr>
@@ -31646,7 +31630,7 @@
       </p:sp>
       <p:sp>
         <p:nvSpPr>
-          <p:cNvPr id="834" name=""/>
+          <p:cNvPr id="833" name=""/>
           <p:cNvSpPr/>
           <p:nvPr/>
         </p:nvSpPr>
@@ -31677,7 +31661,7 @@
       </p:sp>
       <p:pic>
         <p:nvPicPr>
-          <p:cNvPr id="835" name=""/>
+          <p:cNvPr id="834" name=""/>
           <p:cNvPicPr>
             <a:picLocks noChangeAspect="1"/>
           </p:cNvPicPr>
@@ -31708,7 +31692,7 @@
       </p:pic>
       <p:sp>
         <p:nvSpPr>
-          <p:cNvPr id="836" name="" descr="{&quot;isTemplate&quot;:true,&quot;type&quot;:&quot;text&quot;}"/>
+          <p:cNvPr id="835" name="" descr="{&quot;isTemplate&quot;:true,&quot;type&quot;:&quot;text&quot;}"/>
           <p:cNvSpPr txBox="1"/>
           <p:nvPr/>
         </p:nvSpPr>
@@ -31743,7 +31727,7 @@
       </p:sp>
       <p:sp>
         <p:nvSpPr>
-          <p:cNvPr id="837" name="" descr="{&quot;isTemplate&quot;:true,&quot;type&quot;:&quot;text&quot;}"/>
+          <p:cNvPr id="836" name="" descr="{&quot;isTemplate&quot;:true,&quot;type&quot;:&quot;text&quot;}"/>
           <p:cNvSpPr txBox="1"/>
           <p:nvPr/>
         </p:nvSpPr>
@@ -31778,7 +31762,7 @@
       </p:sp>
       <p:sp>
         <p:nvSpPr>
-          <p:cNvPr id="838" name="" descr="{&quot;isTemplate&quot;:true,&quot;type&quot;:&quot;text&quot;}"/>
+          <p:cNvPr id="837" name="" descr="{&quot;isTemplate&quot;:true,&quot;type&quot;:&quot;text&quot;}"/>
           <p:cNvSpPr txBox="1"/>
           <p:nvPr/>
         </p:nvSpPr>
@@ -31813,7 +31797,7 @@
       </p:sp>
       <p:sp>
         <p:nvSpPr>
-          <p:cNvPr id="839" name="" descr="{&quot;isTemplate&quot;:true,&quot;type&quot;:&quot;text&quot;}"/>
+          <p:cNvPr id="838" name="" descr="{&quot;isTemplate&quot;:true,&quot;type&quot;:&quot;text&quot;}"/>
           <p:cNvSpPr txBox="1"/>
           <p:nvPr/>
         </p:nvSpPr>

</xml_diff>

<commit_message>
Fix unreadable pseudocode blocks: switch CodeBlock theme to one-dark-pro
The default github-light theme renders plaintext pseudocode in near-background
grey (#E5E7EB on #F6F8FA), making every code block in W01-W04 invisible in
PowerPoint. All 20 CodeBlocks now use one-dark-pro (dark panel, light text).
</commit_message>
<xml_diff>
--- a/01-slides/W01-Introduction-Systems-Analysts-and-OOAD.pptx
+++ b/01-slides/W01-Introduction-Systems-Analysts-and-OOAD.pptx
@@ -15383,7 +15383,7 @@
   <p:cSld>
     <p:spTree>
       <p:nvGrpSpPr>
-        <p:cNvPr id="355" name="" descr="&lt;Slide style={{ background: '#FFFFFF', padding: 0 }}&gt;&#10;  &lt;Box style={{ height: 72, background: '#1E4FA8', padding: '0 40px', flexDirection: 'row', alignItems: 'center', justifyContent: 'space-between' }}&gt;&#10;    &lt;Text style={{ fontSize: 15, color: '#B9CDF0', letterSpacing: 1 }}&gt;ISAD · INFORMATION SYSTEMS ANALYSIS &amp;amp; DESIGN&lt;/Text&gt;&#10;    &lt;Text style={{ fontSize: 15, color: '#B9CDF0' }}&gt;W01 · INTRODUCTION&lt;/Text&gt;&#10;  &lt;/Box&gt;&#10;  &lt;Box style={{ padding: '24px 40px 0 40px' }}&gt;&#10;    &lt;Text style={{ fontSize: 34, fontWeight: 'bold', color: '#0E3F8C' }}&gt;Why Patterns Matter — A Teaser&lt;/Text&gt;&#10;  &lt;/Box&gt;&#10;  &lt;Box style={{ flex: 1, padding: '18px 40px 0 40px', flexDirection: 'row', gap: 28 }}&gt;&#10;    &lt;Box style={{ flex: 3, flexDirection: 'column', gap: 14 }}&gt;&#10;      &lt;Box style={{ flex: 1, padding: '18px 20px', background: '#FDF3F3', borderRadius: 12, border: '1px solid #D9534F', flexDirection: 'column' }}&gt;&#10;        &lt;Box style={{ flexDirection: 'row', alignItems: 'center', gap: 10, marginBottom: 10 }}&gt;&#10;          &lt;FAIcon name='times-circle' style={{ fill: '#D9534F', width: 22, height: 22 }} /&gt;&#10;          &lt;Text style={{ fontSize: 17, fontWeight: 'bold', color: '#D9534F' }}&gt;Adding a payment type = editing the if-else chain&lt;/Text&gt;&#10;        &lt;/Box&gt;&#10;        &lt;CodeBlock code={`if type = CARD    -&gt; chargeCard(order)&#10;if type = WECHAT  -&gt; chargeWechat(order)&#10;if type = ALIPAY  -&gt; chargeAlipay(order)&#10;otherwise         -&gt; refuse: no such type`} language='text' width={440} fontSize={13} /&gt;&#10;      &lt;/Box&gt;&#10;    &lt;/Box&gt;&#10;    &lt;Box style={{ flex: 2, padding: '24px 22px', background: '#0E3F8C', borderRadius: 12, flexDirection: 'column', justifyContent: 'center', gap: 14 }}&gt;&#10;      &lt;FAIcon name='check-circle' style={{ fill: '#FFC107', width: 34, height: 34 }} /&gt;&#10;      &lt;Text style={{ fontSize: 21, fontWeight: 'bold', color: '#FFFFFF', lineHeight: 1.35 }}&gt;A pattern turns &quot;many if-else branches&quot; into &quot;one stable line&quot;.&lt;/Text&gt;&#10;      &lt;Text style={{ fontSize: 16, color: '#C5D4EA', lineHeight: 1.55 }}&gt;New payment types plug in without touching existing code. This is what we train all semester — and it is what employers ask about.&lt;/Text&gt;&#10;    &lt;/Box&gt;&#10;  &lt;/Box&gt;&#10;  &lt;Box style={{ height: 40, padding: '0 40px', flexDirection: 'row', alignItems: 'center', justifyContent: 'space-between' }}&gt;&#10;    &lt;Text style={{ fontSize: 13, color: '#8B97A8' }}&gt;Full treatment in Weeks 13–15. Today we only see the destination.&lt;/Text&gt;&#10;    &lt;Text style={{ fontSize: 14, color: '#1E4FA8', fontWeight: 'bold' }}&gt;27 / 38&lt;/Text&gt;&#10;  &lt;/Box&gt;&#10;&lt;/Slide&gt;"/>
+        <p:cNvPr id="355" name="" descr="&lt;Slide style={{ background: '#FFFFFF', padding: 0 }}&gt;&#10;  &lt;Box style={{ height: 72, background: '#1E4FA8', padding: '0 40px', flexDirection: 'row', alignItems: 'center', justifyContent: 'space-between' }}&gt;&#10;    &lt;Text style={{ fontSize: 15, color: '#B9CDF0', letterSpacing: 1 }}&gt;ISAD · INFORMATION SYSTEMS ANALYSIS &amp;amp; DESIGN&lt;/Text&gt;&#10;    &lt;Text style={{ fontSize: 15, color: '#B9CDF0' }}&gt;W01 · INTRODUCTION&lt;/Text&gt;&#10;  &lt;/Box&gt;&#10;  &lt;Box style={{ padding: '24px 40px 0 40px' }}&gt;&#10;    &lt;Text style={{ fontSize: 34, fontWeight: 'bold', color: '#0E3F8C' }}&gt;Why Patterns Matter — A Teaser&lt;/Text&gt;&#10;  &lt;/Box&gt;&#10;  &lt;Box style={{ flex: 1, padding: '18px 40px 0 40px', flexDirection: 'row', gap: 28 }}&gt;&#10;    &lt;Box style={{ flex: 3, flexDirection: 'column', gap: 14 }}&gt;&#10;      &lt;Box style={{ flex: 1, padding: '18px 20px', background: '#FDF3F3', borderRadius: 12, border: '1px solid #D9534F', flexDirection: 'column' }}&gt;&#10;        &lt;Box style={{ flexDirection: 'row', alignItems: 'center', gap: 10, marginBottom: 10 }}&gt;&#10;          &lt;FAIcon name='times-circle' style={{ fill: '#D9534F', width: 22, height: 22 }} /&gt;&#10;          &lt;Text style={{ fontSize: 17, fontWeight: 'bold', color: '#D9534F' }}&gt;Adding a payment type = editing the if-else chain&lt;/Text&gt;&#10;        &lt;/Box&gt;&#10;        &lt;CodeBlock theme='one-dark-pro' code={`if type = CARD    -&gt; chargeCard(order)&#10;if type = WECHAT  -&gt; chargeWechat(order)&#10;if type = ALIPAY  -&gt; chargeAlipay(order)&#10;otherwise         -&gt; refuse: no such type`} language='text' width={440} fontSize={13} /&gt;&#10;      &lt;/Box&gt;&#10;    &lt;/Box&gt;&#10;    &lt;Box style={{ flex: 2, padding: '24px 22px', background: '#0E3F8C', borderRadius: 12, flexDirection: 'column', justifyContent: 'center', gap: 14 }}&gt;&#10;      &lt;FAIcon name='check-circle' style={{ fill: '#FFC107', width: 34, height: 34 }} /&gt;&#10;      &lt;Text style={{ fontSize: 21, fontWeight: 'bold', color: '#FFFFFF', lineHeight: 1.35 }}&gt;A pattern turns &quot;many if-else branches&quot; into &quot;one stable line&quot;.&lt;/Text&gt;&#10;      &lt;Text style={{ fontSize: 16, color: '#C5D4EA', lineHeight: 1.55 }}&gt;New payment types plug in without touching existing code. This is what we train all semester — and it is what employers ask about.&lt;/Text&gt;&#10;    &lt;/Box&gt;&#10;  &lt;/Box&gt;&#10;  &lt;Box style={{ height: 40, padding: '0 40px', flexDirection: 'row', alignItems: 'center', justifyContent: 'space-between' }}&gt;&#10;    &lt;Text style={{ fontSize: 13, color: '#8B97A8' }}&gt;Full treatment in Weeks 13–15. Today we only see the destination.&lt;/Text&gt;&#10;    &lt;Text style={{ fontSize: 14, color: '#1E4FA8', fontWeight: 'bold' }}&gt;27 / 38&lt;/Text&gt;&#10;  &lt;/Box&gt;&#10;&lt;/Slide&gt;"/>
         <p:cNvGrpSpPr/>
         <p:nvPr/>
       </p:nvGrpSpPr>
@@ -15855,15 +15855,15 @@
         <p:spPr>
           <a:xfrm rot="0" flipH="0" flipV="0">
             <a:off x="571500" y="1952625"/>
-            <a:ext cx="6315075" cy="1104900"/>
+            <a:ext cx="6315075" cy="866775"/>
           </a:xfrm>
           <a:prstGeom prst="roundRect">
             <a:avLst>
-              <a:gd name="adj" fmla="val 6897"/>
+              <a:gd name="adj" fmla="val 8791"/>
             </a:avLst>
           </a:prstGeom>
           <a:solidFill>
-            <a:srgbClr val="F6F8FA"/>
+            <a:srgbClr val="0E1116"/>
           </a:solidFill>
           <a:ln/>
         </p:spPr>
@@ -15881,7 +15881,7 @@
         <p:spPr>
           <a:xfrm rot="0" flipH="0" flipV="0">
             <a:off x="723900" y="2085975"/>
-            <a:ext cx="6010275" cy="838200"/>
+            <a:ext cx="6010275" cy="600075"/>
           </a:xfrm>
           <a:prstGeom prst="rect"/>
         </p:spPr>
@@ -15890,11 +15890,7 @@
             <a:normAutofit/>
           </a:bodyPr>
           <a:p>
-            <a:pPr>
-              <a:lnSpc>
-                <a:spcPct val="140000"/>
-              </a:lnSpc>
-            </a:pPr>
+            <a:pPr/>
             <a:r>
               <a:rPr sz="975">
                 <a:solidFill>
@@ -15903,61 +15899,10 @@
                 <a:latin typeface="Menlo"/>
                 <a:ea typeface="Menlo"/>
               </a:rPr>
-              <a:t>if type = CARD    -&gt; chargeCard(order)</a:t>
-            </a:r>
-            <a:endParaRPr/>
-          </a:p>
-          <a:p>
-            <a:pPr>
-              <a:lnSpc>
-                <a:spcPct val="140000"/>
-              </a:lnSpc>
-            </a:pPr>
-            <a:r>
-              <a:rPr sz="975">
-                <a:solidFill>
-                  <a:srgbClr val="E5E7EB"/>
-                </a:solidFill>
-                <a:latin typeface="Menlo"/>
-                <a:ea typeface="Menlo"/>
-              </a:rPr>
-              <a:t>if type = WECHAT  -&gt; chargeWechat(order)</a:t>
-            </a:r>
-            <a:endParaRPr/>
-          </a:p>
-          <a:p>
-            <a:pPr>
-              <a:lnSpc>
-                <a:spcPct val="140000"/>
-              </a:lnSpc>
-            </a:pPr>
-            <a:r>
-              <a:rPr sz="975">
-                <a:solidFill>
-                  <a:srgbClr val="E5E7EB"/>
-                </a:solidFill>
-                <a:latin typeface="Menlo"/>
-                <a:ea typeface="Menlo"/>
-              </a:rPr>
-              <a:t>if type = ALIPAY  -&gt; chargeAlipay(order)</a:t>
-            </a:r>
-            <a:endParaRPr/>
-          </a:p>
-          <a:p>
-            <a:pPr>
-              <a:lnSpc>
-                <a:spcPct val="140000"/>
-              </a:lnSpc>
-            </a:pPr>
-            <a:r>
-              <a:rPr sz="975">
-                <a:solidFill>
-                  <a:srgbClr val="E5E7EB"/>
-                </a:solidFill>
-                <a:latin typeface="Menlo"/>
-                <a:ea typeface="Menlo"/>
-              </a:rPr>
-              <a:t>otherwise         -&gt; refuse: no such type</a:t>
+              <a:t>if type = CARD    -&gt; chargeCard(order)
+if type = WECHAT  -&gt; chargeWechat(order)
+if type = ALIPAY  -&gt; chargeAlipay(order)
+otherwise         -&gt; refuse: no such type</a:t>
             </a:r>
             <a:endParaRPr/>
           </a:p>

</xml_diff>